<commit_message>
Update Figure 2 with revised PowerPoint edits, cropped tight
Co-Authored-By: Claude Opus 4.8 (1M context) <noreply@anthropic.com>
</commit_message>
<xml_diff>
--- a/Figure2_system.pptx
+++ b/Figure2_system.pptx
@@ -5,9 +5,10 @@
     <p:sldMasterId id="2147483648" r:id="rId1"/>
   </p:sldMasterIdLst>
   <p:sldIdLst>
-    <p:sldId id="256" r:id="rId7"/>
+    <p:sldId id="256" r:id="rId2"/>
+    <p:sldId id="257" r:id="rId3"/>
   </p:sldIdLst>
-  <p:sldSz cx="12188952" cy="6035040" type="screen4x3"/>
+  <p:sldSz cx="12188825" cy="6035675"/>
   <p:notesSz cx="6858000" cy="9144000"/>
   <p:defaultTextStyle>
     <a:defPPr>
@@ -104,6 +105,22 @@
       </a:defRPr>
     </a:lvl9pPr>
   </p:defaultTextStyle>
+  <p:extLst>
+    <p:ext uri="{EFAFB233-063F-42B5-8137-9DF3F51BA10A}">
+      <p15:sldGuideLst xmlns:p15="http://schemas.microsoft.com/office/powerpoint/2012/main">
+        <p15:guide id="1" orient="horz" pos="2160">
+          <p15:clr>
+            <a:srgbClr val="A4A3A4"/>
+          </p15:clr>
+        </p15:guide>
+        <p15:guide id="2" pos="2880">
+          <p15:clr>
+            <a:srgbClr val="A4A3A4"/>
+          </p15:clr>
+        </p15:guide>
+      </p15:sldGuideLst>
+    </p:ext>
+  </p:extLst>
 </p:presentation>
 </file>
 
@@ -145,10 +162,9 @@
           <a:lstStyle/>
           <a:p>
             <a:r>
-              <a:rPr lang="en-US" smtClean="0"/>
+              <a:rPr lang="en-US"/>
               <a:t>Click to edit Master title style</a:t>
             </a:r>
-            <a:endParaRPr lang="en-US"/>
           </a:p>
         </p:txBody>
       </p:sp>
@@ -264,10 +280,9 @@
           </a:lstStyle>
           <a:p>
             <a:r>
-              <a:rPr lang="en-US" smtClean="0"/>
+              <a:rPr lang="en-US"/>
               <a:t>Click to edit Master subtitle style</a:t>
             </a:r>
-            <a:endParaRPr lang="en-US"/>
           </a:p>
         </p:txBody>
       </p:sp>
@@ -288,7 +303,7 @@
           <a:p>
             <a:fld id="{5BCAD085-E8A6-8845-BD4E-CB4CCA059FC4}" type="datetimeFigureOut">
               <a:rPr lang="en-US" smtClean="0"/>
-              <a:t>1/27/13</a:t>
+              <a:t>8/26/2026</a:t>
             </a:fld>
             <a:endParaRPr lang="en-US"/>
           </a:p>
@@ -382,10 +397,9 @@
           <a:lstStyle/>
           <a:p>
             <a:r>
-              <a:rPr lang="en-US" smtClean="0"/>
+              <a:rPr lang="en-US"/>
               <a:t>Click to edit Master title style</a:t>
             </a:r>
-            <a:endParaRPr lang="en-US"/>
           </a:p>
         </p:txBody>
       </p:sp>
@@ -406,38 +420,37 @@
           <a:p>
             <a:pPr lvl="0"/>
             <a:r>
-              <a:rPr lang="en-US" smtClean="0"/>
+              <a:rPr lang="en-US"/>
               <a:t>Click to edit Master text styles</a:t>
             </a:r>
           </a:p>
           <a:p>
             <a:pPr lvl="1"/>
             <a:r>
-              <a:rPr lang="en-US" smtClean="0"/>
+              <a:rPr lang="en-US"/>
               <a:t>Second level</a:t>
             </a:r>
           </a:p>
           <a:p>
             <a:pPr lvl="2"/>
             <a:r>
-              <a:rPr lang="en-US" smtClean="0"/>
+              <a:rPr lang="en-US"/>
               <a:t>Third level</a:t>
             </a:r>
           </a:p>
           <a:p>
             <a:pPr lvl="3"/>
             <a:r>
-              <a:rPr lang="en-US" smtClean="0"/>
+              <a:rPr lang="en-US"/>
               <a:t>Fourth level</a:t>
             </a:r>
           </a:p>
           <a:p>
             <a:pPr lvl="4"/>
             <a:r>
-              <a:rPr lang="en-US" smtClean="0"/>
+              <a:rPr lang="en-US"/>
               <a:t>Fifth level</a:t>
             </a:r>
-            <a:endParaRPr lang="en-US"/>
           </a:p>
         </p:txBody>
       </p:sp>
@@ -458,7 +471,7 @@
           <a:p>
             <a:fld id="{5BCAD085-E8A6-8845-BD4E-CB4CCA059FC4}" type="datetimeFigureOut">
               <a:rPr lang="en-US" smtClean="0"/>
-              <a:t>1/27/13</a:t>
+              <a:t>8/26/2026</a:t>
             </a:fld>
             <a:endParaRPr lang="en-US"/>
           </a:p>
@@ -557,10 +570,9 @@
           <a:lstStyle/>
           <a:p>
             <a:r>
-              <a:rPr lang="en-US" smtClean="0"/>
+              <a:rPr lang="en-US"/>
               <a:t>Click to edit Master title style</a:t>
             </a:r>
-            <a:endParaRPr lang="en-US"/>
           </a:p>
         </p:txBody>
       </p:sp>
@@ -586,38 +598,37 @@
           <a:p>
             <a:pPr lvl="0"/>
             <a:r>
-              <a:rPr lang="en-US" smtClean="0"/>
+              <a:rPr lang="en-US"/>
               <a:t>Click to edit Master text styles</a:t>
             </a:r>
           </a:p>
           <a:p>
             <a:pPr lvl="1"/>
             <a:r>
-              <a:rPr lang="en-US" smtClean="0"/>
+              <a:rPr lang="en-US"/>
               <a:t>Second level</a:t>
             </a:r>
           </a:p>
           <a:p>
             <a:pPr lvl="2"/>
             <a:r>
-              <a:rPr lang="en-US" smtClean="0"/>
+              <a:rPr lang="en-US"/>
               <a:t>Third level</a:t>
             </a:r>
           </a:p>
           <a:p>
             <a:pPr lvl="3"/>
             <a:r>
-              <a:rPr lang="en-US" smtClean="0"/>
+              <a:rPr lang="en-US"/>
               <a:t>Fourth level</a:t>
             </a:r>
           </a:p>
           <a:p>
             <a:pPr lvl="4"/>
             <a:r>
-              <a:rPr lang="en-US" smtClean="0"/>
+              <a:rPr lang="en-US"/>
               <a:t>Fifth level</a:t>
             </a:r>
-            <a:endParaRPr lang="en-US"/>
           </a:p>
         </p:txBody>
       </p:sp>
@@ -638,7 +649,7 @@
           <a:p>
             <a:fld id="{5BCAD085-E8A6-8845-BD4E-CB4CCA059FC4}" type="datetimeFigureOut">
               <a:rPr lang="en-US" smtClean="0"/>
-              <a:t>1/27/13</a:t>
+              <a:t>8/26/2026</a:t>
             </a:fld>
             <a:endParaRPr lang="en-US"/>
           </a:p>
@@ -732,10 +743,9 @@
           <a:lstStyle/>
           <a:p>
             <a:r>
-              <a:rPr lang="en-US" smtClean="0"/>
+              <a:rPr lang="en-US"/>
               <a:t>Click to edit Master title style</a:t>
             </a:r>
-            <a:endParaRPr lang="en-US"/>
           </a:p>
         </p:txBody>
       </p:sp>
@@ -756,38 +766,37 @@
           <a:p>
             <a:pPr lvl="0"/>
             <a:r>
-              <a:rPr lang="en-US" smtClean="0"/>
+              <a:rPr lang="en-US"/>
               <a:t>Click to edit Master text styles</a:t>
             </a:r>
           </a:p>
           <a:p>
             <a:pPr lvl="1"/>
             <a:r>
-              <a:rPr lang="en-US" smtClean="0"/>
+              <a:rPr lang="en-US"/>
               <a:t>Second level</a:t>
             </a:r>
           </a:p>
           <a:p>
             <a:pPr lvl="2"/>
             <a:r>
-              <a:rPr lang="en-US" smtClean="0"/>
+              <a:rPr lang="en-US"/>
               <a:t>Third level</a:t>
             </a:r>
           </a:p>
           <a:p>
             <a:pPr lvl="3"/>
             <a:r>
-              <a:rPr lang="en-US" smtClean="0"/>
+              <a:rPr lang="en-US"/>
               <a:t>Fourth level</a:t>
             </a:r>
           </a:p>
           <a:p>
             <a:pPr lvl="4"/>
             <a:r>
-              <a:rPr lang="en-US" smtClean="0"/>
+              <a:rPr lang="en-US"/>
               <a:t>Fifth level</a:t>
             </a:r>
-            <a:endParaRPr lang="en-US"/>
           </a:p>
         </p:txBody>
       </p:sp>
@@ -808,7 +817,7 @@
           <a:p>
             <a:fld id="{5BCAD085-E8A6-8845-BD4E-CB4CCA059FC4}" type="datetimeFigureOut">
               <a:rPr lang="en-US" smtClean="0"/>
-              <a:t>1/27/13</a:t>
+              <a:t>8/26/2026</a:t>
             </a:fld>
             <a:endParaRPr lang="en-US"/>
           </a:p>
@@ -911,10 +920,9 @@
           </a:lstStyle>
           <a:p>
             <a:r>
-              <a:rPr lang="en-US" smtClean="0"/>
+              <a:rPr lang="en-US"/>
               <a:t>Click to edit Master title style</a:t>
             </a:r>
-            <a:endParaRPr lang="en-US"/>
           </a:p>
         </p:txBody>
       </p:sp>
@@ -1031,7 +1039,7 @@
           <a:p>
             <a:pPr lvl="0"/>
             <a:r>
-              <a:rPr lang="en-US" smtClean="0"/>
+              <a:rPr lang="en-US"/>
               <a:t>Click to edit Master text styles</a:t>
             </a:r>
           </a:p>
@@ -1054,7 +1062,7 @@
           <a:p>
             <a:fld id="{5BCAD085-E8A6-8845-BD4E-CB4CCA059FC4}" type="datetimeFigureOut">
               <a:rPr lang="en-US" smtClean="0"/>
-              <a:t>1/27/13</a:t>
+              <a:t>8/26/2026</a:t>
             </a:fld>
             <a:endParaRPr lang="en-US"/>
           </a:p>
@@ -1148,10 +1156,9 @@
           <a:lstStyle/>
           <a:p>
             <a:r>
-              <a:rPr lang="en-US" smtClean="0"/>
+              <a:rPr lang="en-US"/>
               <a:t>Click to edit Master title style</a:t>
             </a:r>
-            <a:endParaRPr lang="en-US"/>
           </a:p>
         </p:txBody>
       </p:sp>
@@ -1205,38 +1212,37 @@
           <a:p>
             <a:pPr lvl="0"/>
             <a:r>
-              <a:rPr lang="en-US" smtClean="0"/>
+              <a:rPr lang="en-US"/>
               <a:t>Click to edit Master text styles</a:t>
             </a:r>
           </a:p>
           <a:p>
             <a:pPr lvl="1"/>
             <a:r>
-              <a:rPr lang="en-US" smtClean="0"/>
+              <a:rPr lang="en-US"/>
               <a:t>Second level</a:t>
             </a:r>
           </a:p>
           <a:p>
             <a:pPr lvl="2"/>
             <a:r>
-              <a:rPr lang="en-US" smtClean="0"/>
+              <a:rPr lang="en-US"/>
               <a:t>Third level</a:t>
             </a:r>
           </a:p>
           <a:p>
             <a:pPr lvl="3"/>
             <a:r>
-              <a:rPr lang="en-US" smtClean="0"/>
+              <a:rPr lang="en-US"/>
               <a:t>Fourth level</a:t>
             </a:r>
           </a:p>
           <a:p>
             <a:pPr lvl="4"/>
             <a:r>
-              <a:rPr lang="en-US" smtClean="0"/>
+              <a:rPr lang="en-US"/>
               <a:t>Fifth level</a:t>
             </a:r>
-            <a:endParaRPr lang="en-US"/>
           </a:p>
         </p:txBody>
       </p:sp>
@@ -1290,38 +1296,37 @@
           <a:p>
             <a:pPr lvl="0"/>
             <a:r>
-              <a:rPr lang="en-US" smtClean="0"/>
+              <a:rPr lang="en-US"/>
               <a:t>Click to edit Master text styles</a:t>
             </a:r>
           </a:p>
           <a:p>
             <a:pPr lvl="1"/>
             <a:r>
-              <a:rPr lang="en-US" smtClean="0"/>
+              <a:rPr lang="en-US"/>
               <a:t>Second level</a:t>
             </a:r>
           </a:p>
           <a:p>
             <a:pPr lvl="2"/>
             <a:r>
-              <a:rPr lang="en-US" smtClean="0"/>
+              <a:rPr lang="en-US"/>
               <a:t>Third level</a:t>
             </a:r>
           </a:p>
           <a:p>
             <a:pPr lvl="3"/>
             <a:r>
-              <a:rPr lang="en-US" smtClean="0"/>
+              <a:rPr lang="en-US"/>
               <a:t>Fourth level</a:t>
             </a:r>
           </a:p>
           <a:p>
             <a:pPr lvl="4"/>
             <a:r>
-              <a:rPr lang="en-US" smtClean="0"/>
+              <a:rPr lang="en-US"/>
               <a:t>Fifth level</a:t>
             </a:r>
-            <a:endParaRPr lang="en-US"/>
           </a:p>
         </p:txBody>
       </p:sp>
@@ -1342,7 +1347,7 @@
           <a:p>
             <a:fld id="{5BCAD085-E8A6-8845-BD4E-CB4CCA059FC4}" type="datetimeFigureOut">
               <a:rPr lang="en-US" smtClean="0"/>
-              <a:t>1/27/13</a:t>
+              <a:t>8/26/2026</a:t>
             </a:fld>
             <a:endParaRPr lang="en-US"/>
           </a:p>
@@ -1440,10 +1445,9 @@
           </a:lstStyle>
           <a:p>
             <a:r>
-              <a:rPr lang="en-US" smtClean="0"/>
+              <a:rPr lang="en-US"/>
               <a:t>Click to edit Master title style</a:t>
             </a:r>
-            <a:endParaRPr lang="en-US"/>
           </a:p>
         </p:txBody>
       </p:sp>
@@ -1506,7 +1510,7 @@
           <a:p>
             <a:pPr lvl="0"/>
             <a:r>
-              <a:rPr lang="en-US" smtClean="0"/>
+              <a:rPr lang="en-US"/>
               <a:t>Click to edit Master text styles</a:t>
             </a:r>
           </a:p>
@@ -1562,38 +1566,37 @@
           <a:p>
             <a:pPr lvl="0"/>
             <a:r>
-              <a:rPr lang="en-US" smtClean="0"/>
+              <a:rPr lang="en-US"/>
               <a:t>Click to edit Master text styles</a:t>
             </a:r>
           </a:p>
           <a:p>
             <a:pPr lvl="1"/>
             <a:r>
-              <a:rPr lang="en-US" smtClean="0"/>
+              <a:rPr lang="en-US"/>
               <a:t>Second level</a:t>
             </a:r>
           </a:p>
           <a:p>
             <a:pPr lvl="2"/>
             <a:r>
-              <a:rPr lang="en-US" smtClean="0"/>
+              <a:rPr lang="en-US"/>
               <a:t>Third level</a:t>
             </a:r>
           </a:p>
           <a:p>
             <a:pPr lvl="3"/>
             <a:r>
-              <a:rPr lang="en-US" smtClean="0"/>
+              <a:rPr lang="en-US"/>
               <a:t>Fourth level</a:t>
             </a:r>
           </a:p>
           <a:p>
             <a:pPr lvl="4"/>
             <a:r>
-              <a:rPr lang="en-US" smtClean="0"/>
+              <a:rPr lang="en-US"/>
               <a:t>Fifth level</a:t>
             </a:r>
-            <a:endParaRPr lang="en-US"/>
           </a:p>
         </p:txBody>
       </p:sp>
@@ -1656,7 +1659,7 @@
           <a:p>
             <a:pPr lvl="0"/>
             <a:r>
-              <a:rPr lang="en-US" smtClean="0"/>
+              <a:rPr lang="en-US"/>
               <a:t>Click to edit Master text styles</a:t>
             </a:r>
           </a:p>
@@ -1712,38 +1715,37 @@
           <a:p>
             <a:pPr lvl="0"/>
             <a:r>
-              <a:rPr lang="en-US" smtClean="0"/>
+              <a:rPr lang="en-US"/>
               <a:t>Click to edit Master text styles</a:t>
             </a:r>
           </a:p>
           <a:p>
             <a:pPr lvl="1"/>
             <a:r>
-              <a:rPr lang="en-US" smtClean="0"/>
+              <a:rPr lang="en-US"/>
               <a:t>Second level</a:t>
             </a:r>
           </a:p>
           <a:p>
             <a:pPr lvl="2"/>
             <a:r>
-              <a:rPr lang="en-US" smtClean="0"/>
+              <a:rPr lang="en-US"/>
               <a:t>Third level</a:t>
             </a:r>
           </a:p>
           <a:p>
             <a:pPr lvl="3"/>
             <a:r>
-              <a:rPr lang="en-US" smtClean="0"/>
+              <a:rPr lang="en-US"/>
               <a:t>Fourth level</a:t>
             </a:r>
           </a:p>
           <a:p>
             <a:pPr lvl="4"/>
             <a:r>
-              <a:rPr lang="en-US" smtClean="0"/>
+              <a:rPr lang="en-US"/>
               <a:t>Fifth level</a:t>
             </a:r>
-            <a:endParaRPr lang="en-US"/>
           </a:p>
         </p:txBody>
       </p:sp>
@@ -1764,7 +1766,7 @@
           <a:p>
             <a:fld id="{5BCAD085-E8A6-8845-BD4E-CB4CCA059FC4}" type="datetimeFigureOut">
               <a:rPr lang="en-US" smtClean="0"/>
-              <a:t>1/27/13</a:t>
+              <a:t>8/26/2026</a:t>
             </a:fld>
             <a:endParaRPr lang="en-US"/>
           </a:p>
@@ -1858,10 +1860,9 @@
           <a:lstStyle/>
           <a:p>
             <a:r>
-              <a:rPr lang="en-US" smtClean="0"/>
+              <a:rPr lang="en-US"/>
               <a:t>Click to edit Master title style</a:t>
             </a:r>
-            <a:endParaRPr lang="en-US"/>
           </a:p>
         </p:txBody>
       </p:sp>
@@ -1882,7 +1883,7 @@
           <a:p>
             <a:fld id="{5BCAD085-E8A6-8845-BD4E-CB4CCA059FC4}" type="datetimeFigureOut">
               <a:rPr lang="en-US" smtClean="0"/>
-              <a:t>1/27/13</a:t>
+              <a:t>8/26/2026</a:t>
             </a:fld>
             <a:endParaRPr lang="en-US"/>
           </a:p>
@@ -1977,7 +1978,7 @@
           <a:p>
             <a:fld id="{5BCAD085-E8A6-8845-BD4E-CB4CCA059FC4}" type="datetimeFigureOut">
               <a:rPr lang="en-US" smtClean="0"/>
-              <a:t>1/27/13</a:t>
+              <a:t>8/26/2026</a:t>
             </a:fld>
             <a:endParaRPr lang="en-US"/>
           </a:p>
@@ -2080,10 +2081,9 @@
           </a:lstStyle>
           <a:p>
             <a:r>
-              <a:rPr lang="en-US" smtClean="0"/>
+              <a:rPr lang="en-US"/>
               <a:t>Click to edit Master title style</a:t>
             </a:r>
-            <a:endParaRPr lang="en-US"/>
           </a:p>
         </p:txBody>
       </p:sp>
@@ -2137,38 +2137,37 @@
           <a:p>
             <a:pPr lvl="0"/>
             <a:r>
-              <a:rPr lang="en-US" smtClean="0"/>
+              <a:rPr lang="en-US"/>
               <a:t>Click to edit Master text styles</a:t>
             </a:r>
           </a:p>
           <a:p>
             <a:pPr lvl="1"/>
             <a:r>
-              <a:rPr lang="en-US" smtClean="0"/>
+              <a:rPr lang="en-US"/>
               <a:t>Second level</a:t>
             </a:r>
           </a:p>
           <a:p>
             <a:pPr lvl="2"/>
             <a:r>
-              <a:rPr lang="en-US" smtClean="0"/>
+              <a:rPr lang="en-US"/>
               <a:t>Third level</a:t>
             </a:r>
           </a:p>
           <a:p>
             <a:pPr lvl="3"/>
             <a:r>
-              <a:rPr lang="en-US" smtClean="0"/>
+              <a:rPr lang="en-US"/>
               <a:t>Fourth level</a:t>
             </a:r>
           </a:p>
           <a:p>
             <a:pPr lvl="4"/>
             <a:r>
-              <a:rPr lang="en-US" smtClean="0"/>
+              <a:rPr lang="en-US"/>
               <a:t>Fifth level</a:t>
             </a:r>
-            <a:endParaRPr lang="en-US"/>
           </a:p>
         </p:txBody>
       </p:sp>
@@ -2231,7 +2230,7 @@
           <a:p>
             <a:pPr lvl="0"/>
             <a:r>
-              <a:rPr lang="en-US" smtClean="0"/>
+              <a:rPr lang="en-US"/>
               <a:t>Click to edit Master text styles</a:t>
             </a:r>
           </a:p>
@@ -2254,7 +2253,7 @@
           <a:p>
             <a:fld id="{5BCAD085-E8A6-8845-BD4E-CB4CCA059FC4}" type="datetimeFigureOut">
               <a:rPr lang="en-US" smtClean="0"/>
-              <a:t>1/27/13</a:t>
+              <a:t>8/26/2026</a:t>
             </a:fld>
             <a:endParaRPr lang="en-US"/>
           </a:p>
@@ -2357,10 +2356,9 @@
           </a:lstStyle>
           <a:p>
             <a:r>
-              <a:rPr lang="en-US" smtClean="0"/>
+              <a:rPr lang="en-US"/>
               <a:t>Click to edit Master title style</a:t>
             </a:r>
-            <a:endParaRPr lang="en-US"/>
           </a:p>
         </p:txBody>
       </p:sp>
@@ -2484,7 +2482,7 @@
           <a:p>
             <a:pPr lvl="0"/>
             <a:r>
-              <a:rPr lang="en-US" smtClean="0"/>
+              <a:rPr lang="en-US"/>
               <a:t>Click to edit Master text styles</a:t>
             </a:r>
           </a:p>
@@ -2507,7 +2505,7 @@
           <a:p>
             <a:fld id="{5BCAD085-E8A6-8845-BD4E-CB4CCA059FC4}" type="datetimeFigureOut">
               <a:rPr lang="en-US" smtClean="0"/>
-              <a:t>1/27/13</a:t>
+              <a:t>8/26/2026</a:t>
             </a:fld>
             <a:endParaRPr lang="en-US"/>
           </a:p>
@@ -2616,10 +2614,9 @@
           <a:lstStyle/>
           <a:p>
             <a:r>
-              <a:rPr lang="en-US" smtClean="0"/>
+              <a:rPr lang="en-US"/>
               <a:t>Click to edit Master title style</a:t>
             </a:r>
-            <a:endParaRPr lang="en-US"/>
           </a:p>
         </p:txBody>
       </p:sp>
@@ -2650,38 +2647,37 @@
           <a:p>
             <a:pPr lvl="0"/>
             <a:r>
-              <a:rPr lang="en-US" smtClean="0"/>
+              <a:rPr lang="en-US"/>
               <a:t>Click to edit Master text styles</a:t>
             </a:r>
           </a:p>
           <a:p>
             <a:pPr lvl="1"/>
             <a:r>
-              <a:rPr lang="en-US" smtClean="0"/>
+              <a:rPr lang="en-US"/>
               <a:t>Second level</a:t>
             </a:r>
           </a:p>
           <a:p>
             <a:pPr lvl="2"/>
             <a:r>
-              <a:rPr lang="en-US" smtClean="0"/>
+              <a:rPr lang="en-US"/>
               <a:t>Third level</a:t>
             </a:r>
           </a:p>
           <a:p>
             <a:pPr lvl="3"/>
             <a:r>
-              <a:rPr lang="en-US" smtClean="0"/>
+              <a:rPr lang="en-US"/>
               <a:t>Fourth level</a:t>
             </a:r>
           </a:p>
           <a:p>
             <a:pPr lvl="4"/>
             <a:r>
-              <a:rPr lang="en-US" smtClean="0"/>
+              <a:rPr lang="en-US"/>
               <a:t>Fifth level</a:t>
             </a:r>
-            <a:endParaRPr lang="en-US"/>
           </a:p>
         </p:txBody>
       </p:sp>
@@ -2720,7 +2716,7 @@
           <a:p>
             <a:fld id="{5BCAD085-E8A6-8845-BD4E-CB4CCA059FC4}" type="datetimeFigureOut">
               <a:rPr lang="en-US" smtClean="0"/>
-              <a:t>1/27/13</a:t>
+              <a:t>8/26/2026</a:t>
             </a:fld>
             <a:endParaRPr lang="en-US"/>
           </a:p>
@@ -3079,7 +3075,7 @@
 </file>
 
 <file path=ppt/slides/slide1.xml><?xml version="1.0" encoding="utf-8"?>
-<p:sld xmlns:a="http://schemas.openxmlformats.org/drawingml/2006/main" xmlns:p="http://schemas.openxmlformats.org/presentationml/2006/main" xmlns:r="http://schemas.openxmlformats.org/officeDocument/2006/relationships">
+<p:sld xmlns:a="http://schemas.openxmlformats.org/drawingml/2006/main" xmlns:r="http://schemas.openxmlformats.org/officeDocument/2006/relationships" xmlns:p="http://schemas.openxmlformats.org/presentationml/2006/main">
   <p:cSld>
     <p:bg>
       <p:bgPr>
@@ -3095,7 +3091,14 @@
         <p:cNvGrpSpPr/>
         <p:nvPr/>
       </p:nvGrpSpPr>
-      <p:grpSpPr/>
+      <p:grpSpPr>
+        <a:xfrm>
+          <a:off x="0" y="0"/>
+          <a:ext cx="0" cy="0"/>
+          <a:chOff x="0" y="0"/>
+          <a:chExt cx="0" cy="0"/>
+        </a:xfrm>
+      </p:grpSpPr>
       <p:sp>
         <p:nvSpPr>
           <p:cNvPr id="2" name="Rectangle 1"/>
@@ -3138,6 +3141,7 @@
           <a:lstStyle/>
           <a:p>
             <a:pPr algn="ctr"/>
+            <a:endParaRPr/>
           </a:p>
         </p:txBody>
       </p:sp>
@@ -3183,6 +3187,7 @@
           <a:lstStyle/>
           <a:p>
             <a:pPr algn="ctr"/>
+            <a:endParaRPr/>
           </a:p>
         </p:txBody>
       </p:sp>
@@ -3228,6 +3233,7 @@
           <a:lstStyle/>
           <a:p>
             <a:pPr algn="ctr"/>
+            <a:endParaRPr/>
           </a:p>
         </p:txBody>
       </p:sp>
@@ -3273,6 +3279,7 @@
           <a:lstStyle/>
           <a:p>
             <a:pPr algn="ctr"/>
+            <a:endParaRPr/>
           </a:p>
         </p:txBody>
       </p:sp>
@@ -3293,14 +3300,14 @@
           <a:noFill/>
         </p:spPr>
         <p:txBody>
-          <a:bodyPr wrap="square" lIns="0" rIns="0" tIns="0" bIns="0" anchor="ctr">
+          <a:bodyPr wrap="square" lIns="0" tIns="0" rIns="0" bIns="0" anchor="ctr">
             <a:spAutoFit/>
           </a:bodyPr>
           <a:lstStyle/>
           <a:p>
             <a:pPr algn="ctr"/>
             <a:r>
-              <a:rPr sz="2000" i="0" b="1">
+              <a:rPr sz="2000" b="1" i="0">
                 <a:solidFill>
                   <a:srgbClr val="555F6B"/>
                 </a:solidFill>
@@ -3364,14 +3371,14 @@
           <a:noFill/>
         </p:spPr>
         <p:txBody>
-          <a:bodyPr wrap="square" lIns="0" rIns="0" tIns="0" bIns="0" anchor="ctr">
+          <a:bodyPr wrap="square" lIns="0" tIns="0" rIns="0" bIns="0" anchor="ctr">
             <a:spAutoFit/>
           </a:bodyPr>
           <a:lstStyle/>
           <a:p>
             <a:pPr algn="ctr"/>
             <a:r>
-              <a:rPr sz="1300" i="0" b="1">
+              <a:rPr sz="1300" b="1" i="0">
                 <a:solidFill>
                   <a:srgbClr val="304055"/>
                 </a:solidFill>
@@ -3422,6 +3429,7 @@
           <a:lstStyle/>
           <a:p>
             <a:pPr algn="ctr"/>
+            <a:endParaRPr/>
           </a:p>
         </p:txBody>
       </p:sp>
@@ -3478,14 +3486,14 @@
           <a:noFill/>
         </p:spPr>
         <p:txBody>
-          <a:bodyPr wrap="square" lIns="0" rIns="0" tIns="0" bIns="0" anchor="ctr">
+          <a:bodyPr wrap="square" lIns="0" tIns="0" rIns="0" bIns="0" anchor="ctr">
             <a:spAutoFit/>
           </a:bodyPr>
           <a:lstStyle/>
           <a:p>
             <a:pPr algn="l"/>
             <a:r>
-              <a:rPr sz="1250" i="1" b="0">
+              <a:rPr sz="1250" b="0" i="1">
                 <a:solidFill>
                   <a:srgbClr val="E8A33D"/>
                 </a:solidFill>
@@ -3573,6 +3581,7 @@
           <a:lstStyle/>
           <a:p>
             <a:pPr algn="ctr"/>
+            <a:endParaRPr/>
           </a:p>
         </p:txBody>
       </p:sp>
@@ -3593,14 +3602,14 @@
           <a:noFill/>
         </p:spPr>
         <p:txBody>
-          <a:bodyPr wrap="square" lIns="0" rIns="0" tIns="0" bIns="0" anchor="ctr">
+          <a:bodyPr wrap="square" lIns="0" tIns="0" rIns="0" bIns="0" anchor="ctr">
             <a:spAutoFit/>
           </a:bodyPr>
           <a:lstStyle/>
           <a:p>
             <a:pPr algn="ctr"/>
             <a:r>
-              <a:rPr sz="1350" i="1" b="0">
+              <a:rPr sz="1350" b="0" i="1">
                 <a:solidFill>
                   <a:srgbClr val="3E8E3E"/>
                 </a:solidFill>
@@ -3679,6 +3688,7 @@
           <a:lstStyle/>
           <a:p>
             <a:pPr algn="ctr"/>
+            <a:endParaRPr/>
           </a:p>
         </p:txBody>
       </p:sp>
@@ -3746,6 +3756,7 @@
           <a:lstStyle/>
           <a:p>
             <a:pPr algn="ctr"/>
+            <a:endParaRPr/>
           </a:p>
         </p:txBody>
       </p:sp>
@@ -3792,6 +3803,7 @@
           <a:lstStyle/>
           <a:p>
             <a:pPr algn="ctr"/>
+            <a:endParaRPr/>
           </a:p>
         </p:txBody>
       </p:sp>
@@ -3835,6 +3847,7 @@
           <a:lstStyle/>
           <a:p>
             <a:pPr algn="ctr"/>
+            <a:endParaRPr/>
           </a:p>
         </p:txBody>
       </p:sp>
@@ -3855,14 +3868,14 @@
           <a:noFill/>
         </p:spPr>
         <p:txBody>
-          <a:bodyPr wrap="square" lIns="0" rIns="0" tIns="0" bIns="0" anchor="ctr">
+          <a:bodyPr wrap="square" lIns="0" tIns="0" rIns="0" bIns="0" anchor="ctr">
             <a:spAutoFit/>
           </a:bodyPr>
           <a:lstStyle/>
           <a:p>
             <a:pPr algn="ctr"/>
             <a:r>
-              <a:rPr sz="1400" i="0" b="1">
+              <a:rPr sz="1400" b="1" i="0">
                 <a:solidFill>
                   <a:srgbClr val="2E6DA4"/>
                 </a:solidFill>
@@ -3913,6 +3926,7 @@
           <a:lstStyle/>
           <a:p>
             <a:pPr algn="ctr"/>
+            <a:endParaRPr/>
           </a:p>
         </p:txBody>
       </p:sp>
@@ -3933,14 +3947,14 @@
           <a:noFill/>
         </p:spPr>
         <p:txBody>
-          <a:bodyPr wrap="square" lIns="0" rIns="0" tIns="0" bIns="0" anchor="ctr">
+          <a:bodyPr wrap="square" lIns="0" tIns="0" rIns="0" bIns="0" anchor="ctr">
             <a:spAutoFit/>
           </a:bodyPr>
           <a:lstStyle/>
           <a:p>
             <a:pPr algn="ctr"/>
             <a:r>
-              <a:rPr sz="1400" i="0" b="1">
+              <a:rPr sz="1400" b="1" i="0">
                 <a:solidFill>
                   <a:srgbClr val="333333"/>
                 </a:solidFill>
@@ -4017,6 +4031,7 @@
           <a:lstStyle/>
           <a:p>
             <a:pPr algn="ctr"/>
+            <a:endParaRPr/>
           </a:p>
         </p:txBody>
       </p:sp>
@@ -4083,6 +4098,7 @@
           <a:lstStyle/>
           <a:p>
             <a:pPr algn="ctr"/>
+            <a:endParaRPr/>
           </a:p>
         </p:txBody>
       </p:sp>
@@ -4152,6 +4168,7 @@
           <a:lstStyle/>
           <a:p>
             <a:pPr algn="ctr"/>
+            <a:endParaRPr/>
           </a:p>
         </p:txBody>
       </p:sp>
@@ -4218,6 +4235,7 @@
           <a:lstStyle/>
           <a:p>
             <a:pPr algn="ctr"/>
+            <a:endParaRPr/>
           </a:p>
         </p:txBody>
       </p:sp>
@@ -4287,6 +4305,7 @@
           <a:lstStyle/>
           <a:p>
             <a:pPr algn="ctr"/>
+            <a:endParaRPr/>
           </a:p>
         </p:txBody>
       </p:sp>
@@ -4353,6 +4372,7 @@
           <a:lstStyle/>
           <a:p>
             <a:pPr algn="ctr"/>
+            <a:endParaRPr/>
           </a:p>
         </p:txBody>
       </p:sp>
@@ -4422,6 +4442,7 @@
           <a:lstStyle/>
           <a:p>
             <a:pPr algn="ctr"/>
+            <a:endParaRPr/>
           </a:p>
         </p:txBody>
       </p:sp>
@@ -4488,6 +4509,7 @@
           <a:lstStyle/>
           <a:p>
             <a:pPr algn="ctr"/>
+            <a:endParaRPr/>
           </a:p>
         </p:txBody>
       </p:sp>
@@ -4531,6 +4553,7 @@
           <a:lstStyle/>
           <a:p>
             <a:pPr algn="ctr"/>
+            <a:endParaRPr/>
           </a:p>
         </p:txBody>
       </p:sp>
@@ -4586,14 +4609,14 @@
           <a:noFill/>
         </p:spPr>
         <p:txBody>
-          <a:bodyPr wrap="square" lIns="0" rIns="0" tIns="0" bIns="0" anchor="ctr">
+          <a:bodyPr wrap="square" lIns="0" tIns="0" rIns="0" bIns="0" anchor="ctr">
             <a:spAutoFit/>
           </a:bodyPr>
           <a:lstStyle/>
           <a:p>
             <a:pPr algn="ctr"/>
             <a:r>
-              <a:rPr sz="1200" i="0" b="1">
+              <a:rPr sz="1200" b="1" i="0">
                 <a:solidFill>
                   <a:srgbClr val="C0392B"/>
                 </a:solidFill>
@@ -4665,6 +4688,7 @@
           <a:lstStyle/>
           <a:p>
             <a:pPr algn="ctr"/>
+            <a:endParaRPr/>
           </a:p>
         </p:txBody>
       </p:sp>
@@ -4729,6 +4753,7 @@
           <a:lstStyle/>
           <a:p>
             <a:pPr algn="ctr"/>
+            <a:endParaRPr/>
           </a:p>
         </p:txBody>
       </p:sp>
@@ -4793,6 +4818,7 @@
           <a:lstStyle/>
           <a:p>
             <a:pPr algn="ctr"/>
+            <a:endParaRPr/>
           </a:p>
         </p:txBody>
       </p:sp>
@@ -4813,14 +4839,14 @@
           <a:noFill/>
         </p:spPr>
         <p:txBody>
-          <a:bodyPr wrap="square" lIns="0" rIns="0" tIns="0" bIns="0" anchor="ctr">
+          <a:bodyPr wrap="square" lIns="0" tIns="0" rIns="0" bIns="0" anchor="ctr">
             <a:spAutoFit/>
           </a:bodyPr>
           <a:lstStyle/>
           <a:p>
             <a:pPr algn="ctr"/>
             <a:r>
-              <a:rPr sz="1200" i="0" b="1">
+              <a:rPr sz="1200" b="1" i="0">
                 <a:solidFill>
                   <a:srgbClr val="2A8AA8"/>
                 </a:solidFill>
@@ -4848,14 +4874,14 @@
           <a:noFill/>
         </p:spPr>
         <p:txBody>
-          <a:bodyPr wrap="square" lIns="0" rIns="0" tIns="0" bIns="0" anchor="ctr">
+          <a:bodyPr wrap="square" lIns="0" tIns="0" rIns="0" bIns="0" anchor="ctr">
             <a:spAutoFit/>
           </a:bodyPr>
           <a:lstStyle/>
           <a:p>
             <a:pPr algn="ctr"/>
             <a:r>
-              <a:rPr sz="1000" i="1" b="0">
+              <a:rPr sz="1000" b="0" i="1">
                 <a:solidFill>
                   <a:srgbClr val="2A8AA8"/>
                 </a:solidFill>
@@ -4907,6 +4933,7 @@
           <a:lstStyle/>
           <a:p>
             <a:pPr algn="ctr"/>
+            <a:endParaRPr/>
           </a:p>
         </p:txBody>
       </p:sp>
@@ -4952,6 +4979,7 @@
           <a:lstStyle/>
           <a:p>
             <a:pPr algn="ctr"/>
+            <a:endParaRPr/>
           </a:p>
         </p:txBody>
       </p:sp>
@@ -5069,6 +5097,7 @@
           <a:lstStyle/>
           <a:p>
             <a:pPr algn="ctr"/>
+            <a:endParaRPr/>
           </a:p>
         </p:txBody>
       </p:sp>
@@ -5089,14 +5118,14 @@
           <a:noFill/>
         </p:spPr>
         <p:txBody>
-          <a:bodyPr wrap="square" lIns="0" rIns="0" tIns="0" bIns="0" anchor="ctr">
+          <a:bodyPr wrap="square" lIns="0" tIns="0" rIns="0" bIns="0" anchor="ctr">
             <a:spAutoFit/>
           </a:bodyPr>
           <a:lstStyle/>
           <a:p>
             <a:pPr algn="ctr"/>
             <a:r>
-              <a:rPr sz="1100" i="0" b="1">
+              <a:rPr sz="1100" b="1" i="0">
                 <a:solidFill>
                   <a:srgbClr val="555F6B"/>
                 </a:solidFill>
@@ -5160,14 +5189,14 @@
           <a:noFill/>
         </p:spPr>
         <p:txBody>
-          <a:bodyPr wrap="square" lIns="0" rIns="0" tIns="0" bIns="0" anchor="ctr">
+          <a:bodyPr wrap="square" lIns="0" tIns="0" rIns="0" bIns="0" anchor="ctr">
             <a:spAutoFit/>
           </a:bodyPr>
           <a:lstStyle/>
           <a:p>
             <a:pPr algn="ctr"/>
             <a:r>
-              <a:rPr sz="1050" i="1" b="0">
+              <a:rPr sz="1050" b="0" i="1">
                 <a:solidFill>
                   <a:srgbClr val="C0392B"/>
                 </a:solidFill>
@@ -5220,6 +5249,7 @@
           <a:lstStyle/>
           <a:p>
             <a:pPr algn="ctr"/>
+            <a:endParaRPr/>
           </a:p>
         </p:txBody>
       </p:sp>
@@ -5265,6 +5295,7 @@
           <a:lstStyle/>
           <a:p>
             <a:pPr algn="ctr"/>
+            <a:endParaRPr/>
           </a:p>
         </p:txBody>
       </p:sp>
@@ -5310,6 +5341,7 @@
           <a:lstStyle/>
           <a:p>
             <a:pPr algn="ctr"/>
+            <a:endParaRPr/>
           </a:p>
         </p:txBody>
       </p:sp>
@@ -5356,6 +5388,7 @@
           <a:lstStyle/>
           <a:p>
             <a:pPr algn="ctr"/>
+            <a:endParaRPr/>
           </a:p>
         </p:txBody>
       </p:sp>
@@ -5425,6 +5458,7 @@
           <a:lstStyle/>
           <a:p>
             <a:pPr algn="ctr"/>
+            <a:endParaRPr/>
           </a:p>
         </p:txBody>
       </p:sp>
@@ -5491,6 +5525,7 @@
           <a:lstStyle/>
           <a:p>
             <a:pPr algn="ctr"/>
+            <a:endParaRPr/>
           </a:p>
         </p:txBody>
       </p:sp>
@@ -5511,14 +5546,14 @@
           <a:noFill/>
         </p:spPr>
         <p:txBody>
-          <a:bodyPr wrap="square" lIns="0" rIns="0" tIns="0" bIns="0" anchor="ctr">
+          <a:bodyPr wrap="square" lIns="0" tIns="0" rIns="0" bIns="0" anchor="ctr">
             <a:spAutoFit/>
           </a:bodyPr>
           <a:lstStyle/>
           <a:p>
             <a:pPr algn="ctr"/>
             <a:r>
-              <a:rPr sz="1100" i="0" b="1">
+              <a:rPr sz="1100" b="1" i="0">
                 <a:solidFill>
                   <a:srgbClr val="C0392B"/>
                 </a:solidFill>
@@ -5581,14 +5616,14 @@
           <a:noFill/>
         </p:spPr>
         <p:txBody>
-          <a:bodyPr wrap="square" lIns="0" rIns="0" tIns="0" bIns="0" anchor="ctr">
+          <a:bodyPr wrap="square" lIns="0" tIns="0" rIns="0" bIns="0" anchor="ctr">
             <a:spAutoFit/>
           </a:bodyPr>
           <a:lstStyle/>
           <a:p>
             <a:pPr algn="ctr"/>
             <a:r>
-              <a:rPr sz="1150" i="0" b="1">
+              <a:rPr sz="1150" b="1" i="0">
                 <a:solidFill>
                   <a:srgbClr val="3E8E3E"/>
                 </a:solidFill>
@@ -5616,14 +5651,14 @@
           <a:noFill/>
         </p:spPr>
         <p:txBody>
-          <a:bodyPr wrap="square" lIns="0" rIns="0" tIns="0" bIns="0" anchor="ctr">
+          <a:bodyPr wrap="square" lIns="0" tIns="0" rIns="0" bIns="0" anchor="ctr">
             <a:spAutoFit/>
           </a:bodyPr>
           <a:lstStyle/>
           <a:p>
             <a:pPr algn="ctr"/>
             <a:r>
-              <a:rPr sz="1050" i="1" b="0">
+              <a:rPr sz="1050" b="0" i="1">
                 <a:solidFill>
                   <a:srgbClr val="666666"/>
                 </a:solidFill>
@@ -5672,7 +5707,7 @@
           </a:fontRef>
         </p:style>
         <p:txBody>
-          <a:bodyPr rtlCol="0" anchor="ctr" wrap="square" lIns="45720" rIns="45720"/>
+          <a:bodyPr wrap="square" lIns="45720" rIns="45720" rtlCol="0" anchor="ctr"/>
           <a:lstStyle/>
           <a:p>
             <a:pPr algn="l"/>
@@ -5773,7 +5808,7 @@
           </a:fontRef>
         </p:style>
         <p:txBody>
-          <a:bodyPr rtlCol="0" anchor="ctr" wrap="square" lIns="45720" rIns="45720"/>
+          <a:bodyPr wrap="square" lIns="45720" rIns="45720" rtlCol="0" anchor="ctr"/>
           <a:lstStyle/>
           <a:p>
             <a:pPr algn="l"/>
@@ -5837,6 +5872,2090 @@
         </p:style>
       </p:cxnSp>
     </p:spTree>
+  </p:cSld>
+  <p:clrMapOvr>
+    <a:masterClrMapping/>
+  </p:clrMapOvr>
+</p:sld>
+</file>
+
+<file path=ppt/slides/slide2.xml><?xml version="1.0" encoding="utf-8"?>
+<p:sld xmlns:a="http://schemas.openxmlformats.org/drawingml/2006/main" xmlns:r="http://schemas.openxmlformats.org/officeDocument/2006/relationships" xmlns:p="http://schemas.openxmlformats.org/presentationml/2006/main">
+  <p:cSld>
+    <p:spTree>
+      <p:nvGrpSpPr>
+        <p:cNvPr id="1" name="">
+          <a:extLst>
+            <a:ext uri="{FF2B5EF4-FFF2-40B4-BE49-F238E27FC236}">
+              <a16:creationId xmlns:a16="http://schemas.microsoft.com/office/drawing/2014/main" id="{0A4E6A28-E52B-B835-9768-FF77F1905746}"/>
+            </a:ext>
+          </a:extLst>
+        </p:cNvPr>
+        <p:cNvGrpSpPr/>
+        <p:nvPr/>
+      </p:nvGrpSpPr>
+      <p:grpSpPr>
+        <a:xfrm>
+          <a:off x="0" y="0"/>
+          <a:ext cx="0" cy="0"/>
+          <a:chOff x="0" y="0"/>
+          <a:chExt cx="0" cy="0"/>
+        </a:xfrm>
+      </p:grpSpPr>
+      <p:sp>
+        <p:nvSpPr>
+          <p:cNvPr id="131" name="자유형: 도형 130">
+            <a:extLst>
+              <a:ext uri="{FF2B5EF4-FFF2-40B4-BE49-F238E27FC236}">
+                <a16:creationId xmlns:a16="http://schemas.microsoft.com/office/drawing/2014/main" id="{D0F675B2-8E45-E963-5A6C-6526A778AB9C}"/>
+              </a:ext>
+            </a:extLst>
+          </p:cNvPr>
+          <p:cNvSpPr/>
+          <p:nvPr/>
+        </p:nvSpPr>
+        <p:spPr>
+          <a:xfrm>
+            <a:off x="4417637" y="1793041"/>
+            <a:ext cx="3587553" cy="1419722"/>
+          </a:xfrm>
+          <a:custGeom>
+            <a:avLst/>
+            <a:gdLst>
+              <a:gd name="csX0" fmla="*/ 2577523 w 3587553"/>
+              <a:gd name="csY0" fmla="*/ 15439 h 1419722"/>
+              <a:gd name="csX1" fmla="*/ 1856163 w 3587553"/>
+              <a:gd name="csY1" fmla="*/ 25599 h 1419722"/>
+              <a:gd name="csX2" fmla="*/ 1038283 w 3587553"/>
+              <a:gd name="csY2" fmla="*/ 40839 h 1419722"/>
+              <a:gd name="csX3" fmla="*/ 393123 w 3587553"/>
+              <a:gd name="csY3" fmla="*/ 132279 h 1419722"/>
+              <a:gd name="csX4" fmla="*/ 83243 w 3587553"/>
+              <a:gd name="csY4" fmla="*/ 401519 h 1419722"/>
+              <a:gd name="csX5" fmla="*/ 7043 w 3587553"/>
+              <a:gd name="csY5" fmla="*/ 848559 h 1419722"/>
+              <a:gd name="csX6" fmla="*/ 220403 w 3587553"/>
+              <a:gd name="csY6" fmla="*/ 1280359 h 1419722"/>
+              <a:gd name="csX7" fmla="*/ 941763 w 3587553"/>
+              <a:gd name="csY7" fmla="*/ 1402279 h 1419722"/>
+              <a:gd name="csX8" fmla="*/ 1612323 w 3587553"/>
+              <a:gd name="csY8" fmla="*/ 950159 h 1419722"/>
+              <a:gd name="csX9" fmla="*/ 2084763 w 3587553"/>
+              <a:gd name="csY9" fmla="*/ 538679 h 1419722"/>
+              <a:gd name="csX10" fmla="*/ 2648643 w 3587553"/>
+              <a:gd name="csY10" fmla="*/ 426919 h 1419722"/>
+              <a:gd name="csX11" fmla="*/ 3380163 w 3587553"/>
+              <a:gd name="csY11" fmla="*/ 431999 h 1419722"/>
+              <a:gd name="csX12" fmla="*/ 3568123 w 3587553"/>
+              <a:gd name="csY12" fmla="*/ 264359 h 1419722"/>
+              <a:gd name="csX13" fmla="*/ 3552883 w 3587553"/>
+              <a:gd name="csY13" fmla="*/ 101799 h 1419722"/>
+              <a:gd name="csX14" fmla="*/ 3314123 w 3587553"/>
+              <a:gd name="csY14" fmla="*/ 5279 h 1419722"/>
+              <a:gd name="csX15" fmla="*/ 2877243 w 3587553"/>
+              <a:gd name="csY15" fmla="*/ 10359 h 1419722"/>
+              <a:gd name="csX16" fmla="*/ 2577523 w 3587553"/>
+              <a:gd name="csY16" fmla="*/ 15439 h 1419722"/>
+            </a:gdLst>
+            <a:ahLst/>
+            <a:cxnLst>
+              <a:cxn ang="0">
+                <a:pos x="csX0" y="csY0"/>
+              </a:cxn>
+              <a:cxn ang="0">
+                <a:pos x="csX1" y="csY1"/>
+              </a:cxn>
+              <a:cxn ang="0">
+                <a:pos x="csX2" y="csY2"/>
+              </a:cxn>
+              <a:cxn ang="0">
+                <a:pos x="csX3" y="csY3"/>
+              </a:cxn>
+              <a:cxn ang="0">
+                <a:pos x="csX4" y="csY4"/>
+              </a:cxn>
+              <a:cxn ang="0">
+                <a:pos x="csX5" y="csY5"/>
+              </a:cxn>
+              <a:cxn ang="0">
+                <a:pos x="csX6" y="csY6"/>
+              </a:cxn>
+              <a:cxn ang="0">
+                <a:pos x="csX7" y="csY7"/>
+              </a:cxn>
+              <a:cxn ang="0">
+                <a:pos x="csX8" y="csY8"/>
+              </a:cxn>
+              <a:cxn ang="0">
+                <a:pos x="csX9" y="csY9"/>
+              </a:cxn>
+              <a:cxn ang="0">
+                <a:pos x="csX10" y="csY10"/>
+              </a:cxn>
+              <a:cxn ang="0">
+                <a:pos x="csX11" y="csY11"/>
+              </a:cxn>
+              <a:cxn ang="0">
+                <a:pos x="csX12" y="csY12"/>
+              </a:cxn>
+              <a:cxn ang="0">
+                <a:pos x="csX13" y="csY13"/>
+              </a:cxn>
+              <a:cxn ang="0">
+                <a:pos x="csX14" y="csY14"/>
+              </a:cxn>
+              <a:cxn ang="0">
+                <a:pos x="csX15" y="csY15"/>
+              </a:cxn>
+              <a:cxn ang="0">
+                <a:pos x="csX16" y="csY16"/>
+              </a:cxn>
+            </a:cxnLst>
+            <a:rect l="l" t="t" r="r" b="b"/>
+            <a:pathLst>
+              <a:path w="3587553" h="1419722">
+                <a:moveTo>
+                  <a:pt x="2577523" y="15439"/>
+                </a:moveTo>
+                <a:lnTo>
+                  <a:pt x="1856163" y="25599"/>
+                </a:lnTo>
+                <a:cubicBezTo>
+                  <a:pt x="1599623" y="29832"/>
+                  <a:pt x="1282123" y="23059"/>
+                  <a:pt x="1038283" y="40839"/>
+                </a:cubicBezTo>
+                <a:cubicBezTo>
+                  <a:pt x="794443" y="58619"/>
+                  <a:pt x="552296" y="72166"/>
+                  <a:pt x="393123" y="132279"/>
+                </a:cubicBezTo>
+                <a:cubicBezTo>
+                  <a:pt x="233950" y="192392"/>
+                  <a:pt x="147590" y="282139"/>
+                  <a:pt x="83243" y="401519"/>
+                </a:cubicBezTo>
+                <a:cubicBezTo>
+                  <a:pt x="18896" y="520899"/>
+                  <a:pt x="-15817" y="702086"/>
+                  <a:pt x="7043" y="848559"/>
+                </a:cubicBezTo>
+                <a:cubicBezTo>
+                  <a:pt x="29903" y="995032"/>
+                  <a:pt x="64616" y="1188072"/>
+                  <a:pt x="220403" y="1280359"/>
+                </a:cubicBezTo>
+                <a:cubicBezTo>
+                  <a:pt x="376190" y="1372646"/>
+                  <a:pt x="709776" y="1457312"/>
+                  <a:pt x="941763" y="1402279"/>
+                </a:cubicBezTo>
+                <a:cubicBezTo>
+                  <a:pt x="1173750" y="1347246"/>
+                  <a:pt x="1421823" y="1094092"/>
+                  <a:pt x="1612323" y="950159"/>
+                </a:cubicBezTo>
+                <a:cubicBezTo>
+                  <a:pt x="1802823" y="806226"/>
+                  <a:pt x="1912043" y="625886"/>
+                  <a:pt x="2084763" y="538679"/>
+                </a:cubicBezTo>
+                <a:cubicBezTo>
+                  <a:pt x="2257483" y="451472"/>
+                  <a:pt x="2432743" y="444699"/>
+                  <a:pt x="2648643" y="426919"/>
+                </a:cubicBezTo>
+                <a:cubicBezTo>
+                  <a:pt x="2864543" y="409139"/>
+                  <a:pt x="3226916" y="459092"/>
+                  <a:pt x="3380163" y="431999"/>
+                </a:cubicBezTo>
+                <a:cubicBezTo>
+                  <a:pt x="3533410" y="404906"/>
+                  <a:pt x="3539336" y="319392"/>
+                  <a:pt x="3568123" y="264359"/>
+                </a:cubicBezTo>
+                <a:cubicBezTo>
+                  <a:pt x="3596910" y="209326"/>
+                  <a:pt x="3595216" y="144979"/>
+                  <a:pt x="3552883" y="101799"/>
+                </a:cubicBezTo>
+                <a:cubicBezTo>
+                  <a:pt x="3510550" y="58619"/>
+                  <a:pt x="3426730" y="20519"/>
+                  <a:pt x="3314123" y="5279"/>
+                </a:cubicBezTo>
+                <a:cubicBezTo>
+                  <a:pt x="3201516" y="-9961"/>
+                  <a:pt x="3002550" y="12899"/>
+                  <a:pt x="2877243" y="10359"/>
+                </a:cubicBezTo>
+                <a:lnTo>
+                  <a:pt x="2577523" y="15439"/>
+                </a:lnTo>
+                <a:close/>
+              </a:path>
+            </a:pathLst>
+          </a:custGeom>
+          <a:solidFill>
+            <a:schemeClr val="accent3">
+              <a:lumMod val="20000"/>
+              <a:lumOff val="80000"/>
+            </a:schemeClr>
+          </a:solidFill>
+          <a:ln w="12700">
+            <a:solidFill>
+              <a:srgbClr val="316525"/>
+            </a:solidFill>
+          </a:ln>
+          <a:effectLst/>
+        </p:spPr>
+        <p:style>
+          <a:lnRef idx="1">
+            <a:schemeClr val="accent1"/>
+          </a:lnRef>
+          <a:fillRef idx="3">
+            <a:schemeClr val="accent1"/>
+          </a:fillRef>
+          <a:effectRef idx="2">
+            <a:schemeClr val="accent1"/>
+          </a:effectRef>
+          <a:fontRef idx="minor">
+            <a:schemeClr val="lt1"/>
+          </a:fontRef>
+        </p:style>
+        <p:txBody>
+          <a:bodyPr rtlCol="0" anchor="ctr"/>
+          <a:lstStyle/>
+          <a:p>
+            <a:pPr algn="ctr"/>
+            <a:endParaRPr lang="ko-KR" altLang="en-US"/>
+          </a:p>
+        </p:txBody>
+      </p:sp>
+      <p:pic>
+        <p:nvPicPr>
+          <p:cNvPr id="70" name="그림 69">
+            <a:extLst>
+              <a:ext uri="{FF2B5EF4-FFF2-40B4-BE49-F238E27FC236}">
+                <a16:creationId xmlns:a16="http://schemas.microsoft.com/office/drawing/2014/main" id="{13FACF93-DC75-6639-648F-474054E7DFC6}"/>
+              </a:ext>
+            </a:extLst>
+          </p:cNvPr>
+          <p:cNvPicPr>
+            <a:picLocks noChangeAspect="1"/>
+          </p:cNvPicPr>
+          <p:nvPr/>
+        </p:nvPicPr>
+        <p:blipFill>
+          <a:blip r:embed="rId2"/>
+          <a:stretch>
+            <a:fillRect/>
+          </a:stretch>
+        </p:blipFill>
+        <p:spPr>
+          <a:xfrm rot="10800000">
+            <a:off x="6624201" y="1331735"/>
+            <a:ext cx="1526475" cy="1374889"/>
+          </a:xfrm>
+          <a:prstGeom prst="rect">
+            <a:avLst/>
+          </a:prstGeom>
+        </p:spPr>
+      </p:pic>
+      <p:cxnSp>
+        <p:nvCxnSpPr>
+          <p:cNvPr id="7" name="Connector 6">
+            <a:extLst>
+              <a:ext uri="{FF2B5EF4-FFF2-40B4-BE49-F238E27FC236}">
+                <a16:creationId xmlns:a16="http://schemas.microsoft.com/office/drawing/2014/main" id="{13FEFD46-0815-C9F4-0D3E-1A3852F63231}"/>
+              </a:ext>
+            </a:extLst>
+          </p:cNvPr>
+          <p:cNvCxnSpPr/>
+          <p:nvPr/>
+        </p:nvCxnSpPr>
+        <p:spPr>
+          <a:xfrm>
+            <a:off x="5212080" y="269240"/>
+            <a:ext cx="2743200" cy="0"/>
+          </a:xfrm>
+          <a:prstGeom prst="line">
+            <a:avLst/>
+          </a:prstGeom>
+          <a:ln w="38100">
+            <a:solidFill>
+              <a:srgbClr val="304055"/>
+            </a:solidFill>
+            <a:tailEnd type="triangle" w="med" len="med"/>
+          </a:ln>
+        </p:spPr>
+        <p:style>
+          <a:lnRef idx="2">
+            <a:schemeClr val="accent1"/>
+          </a:lnRef>
+          <a:fillRef idx="0">
+            <a:schemeClr val="accent1"/>
+          </a:fillRef>
+          <a:effectRef idx="1">
+            <a:schemeClr val="accent1"/>
+          </a:effectRef>
+          <a:fontRef idx="minor">
+            <a:schemeClr val="tx1"/>
+          </a:fontRef>
+        </p:style>
+      </p:cxnSp>
+      <p:sp>
+        <p:nvSpPr>
+          <p:cNvPr id="8" name="TextBox 7">
+            <a:extLst>
+              <a:ext uri="{FF2B5EF4-FFF2-40B4-BE49-F238E27FC236}">
+                <a16:creationId xmlns:a16="http://schemas.microsoft.com/office/drawing/2014/main" id="{4AA435FE-8618-A334-8C16-2369EDB72E31}"/>
+              </a:ext>
+            </a:extLst>
+          </p:cNvPr>
+          <p:cNvSpPr txBox="1"/>
+          <p:nvPr/>
+        </p:nvSpPr>
+        <p:spPr>
+          <a:xfrm>
+            <a:off x="4663440" y="-114808"/>
+            <a:ext cx="3840480" cy="457200"/>
+          </a:xfrm>
+          <a:prstGeom prst="rect">
+            <a:avLst/>
+          </a:prstGeom>
+          <a:noFill/>
+        </p:spPr>
+        <p:txBody>
+          <a:bodyPr wrap="square" lIns="0" tIns="0" rIns="0" bIns="0" anchor="ctr">
+            <a:spAutoFit/>
+          </a:bodyPr>
+          <a:lstStyle/>
+          <a:p>
+            <a:pPr algn="ctr"/>
+            <a:r>
+              <a:rPr sz="1300" b="1" i="0">
+                <a:solidFill>
+                  <a:srgbClr val="304055"/>
+                </a:solidFill>
+                <a:latin typeface="Arial"/>
+              </a:rPr>
+              <a:t>Vₛ   (mothership advances)</a:t>
+            </a:r>
+          </a:p>
+        </p:txBody>
+      </p:sp>
+      <p:sp>
+        <p:nvSpPr>
+          <p:cNvPr id="9" name="Rectangle 8">
+            <a:extLst>
+              <a:ext uri="{FF2B5EF4-FFF2-40B4-BE49-F238E27FC236}">
+                <a16:creationId xmlns:a16="http://schemas.microsoft.com/office/drawing/2014/main" id="{E6BB39B8-992D-A1D7-83F1-2D5DF624FE2E}"/>
+              </a:ext>
+            </a:extLst>
+          </p:cNvPr>
+          <p:cNvSpPr/>
+          <p:nvPr/>
+        </p:nvSpPr>
+        <p:spPr>
+          <a:xfrm>
+            <a:off x="1559560" y="1609344"/>
+            <a:ext cx="10629392" cy="91440"/>
+          </a:xfrm>
+          <a:prstGeom prst="rect">
+            <a:avLst/>
+          </a:prstGeom>
+          <a:solidFill>
+            <a:srgbClr val="FBE9DA"/>
+          </a:solidFill>
+          <a:ln>
+            <a:noFill/>
+          </a:ln>
+        </p:spPr>
+        <p:style>
+          <a:lnRef idx="1">
+            <a:schemeClr val="accent1"/>
+          </a:lnRef>
+          <a:fillRef idx="3">
+            <a:schemeClr val="accent1"/>
+          </a:fillRef>
+          <a:effectRef idx="2">
+            <a:schemeClr val="accent1"/>
+          </a:effectRef>
+          <a:fontRef idx="minor">
+            <a:schemeClr val="lt1"/>
+          </a:fontRef>
+        </p:style>
+        <p:txBody>
+          <a:bodyPr rtlCol="0" anchor="ctr"/>
+          <a:lstStyle/>
+          <a:p>
+            <a:pPr algn="ctr"/>
+            <a:endParaRPr/>
+          </a:p>
+        </p:txBody>
+      </p:sp>
+      <p:cxnSp>
+        <p:nvCxnSpPr>
+          <p:cNvPr id="10" name="Connector 9">
+            <a:extLst>
+              <a:ext uri="{FF2B5EF4-FFF2-40B4-BE49-F238E27FC236}">
+                <a16:creationId xmlns:a16="http://schemas.microsoft.com/office/drawing/2014/main" id="{7F11AEEF-9A02-EC64-71D1-FF4A6FD0F7B8}"/>
+              </a:ext>
+            </a:extLst>
+          </p:cNvPr>
+          <p:cNvCxnSpPr>
+            <a:cxnSpLocks/>
+          </p:cNvCxnSpPr>
+          <p:nvPr/>
+        </p:nvCxnSpPr>
+        <p:spPr>
+          <a:xfrm>
+            <a:off x="1559560" y="1700784"/>
+            <a:ext cx="10629392" cy="0"/>
+          </a:xfrm>
+          <a:prstGeom prst="line">
+            <a:avLst/>
+          </a:prstGeom>
+          <a:ln w="33020">
+            <a:solidFill>
+              <a:srgbClr val="E8A33D"/>
+            </a:solidFill>
+            <a:prstDash val="dash"/>
+          </a:ln>
+        </p:spPr>
+        <p:style>
+          <a:lnRef idx="2">
+            <a:schemeClr val="accent1"/>
+          </a:lnRef>
+          <a:fillRef idx="0">
+            <a:schemeClr val="accent1"/>
+          </a:fillRef>
+          <a:effectRef idx="1">
+            <a:schemeClr val="accent1"/>
+          </a:effectRef>
+          <a:fontRef idx="minor">
+            <a:schemeClr val="tx1"/>
+          </a:fontRef>
+        </p:style>
+      </p:cxnSp>
+      <p:sp>
+        <p:nvSpPr>
+          <p:cNvPr id="13" name="TextBox 12">
+            <a:extLst>
+              <a:ext uri="{FF2B5EF4-FFF2-40B4-BE49-F238E27FC236}">
+                <a16:creationId xmlns:a16="http://schemas.microsoft.com/office/drawing/2014/main" id="{B3373DAF-BEA1-4EB3-7F0E-FE2CF2EB5749}"/>
+              </a:ext>
+            </a:extLst>
+          </p:cNvPr>
+          <p:cNvSpPr txBox="1"/>
+          <p:nvPr/>
+        </p:nvSpPr>
+        <p:spPr>
+          <a:xfrm>
+            <a:off x="3869053" y="3236765"/>
+            <a:ext cx="3291840" cy="161583"/>
+          </a:xfrm>
+          <a:prstGeom prst="rect">
+            <a:avLst/>
+          </a:prstGeom>
+          <a:noFill/>
+        </p:spPr>
+        <p:txBody>
+          <a:bodyPr wrap="square" lIns="0" tIns="0" rIns="0" bIns="0" anchor="ctr">
+            <a:spAutoFit/>
+          </a:bodyPr>
+          <a:lstStyle/>
+          <a:p>
+            <a:pPr algn="ctr"/>
+            <a:r>
+              <a:rPr sz="1050" b="1" i="1">
+                <a:solidFill>
+                  <a:srgbClr val="3E8E3E"/>
+                </a:solidFill>
+                <a:latin typeface="Arial"/>
+              </a:rPr>
+              <a:t>reach avoid set  (V(s) ≤ 0)</a:t>
+            </a:r>
+          </a:p>
+        </p:txBody>
+      </p:sp>
+      <p:sp>
+        <p:nvSpPr>
+          <p:cNvPr id="14" name="Freeform 13">
+            <a:extLst>
+              <a:ext uri="{FF2B5EF4-FFF2-40B4-BE49-F238E27FC236}">
+                <a16:creationId xmlns:a16="http://schemas.microsoft.com/office/drawing/2014/main" id="{B8E3F948-9B4E-B0E7-EDF5-08701C06A17F}"/>
+              </a:ext>
+            </a:extLst>
+          </p:cNvPr>
+          <p:cNvSpPr/>
+          <p:nvPr/>
+        </p:nvSpPr>
+        <p:spPr>
+          <a:xfrm>
+            <a:off x="1920239" y="2263141"/>
+            <a:ext cx="3129281" cy="1623693"/>
+          </a:xfrm>
+          <a:custGeom>
+            <a:avLst/>
+            <a:gdLst/>
+            <a:ahLst/>
+            <a:cxnLst/>
+            <a:rect l="l" t="t" r="r" b="b"/>
+            <a:pathLst>
+              <a:path w="4526280" h="932688">
+                <a:moveTo>
+                  <a:pt x="0" y="932688"/>
+                </a:moveTo>
+                <a:lnTo>
+                  <a:pt x="960120" y="658368"/>
+                </a:lnTo>
+                <a:lnTo>
+                  <a:pt x="2057400" y="365760"/>
+                </a:lnTo>
+                <a:lnTo>
+                  <a:pt x="3063240" y="146304"/>
+                </a:lnTo>
+                <a:lnTo>
+                  <a:pt x="4160520" y="18288"/>
+                </a:lnTo>
+                <a:lnTo>
+                  <a:pt x="4526280" y="0"/>
+                </a:lnTo>
+              </a:path>
+            </a:pathLst>
+          </a:custGeom>
+          <a:noFill/>
+          <a:ln w="38100">
+            <a:solidFill>
+              <a:srgbClr val="2E6DA4"/>
+            </a:solidFill>
+            <a:prstDash val="dash"/>
+            <a:tailEnd type="triangle" w="med" len="med"/>
+          </a:ln>
+        </p:spPr>
+        <p:style>
+          <a:lnRef idx="1">
+            <a:schemeClr val="accent1"/>
+          </a:lnRef>
+          <a:fillRef idx="3">
+            <a:schemeClr val="accent1"/>
+          </a:fillRef>
+          <a:effectRef idx="2">
+            <a:schemeClr val="accent1"/>
+          </a:effectRef>
+          <a:fontRef idx="minor">
+            <a:schemeClr val="lt1"/>
+          </a:fontRef>
+        </p:style>
+        <p:txBody>
+          <a:bodyPr rtlCol="0" anchor="ctr"/>
+          <a:lstStyle/>
+          <a:p>
+            <a:pPr algn="ctr"/>
+            <a:endParaRPr/>
+          </a:p>
+        </p:txBody>
+      </p:sp>
+      <p:sp>
+        <p:nvSpPr>
+          <p:cNvPr id="15" name="Freeform 14">
+            <a:extLst>
+              <a:ext uri="{FF2B5EF4-FFF2-40B4-BE49-F238E27FC236}">
+                <a16:creationId xmlns:a16="http://schemas.microsoft.com/office/drawing/2014/main" id="{CDE39922-CCB5-D878-E98F-396D9B746BA5}"/>
+              </a:ext>
+            </a:extLst>
+          </p:cNvPr>
+          <p:cNvSpPr/>
+          <p:nvPr/>
+        </p:nvSpPr>
+        <p:spPr>
+          <a:xfrm>
+            <a:off x="5454904" y="2025643"/>
+            <a:ext cx="1992376" cy="168916"/>
+          </a:xfrm>
+          <a:custGeom>
+            <a:avLst/>
+            <a:gdLst/>
+            <a:ahLst/>
+            <a:cxnLst/>
+            <a:rect l="l" t="t" r="r" b="b"/>
+            <a:pathLst>
+              <a:path w="4297680" h="182880">
+                <a:moveTo>
+                  <a:pt x="0" y="182880"/>
+                </a:moveTo>
+                <a:lnTo>
+                  <a:pt x="1234440" y="109728"/>
+                </a:lnTo>
+                <a:lnTo>
+                  <a:pt x="2423160" y="54864"/>
+                </a:lnTo>
+                <a:lnTo>
+                  <a:pt x="3611880" y="18288"/>
+                </a:lnTo>
+                <a:lnTo>
+                  <a:pt x="4297680" y="0"/>
+                </a:lnTo>
+              </a:path>
+            </a:pathLst>
+          </a:custGeom>
+          <a:noFill/>
+          <a:ln w="38100">
+            <a:solidFill>
+              <a:srgbClr val="C0392B"/>
+            </a:solidFill>
+            <a:prstDash val="dash"/>
+          </a:ln>
+        </p:spPr>
+        <p:style>
+          <a:lnRef idx="1">
+            <a:schemeClr val="accent1"/>
+          </a:lnRef>
+          <a:fillRef idx="3">
+            <a:schemeClr val="accent1"/>
+          </a:fillRef>
+          <a:effectRef idx="2">
+            <a:schemeClr val="accent1"/>
+          </a:effectRef>
+          <a:fontRef idx="minor">
+            <a:schemeClr val="lt1"/>
+          </a:fontRef>
+        </p:style>
+        <p:txBody>
+          <a:bodyPr rtlCol="0" anchor="ctr"/>
+          <a:lstStyle/>
+          <a:p>
+            <a:pPr algn="ctr"/>
+            <a:endParaRPr/>
+          </a:p>
+        </p:txBody>
+      </p:sp>
+      <p:grpSp>
+        <p:nvGrpSpPr>
+          <p:cNvPr id="68" name="그룹 67">
+            <a:extLst>
+              <a:ext uri="{FF2B5EF4-FFF2-40B4-BE49-F238E27FC236}">
+                <a16:creationId xmlns:a16="http://schemas.microsoft.com/office/drawing/2014/main" id="{60728377-5E44-0468-523B-1F77CF50FC76}"/>
+              </a:ext>
+            </a:extLst>
+          </p:cNvPr>
+          <p:cNvGrpSpPr/>
+          <p:nvPr/>
+        </p:nvGrpSpPr>
+        <p:grpSpPr>
+          <a:xfrm>
+            <a:off x="5171156" y="2135124"/>
+            <a:ext cx="201168" cy="201168"/>
+            <a:chOff x="5248656" y="2715768"/>
+            <a:chExt cx="201168" cy="201168"/>
+          </a:xfrm>
+        </p:grpSpPr>
+        <p:sp>
+          <p:nvSpPr>
+            <p:cNvPr id="16" name="Oval 15">
+              <a:extLst>
+                <a:ext uri="{FF2B5EF4-FFF2-40B4-BE49-F238E27FC236}">
+                  <a16:creationId xmlns:a16="http://schemas.microsoft.com/office/drawing/2014/main" id="{53E86195-FD30-6CCE-1514-416AD0ED3218}"/>
+                </a:ext>
+              </a:extLst>
+            </p:cNvPr>
+            <p:cNvSpPr/>
+            <p:nvPr/>
+          </p:nvSpPr>
+          <p:spPr>
+            <a:xfrm>
+              <a:off x="5248656" y="2715768"/>
+              <a:ext cx="201168" cy="201168"/>
+            </a:xfrm>
+            <a:prstGeom prst="ellipse">
+              <a:avLst/>
+            </a:prstGeom>
+            <a:solidFill>
+              <a:srgbClr val="FFFFFF"/>
+            </a:solidFill>
+            <a:ln w="17780">
+              <a:solidFill>
+                <a:srgbClr val="333333"/>
+              </a:solidFill>
+              <a:prstDash val="dash"/>
+            </a:ln>
+          </p:spPr>
+          <p:style>
+            <a:lnRef idx="1">
+              <a:schemeClr val="accent1"/>
+            </a:lnRef>
+            <a:fillRef idx="3">
+              <a:schemeClr val="accent1"/>
+            </a:fillRef>
+            <a:effectRef idx="2">
+              <a:schemeClr val="accent1"/>
+            </a:effectRef>
+            <a:fontRef idx="minor">
+              <a:schemeClr val="lt1"/>
+            </a:fontRef>
+          </p:style>
+          <p:txBody>
+            <a:bodyPr rtlCol="0" anchor="ctr"/>
+            <a:lstStyle/>
+            <a:p>
+              <a:pPr algn="ctr"/>
+              <a:endParaRPr/>
+            </a:p>
+          </p:txBody>
+        </p:sp>
+        <p:sp>
+          <p:nvSpPr>
+            <p:cNvPr id="17" name="Oval 16">
+              <a:extLst>
+                <a:ext uri="{FF2B5EF4-FFF2-40B4-BE49-F238E27FC236}">
+                  <a16:creationId xmlns:a16="http://schemas.microsoft.com/office/drawing/2014/main" id="{250536D7-CEC7-DB8D-98C4-B1C750B52A9C}"/>
+                </a:ext>
+              </a:extLst>
+            </p:cNvPr>
+            <p:cNvSpPr/>
+            <p:nvPr/>
+          </p:nvSpPr>
+          <p:spPr>
+            <a:xfrm>
+              <a:off x="5321808" y="2788920"/>
+              <a:ext cx="54864" cy="54864"/>
+            </a:xfrm>
+            <a:prstGeom prst="ellipse">
+              <a:avLst/>
+            </a:prstGeom>
+            <a:solidFill>
+              <a:srgbClr val="333333"/>
+            </a:solidFill>
+            <a:ln>
+              <a:noFill/>
+            </a:ln>
+          </p:spPr>
+          <p:style>
+            <a:lnRef idx="1">
+              <a:schemeClr val="accent1"/>
+            </a:lnRef>
+            <a:fillRef idx="3">
+              <a:schemeClr val="accent1"/>
+            </a:fillRef>
+            <a:effectRef idx="2">
+              <a:schemeClr val="accent1"/>
+            </a:effectRef>
+            <a:fontRef idx="minor">
+              <a:schemeClr val="lt1"/>
+            </a:fontRef>
+          </p:style>
+          <p:txBody>
+            <a:bodyPr rtlCol="0" anchor="ctr"/>
+            <a:lstStyle/>
+            <a:p>
+              <a:pPr algn="ctr"/>
+              <a:endParaRPr/>
+            </a:p>
+          </p:txBody>
+        </p:sp>
+      </p:grpSp>
+      <p:sp>
+        <p:nvSpPr>
+          <p:cNvPr id="18" name="TextBox 17">
+            <a:extLst>
+              <a:ext uri="{FF2B5EF4-FFF2-40B4-BE49-F238E27FC236}">
+                <a16:creationId xmlns:a16="http://schemas.microsoft.com/office/drawing/2014/main" id="{768AE48A-56F4-CDFC-A775-B2385DC65CDA}"/>
+              </a:ext>
+            </a:extLst>
+          </p:cNvPr>
+          <p:cNvSpPr txBox="1"/>
+          <p:nvPr/>
+        </p:nvSpPr>
+        <p:spPr>
+          <a:xfrm>
+            <a:off x="4448780" y="2272285"/>
+            <a:ext cx="1645920" cy="457200"/>
+          </a:xfrm>
+          <a:prstGeom prst="rect">
+            <a:avLst/>
+          </a:prstGeom>
+          <a:noFill/>
+        </p:spPr>
+        <p:txBody>
+          <a:bodyPr wrap="square" lIns="0" tIns="0" rIns="0" bIns="0" anchor="ctr">
+            <a:spAutoFit/>
+          </a:bodyPr>
+          <a:lstStyle/>
+          <a:p>
+            <a:pPr algn="ctr"/>
+            <a:r>
+              <a:rPr sz="1400" b="1" i="0" dirty="0">
+                <a:solidFill>
+                  <a:srgbClr val="2E6DA4"/>
+                </a:solidFill>
+                <a:latin typeface="Arial"/>
+              </a:rPr>
+              <a:t>DP point</a:t>
+            </a:r>
+          </a:p>
+        </p:txBody>
+      </p:sp>
+      <p:sp>
+        <p:nvSpPr>
+          <p:cNvPr id="20" name="TextBox 19">
+            <a:extLst>
+              <a:ext uri="{FF2B5EF4-FFF2-40B4-BE49-F238E27FC236}">
+                <a16:creationId xmlns:a16="http://schemas.microsoft.com/office/drawing/2014/main" id="{E8D61342-A978-517E-33B3-BBB75958B547}"/>
+              </a:ext>
+            </a:extLst>
+          </p:cNvPr>
+          <p:cNvSpPr txBox="1"/>
+          <p:nvPr/>
+        </p:nvSpPr>
+        <p:spPr>
+          <a:xfrm>
+            <a:off x="9948672" y="1737360"/>
+            <a:ext cx="1463040" cy="457200"/>
+          </a:xfrm>
+          <a:prstGeom prst="rect">
+            <a:avLst/>
+          </a:prstGeom>
+          <a:noFill/>
+        </p:spPr>
+        <p:txBody>
+          <a:bodyPr wrap="square" lIns="0" tIns="0" rIns="0" bIns="0" anchor="ctr">
+            <a:spAutoFit/>
+          </a:bodyPr>
+          <a:lstStyle/>
+          <a:p>
+            <a:pPr algn="ctr"/>
+            <a:r>
+              <a:rPr sz="1400" b="1" i="0">
+                <a:solidFill>
+                  <a:srgbClr val="333333"/>
+                </a:solidFill>
+                <a:latin typeface="Arial"/>
+              </a:rPr>
+              <a:t>Cradle</a:t>
+            </a:r>
+          </a:p>
+        </p:txBody>
+      </p:sp>
+      <p:sp>
+        <p:nvSpPr>
+          <p:cNvPr id="55" name="Rounded Rectangle 54">
+            <a:extLst>
+              <a:ext uri="{FF2B5EF4-FFF2-40B4-BE49-F238E27FC236}">
+                <a16:creationId xmlns:a16="http://schemas.microsoft.com/office/drawing/2014/main" id="{D9E1E059-E28D-B350-AA21-08D97FA463EC}"/>
+              </a:ext>
+            </a:extLst>
+          </p:cNvPr>
+          <p:cNvSpPr/>
+          <p:nvPr/>
+        </p:nvSpPr>
+        <p:spPr>
+          <a:xfrm>
+            <a:off x="2638169" y="4180136"/>
+            <a:ext cx="2646680" cy="658368"/>
+          </a:xfrm>
+          <a:prstGeom prst="roundRect">
+            <a:avLst/>
+          </a:prstGeom>
+          <a:solidFill>
+            <a:srgbClr val="FFFFFF"/>
+          </a:solidFill>
+          <a:ln w="20320">
+            <a:solidFill>
+              <a:srgbClr val="2E6DA4"/>
+            </a:solidFill>
+          </a:ln>
+        </p:spPr>
+        <p:style>
+          <a:lnRef idx="1">
+            <a:schemeClr val="accent1"/>
+          </a:lnRef>
+          <a:fillRef idx="3">
+            <a:schemeClr val="accent1"/>
+          </a:fillRef>
+          <a:effectRef idx="2">
+            <a:schemeClr val="accent1"/>
+          </a:effectRef>
+          <a:fontRef idx="minor">
+            <a:schemeClr val="lt1"/>
+          </a:fontRef>
+        </p:style>
+        <p:txBody>
+          <a:bodyPr wrap="square" lIns="45720" rIns="45720" rtlCol="0" anchor="ctr"/>
+          <a:lstStyle/>
+          <a:p>
+            <a:pPr algn="l"/>
+            <a:r>
+              <a:rPr sz="1350" b="1">
+                <a:solidFill>
+                  <a:srgbClr val="2E6DA4"/>
+                </a:solidFill>
+                <a:latin typeface="Arial"/>
+              </a:rPr>
+              <a:t>Phase 1 · Approach / DP</a:t>
+            </a:r>
+          </a:p>
+          <a:p>
+            <a:pPr algn="l"/>
+            <a:r>
+              <a:rPr sz="1100">
+                <a:solidFill>
+                  <a:srgbClr val="333333"/>
+                </a:solidFill>
+                <a:latin typeface="Arial"/>
+              </a:rPr>
+              <a:t>Method : DOB-MPC w RaCBF</a:t>
+            </a:r>
+          </a:p>
+        </p:txBody>
+      </p:sp>
+      <p:cxnSp>
+        <p:nvCxnSpPr>
+          <p:cNvPr id="56" name="Connector 55">
+            <a:extLst>
+              <a:ext uri="{FF2B5EF4-FFF2-40B4-BE49-F238E27FC236}">
+                <a16:creationId xmlns:a16="http://schemas.microsoft.com/office/drawing/2014/main" id="{54173DD8-5377-CE1C-9721-7A58896FF512}"/>
+              </a:ext>
+            </a:extLst>
+          </p:cNvPr>
+          <p:cNvCxnSpPr>
+            <a:cxnSpLocks/>
+            <a:stCxn id="55" idx="0"/>
+          </p:cNvCxnSpPr>
+          <p:nvPr/>
+        </p:nvCxnSpPr>
+        <p:spPr>
+          <a:xfrm flipV="1">
+            <a:off x="3961509" y="2798762"/>
+            <a:ext cx="53894" cy="1381374"/>
+          </a:xfrm>
+          <a:prstGeom prst="line">
+            <a:avLst/>
+          </a:prstGeom>
+          <a:ln w="12700">
+            <a:solidFill>
+              <a:srgbClr val="2E6DA4"/>
+            </a:solidFill>
+          </a:ln>
+        </p:spPr>
+        <p:style>
+          <a:lnRef idx="2">
+            <a:schemeClr val="accent1"/>
+          </a:lnRef>
+          <a:fillRef idx="0">
+            <a:schemeClr val="accent1"/>
+          </a:fillRef>
+          <a:effectRef idx="1">
+            <a:schemeClr val="accent1"/>
+          </a:effectRef>
+          <a:fontRef idx="minor">
+            <a:schemeClr val="tx1"/>
+          </a:fontRef>
+        </p:style>
+      </p:cxnSp>
+      <p:sp>
+        <p:nvSpPr>
+          <p:cNvPr id="57" name="Rounded Rectangle 56">
+            <a:extLst>
+              <a:ext uri="{FF2B5EF4-FFF2-40B4-BE49-F238E27FC236}">
+                <a16:creationId xmlns:a16="http://schemas.microsoft.com/office/drawing/2014/main" id="{AF4B4A3A-D2E5-23BB-30B6-D08550498433}"/>
+              </a:ext>
+            </a:extLst>
+          </p:cNvPr>
+          <p:cNvSpPr/>
+          <p:nvPr/>
+        </p:nvSpPr>
+        <p:spPr>
+          <a:xfrm>
+            <a:off x="6206520" y="4166098"/>
+            <a:ext cx="2646680" cy="658368"/>
+          </a:xfrm>
+          <a:prstGeom prst="roundRect">
+            <a:avLst/>
+          </a:prstGeom>
+          <a:solidFill>
+            <a:srgbClr val="FFFFFF"/>
+          </a:solidFill>
+          <a:ln w="20320">
+            <a:solidFill>
+              <a:srgbClr val="C0392B"/>
+            </a:solidFill>
+          </a:ln>
+        </p:spPr>
+        <p:style>
+          <a:lnRef idx="1">
+            <a:schemeClr val="accent1"/>
+          </a:lnRef>
+          <a:fillRef idx="3">
+            <a:schemeClr val="accent1"/>
+          </a:fillRef>
+          <a:effectRef idx="2">
+            <a:schemeClr val="accent1"/>
+          </a:effectRef>
+          <a:fontRef idx="minor">
+            <a:schemeClr val="lt1"/>
+          </a:fontRef>
+        </p:style>
+        <p:txBody>
+          <a:bodyPr wrap="square" lIns="45720" rIns="45720" rtlCol="0" anchor="ctr"/>
+          <a:lstStyle/>
+          <a:p>
+            <a:pPr algn="l"/>
+            <a:r>
+              <a:rPr sz="1350" b="1">
+                <a:solidFill>
+                  <a:srgbClr val="C0392B"/>
+                </a:solidFill>
+                <a:latin typeface="Arial"/>
+              </a:rPr>
+              <a:t>Phase 2 · Docking</a:t>
+            </a:r>
+          </a:p>
+          <a:p>
+            <a:pPr algn="l"/>
+            <a:r>
+              <a:rPr sz="1100">
+                <a:solidFill>
+                  <a:srgbClr val="333333"/>
+                </a:solidFill>
+                <a:latin typeface="Arial"/>
+              </a:rPr>
+              <a:t>Method : Robust reach avoid RL</a:t>
+            </a:r>
+          </a:p>
+        </p:txBody>
+      </p:sp>
+      <p:cxnSp>
+        <p:nvCxnSpPr>
+          <p:cNvPr id="58" name="Connector 57">
+            <a:extLst>
+              <a:ext uri="{FF2B5EF4-FFF2-40B4-BE49-F238E27FC236}">
+                <a16:creationId xmlns:a16="http://schemas.microsoft.com/office/drawing/2014/main" id="{B95ECA1F-BDEF-A98B-EDA9-BA7F9635612A}"/>
+              </a:ext>
+            </a:extLst>
+          </p:cNvPr>
+          <p:cNvCxnSpPr>
+            <a:cxnSpLocks/>
+            <a:stCxn id="57" idx="0"/>
+          </p:cNvCxnSpPr>
+          <p:nvPr/>
+        </p:nvCxnSpPr>
+        <p:spPr>
+          <a:xfrm flipH="1" flipV="1">
+            <a:off x="6330029" y="2333223"/>
+            <a:ext cx="1199831" cy="1832875"/>
+          </a:xfrm>
+          <a:prstGeom prst="line">
+            <a:avLst/>
+          </a:prstGeom>
+          <a:ln w="12700">
+            <a:solidFill>
+              <a:srgbClr val="C0392B"/>
+            </a:solidFill>
+          </a:ln>
+        </p:spPr>
+        <p:style>
+          <a:lnRef idx="2">
+            <a:schemeClr val="accent1"/>
+          </a:lnRef>
+          <a:fillRef idx="0">
+            <a:schemeClr val="accent1"/>
+          </a:fillRef>
+          <a:effectRef idx="1">
+            <a:schemeClr val="accent1"/>
+          </a:effectRef>
+          <a:fontRef idx="minor">
+            <a:schemeClr val="tx1"/>
+          </a:fontRef>
+        </p:style>
+      </p:cxnSp>
+      <p:pic>
+        <p:nvPicPr>
+          <p:cNvPr id="61" name="그림 60">
+            <a:extLst>
+              <a:ext uri="{FF2B5EF4-FFF2-40B4-BE49-F238E27FC236}">
+                <a16:creationId xmlns:a16="http://schemas.microsoft.com/office/drawing/2014/main" id="{883BAE08-957C-1E71-D49A-D6A98D467135}"/>
+              </a:ext>
+            </a:extLst>
+          </p:cNvPr>
+          <p:cNvPicPr>
+            <a:picLocks noChangeAspect="1"/>
+          </p:cNvPicPr>
+          <p:nvPr/>
+        </p:nvPicPr>
+        <p:blipFill>
+          <a:blip r:embed="rId3"/>
+          <a:srcRect l="3415" t="5994" r="4938" b="66394"/>
+          <a:stretch>
+            <a:fillRect/>
+          </a:stretch>
+        </p:blipFill>
+        <p:spPr>
+          <a:xfrm>
+            <a:off x="4294066" y="398512"/>
+            <a:ext cx="6186746" cy="1242589"/>
+          </a:xfrm>
+          <a:prstGeom prst="rect">
+            <a:avLst/>
+          </a:prstGeom>
+        </p:spPr>
+      </p:pic>
+      <p:pic>
+        <p:nvPicPr>
+          <p:cNvPr id="63" name="그림 62">
+            <a:extLst>
+              <a:ext uri="{FF2B5EF4-FFF2-40B4-BE49-F238E27FC236}">
+                <a16:creationId xmlns:a16="http://schemas.microsoft.com/office/drawing/2014/main" id="{71AE7082-E866-3631-951D-8CDCD1750943}"/>
+              </a:ext>
+            </a:extLst>
+          </p:cNvPr>
+          <p:cNvPicPr>
+            <a:picLocks noChangeAspect="1"/>
+          </p:cNvPicPr>
+          <p:nvPr/>
+        </p:nvPicPr>
+        <p:blipFill>
+          <a:blip r:embed="rId3"/>
+          <a:srcRect l="10392" t="79073" r="57408" b="8050"/>
+          <a:stretch>
+            <a:fillRect/>
+          </a:stretch>
+        </p:blipFill>
+        <p:spPr>
+          <a:xfrm rot="20514241">
+            <a:off x="1642438" y="3627212"/>
+            <a:ext cx="1008240" cy="329871"/>
+          </a:xfrm>
+          <a:prstGeom prst="rect">
+            <a:avLst/>
+          </a:prstGeom>
+        </p:spPr>
+      </p:pic>
+      <p:pic>
+        <p:nvPicPr>
+          <p:cNvPr id="65" name="그림 64">
+            <a:extLst>
+              <a:ext uri="{FF2B5EF4-FFF2-40B4-BE49-F238E27FC236}">
+                <a16:creationId xmlns:a16="http://schemas.microsoft.com/office/drawing/2014/main" id="{93F66D66-3BE8-07A9-831B-46B5EFB8C37C}"/>
+              </a:ext>
+            </a:extLst>
+          </p:cNvPr>
+          <p:cNvPicPr>
+            <a:picLocks noChangeAspect="1"/>
+          </p:cNvPicPr>
+          <p:nvPr/>
+        </p:nvPicPr>
+        <p:blipFill>
+          <a:blip r:embed="rId3"/>
+          <a:srcRect l="10392" t="79073" r="57408" b="8050"/>
+          <a:stretch>
+            <a:fillRect/>
+          </a:stretch>
+        </p:blipFill>
+        <p:spPr>
+          <a:xfrm rot="20594310">
+            <a:off x="3103357" y="2549342"/>
+            <a:ext cx="1008240" cy="329871"/>
+          </a:xfrm>
+          <a:prstGeom prst="rect">
+            <a:avLst/>
+          </a:prstGeom>
+        </p:spPr>
+      </p:pic>
+      <p:pic>
+        <p:nvPicPr>
+          <p:cNvPr id="67" name="그림 66">
+            <a:extLst>
+              <a:ext uri="{FF2B5EF4-FFF2-40B4-BE49-F238E27FC236}">
+                <a16:creationId xmlns:a16="http://schemas.microsoft.com/office/drawing/2014/main" id="{63E96745-3C56-DF2E-2B29-542D44D0CC96}"/>
+              </a:ext>
+            </a:extLst>
+          </p:cNvPr>
+          <p:cNvPicPr>
+            <a:picLocks noChangeAspect="1"/>
+          </p:cNvPicPr>
+          <p:nvPr/>
+        </p:nvPicPr>
+        <p:blipFill>
+          <a:blip r:embed="rId3"/>
+          <a:srcRect l="10392" t="79073" r="57408" b="8050"/>
+          <a:stretch>
+            <a:fillRect/>
+          </a:stretch>
+        </p:blipFill>
+        <p:spPr>
+          <a:xfrm rot="21263084">
+            <a:off x="5843188" y="1916738"/>
+            <a:ext cx="1008240" cy="329871"/>
+          </a:xfrm>
+          <a:prstGeom prst="rect">
+            <a:avLst/>
+          </a:prstGeom>
+        </p:spPr>
+      </p:pic>
+      <p:grpSp>
+        <p:nvGrpSpPr>
+          <p:cNvPr id="128" name="그룹 127">
+            <a:extLst>
+              <a:ext uri="{FF2B5EF4-FFF2-40B4-BE49-F238E27FC236}">
+                <a16:creationId xmlns:a16="http://schemas.microsoft.com/office/drawing/2014/main" id="{EC4D1173-50B8-FB43-9ABD-E5B3C1C6773C}"/>
+              </a:ext>
+            </a:extLst>
+          </p:cNvPr>
+          <p:cNvGrpSpPr/>
+          <p:nvPr/>
+        </p:nvGrpSpPr>
+        <p:grpSpPr>
+          <a:xfrm>
+            <a:off x="8344916" y="2515132"/>
+            <a:ext cx="3538489" cy="1328342"/>
+            <a:chOff x="7619108" y="3018448"/>
+            <a:chExt cx="4374738" cy="1642268"/>
+          </a:xfrm>
+        </p:grpSpPr>
+        <p:sp>
+          <p:nvSpPr>
+            <p:cNvPr id="124" name="사각형: 둥근 모서리 123">
+              <a:extLst>
+                <a:ext uri="{FF2B5EF4-FFF2-40B4-BE49-F238E27FC236}">
+                  <a16:creationId xmlns:a16="http://schemas.microsoft.com/office/drawing/2014/main" id="{0EEBA7F7-2C90-20E4-BFDE-273BCA72CB8A}"/>
+                </a:ext>
+              </a:extLst>
+            </p:cNvPr>
+            <p:cNvSpPr/>
+            <p:nvPr/>
+          </p:nvSpPr>
+          <p:spPr>
+            <a:xfrm>
+              <a:off x="7619108" y="3018448"/>
+              <a:ext cx="4325946" cy="1628953"/>
+            </a:xfrm>
+            <a:prstGeom prst="roundRect">
+              <a:avLst/>
+            </a:prstGeom>
+            <a:noFill/>
+            <a:ln w="19050">
+              <a:solidFill>
+                <a:schemeClr val="tx1"/>
+              </a:solidFill>
+              <a:prstDash val="dash"/>
+            </a:ln>
+            <a:effectLst/>
+          </p:spPr>
+          <p:style>
+            <a:lnRef idx="1">
+              <a:schemeClr val="accent1"/>
+            </a:lnRef>
+            <a:fillRef idx="3">
+              <a:schemeClr val="accent1"/>
+            </a:fillRef>
+            <a:effectRef idx="2">
+              <a:schemeClr val="accent1"/>
+            </a:effectRef>
+            <a:fontRef idx="minor">
+              <a:schemeClr val="lt1"/>
+            </a:fontRef>
+          </p:style>
+          <p:txBody>
+            <a:bodyPr rtlCol="0" anchor="ctr"/>
+            <a:lstStyle/>
+            <a:p>
+              <a:pPr algn="ctr"/>
+              <a:endParaRPr lang="ko-KR" altLang="en-US"/>
+            </a:p>
+          </p:txBody>
+        </p:sp>
+        <p:sp>
+          <p:nvSpPr>
+            <p:cNvPr id="44" name="TextBox 43">
+              <a:extLst>
+                <a:ext uri="{FF2B5EF4-FFF2-40B4-BE49-F238E27FC236}">
+                  <a16:creationId xmlns:a16="http://schemas.microsoft.com/office/drawing/2014/main" id="{638202AF-2449-538A-8694-561A42B05DC2}"/>
+                </a:ext>
+              </a:extLst>
+            </p:cNvPr>
+            <p:cNvSpPr txBox="1"/>
+            <p:nvPr/>
+          </p:nvSpPr>
+          <p:spPr>
+            <a:xfrm>
+              <a:off x="7675879" y="3468445"/>
+              <a:ext cx="1563928" cy="199770"/>
+            </a:xfrm>
+            <a:prstGeom prst="rect">
+              <a:avLst/>
+            </a:prstGeom>
+            <a:noFill/>
+          </p:spPr>
+          <p:txBody>
+            <a:bodyPr wrap="square" lIns="0" tIns="0" rIns="0" bIns="0" anchor="ctr">
+              <a:spAutoFit/>
+            </a:bodyPr>
+            <a:lstStyle/>
+            <a:p>
+              <a:pPr algn="ctr"/>
+              <a:r>
+                <a:rPr sz="1050" b="1" i="1" dirty="0">
+                  <a:solidFill>
+                    <a:srgbClr val="C0392B"/>
+                  </a:solidFill>
+                  <a:latin typeface="Arial"/>
+                </a:rPr>
+                <a:t>side boundary ∈ F</a:t>
+              </a:r>
+            </a:p>
+          </p:txBody>
+        </p:sp>
+        <p:sp>
+          <p:nvSpPr>
+            <p:cNvPr id="51" name="TextBox 50">
+              <a:extLst>
+                <a:ext uri="{FF2B5EF4-FFF2-40B4-BE49-F238E27FC236}">
+                  <a16:creationId xmlns:a16="http://schemas.microsoft.com/office/drawing/2014/main" id="{5FA0D53B-4563-1417-900B-0BEF02EEE23A}"/>
+                </a:ext>
+              </a:extLst>
+            </p:cNvPr>
+            <p:cNvSpPr txBox="1"/>
+            <p:nvPr/>
+          </p:nvSpPr>
+          <p:spPr>
+            <a:xfrm>
+              <a:off x="10256486" y="4203516"/>
+              <a:ext cx="1737360" cy="457200"/>
+            </a:xfrm>
+            <a:prstGeom prst="rect">
+              <a:avLst/>
+            </a:prstGeom>
+            <a:noFill/>
+          </p:spPr>
+          <p:txBody>
+            <a:bodyPr wrap="square" lIns="0" tIns="0" rIns="0" bIns="0" anchor="ctr">
+              <a:spAutoFit/>
+            </a:bodyPr>
+            <a:lstStyle/>
+            <a:p>
+              <a:pPr algn="ctr"/>
+              <a:r>
+                <a:rPr sz="1100" b="1" i="0" dirty="0">
+                  <a:solidFill>
+                    <a:srgbClr val="C0392B"/>
+                  </a:solidFill>
+                  <a:latin typeface="Arial"/>
+                </a:rPr>
+                <a:t>cradle walls  ∈ F</a:t>
+              </a:r>
+            </a:p>
+          </p:txBody>
+        </p:sp>
+        <p:grpSp>
+          <p:nvGrpSpPr>
+            <p:cNvPr id="91" name="그룹 90">
+              <a:extLst>
+                <a:ext uri="{FF2B5EF4-FFF2-40B4-BE49-F238E27FC236}">
+                  <a16:creationId xmlns:a16="http://schemas.microsoft.com/office/drawing/2014/main" id="{F0450F82-CC08-EA1E-8777-9CFA82134FD8}"/>
+                </a:ext>
+              </a:extLst>
+            </p:cNvPr>
+            <p:cNvGrpSpPr/>
+            <p:nvPr/>
+          </p:nvGrpSpPr>
+          <p:grpSpPr>
+            <a:xfrm>
+              <a:off x="9610317" y="3440897"/>
+              <a:ext cx="1772290" cy="871097"/>
+              <a:chOff x="7609842" y="3689133"/>
+              <a:chExt cx="2338830" cy="1149557"/>
+            </a:xfrm>
+          </p:grpSpPr>
+          <p:grpSp>
+            <p:nvGrpSpPr>
+              <p:cNvPr id="89" name="그룹 88">
+                <a:extLst>
+                  <a:ext uri="{FF2B5EF4-FFF2-40B4-BE49-F238E27FC236}">
+                    <a16:creationId xmlns:a16="http://schemas.microsoft.com/office/drawing/2014/main" id="{DBD66AA6-2578-D289-6CCA-E422E1496EF0}"/>
+                  </a:ext>
+                </a:extLst>
+              </p:cNvPr>
+              <p:cNvGrpSpPr/>
+              <p:nvPr/>
+            </p:nvGrpSpPr>
+            <p:grpSpPr>
+              <a:xfrm>
+                <a:off x="7614075" y="3689133"/>
+                <a:ext cx="2334597" cy="1149557"/>
+                <a:chOff x="7447280" y="3841662"/>
+                <a:chExt cx="2334597" cy="1149557"/>
+              </a:xfrm>
+            </p:grpSpPr>
+            <p:pic>
+              <p:nvPicPr>
+                <p:cNvPr id="73" name="그림 72">
+                  <a:extLst>
+                    <a:ext uri="{FF2B5EF4-FFF2-40B4-BE49-F238E27FC236}">
+                      <a16:creationId xmlns:a16="http://schemas.microsoft.com/office/drawing/2014/main" id="{D25F8341-DA89-F3A7-409F-81BFE6AF6937}"/>
+                    </a:ext>
+                  </a:extLst>
+                </p:cNvPr>
+                <p:cNvPicPr>
+                  <a:picLocks noChangeAspect="1"/>
+                </p:cNvPicPr>
+                <p:nvPr/>
+              </p:nvPicPr>
+              <p:blipFill>
+                <a:blip r:embed="rId2"/>
+                <a:srcRect t="20686" b="23574"/>
+                <a:stretch>
+                  <a:fillRect/>
+                </a:stretch>
+              </p:blipFill>
+              <p:spPr>
+                <a:xfrm rot="10800000">
+                  <a:off x="7447280" y="3850128"/>
+                  <a:ext cx="2272876" cy="1141091"/>
+                </a:xfrm>
+                <a:prstGeom prst="rect">
+                  <a:avLst/>
+                </a:prstGeom>
+              </p:spPr>
+            </p:pic>
+            <p:sp>
+              <p:nvSpPr>
+                <p:cNvPr id="87" name="자유형: 도형 86">
+                  <a:extLst>
+                    <a:ext uri="{FF2B5EF4-FFF2-40B4-BE49-F238E27FC236}">
+                      <a16:creationId xmlns:a16="http://schemas.microsoft.com/office/drawing/2014/main" id="{512C4FC6-179E-7D9D-64E8-27A745264EB8}"/>
+                    </a:ext>
+                  </a:extLst>
+                </p:cNvPr>
+                <p:cNvSpPr/>
+                <p:nvPr/>
+              </p:nvSpPr>
+              <p:spPr>
+                <a:xfrm>
+                  <a:off x="7447280" y="3841662"/>
+                  <a:ext cx="2334597" cy="1141092"/>
+                </a:xfrm>
+                <a:custGeom>
+                  <a:avLst/>
+                  <a:gdLst>
+                    <a:gd name="csX0" fmla="*/ 1815251 w 2334597"/>
+                    <a:gd name="csY0" fmla="*/ 0 h 1141092"/>
+                    <a:gd name="csX1" fmla="*/ 2334597 w 2334597"/>
+                    <a:gd name="csY1" fmla="*/ 0 h 1141092"/>
+                    <a:gd name="csX2" fmla="*/ 2334597 w 2334597"/>
+                    <a:gd name="csY2" fmla="*/ 1141092 h 1141092"/>
+                    <a:gd name="csX3" fmla="*/ 2332567 w 2334597"/>
+                    <a:gd name="csY3" fmla="*/ 1141092 h 1141092"/>
+                    <a:gd name="csX4" fmla="*/ 1815251 w 2334597"/>
+                    <a:gd name="csY4" fmla="*/ 1141092 h 1141092"/>
+                    <a:gd name="csX5" fmla="*/ 0 w 2334597"/>
+                    <a:gd name="csY5" fmla="*/ 1141092 h 1141092"/>
+                    <a:gd name="csX6" fmla="*/ 0 w 2334597"/>
+                    <a:gd name="csY6" fmla="*/ 778422 h 1141092"/>
+                    <a:gd name="csX7" fmla="*/ 1815251 w 2334597"/>
+                    <a:gd name="csY7" fmla="*/ 778422 h 1141092"/>
+                    <a:gd name="csX8" fmla="*/ 1815251 w 2334597"/>
+                    <a:gd name="csY8" fmla="*/ 362671 h 1141092"/>
+                    <a:gd name="csX9" fmla="*/ 0 w 2334597"/>
+                    <a:gd name="csY9" fmla="*/ 362671 h 1141092"/>
+                    <a:gd name="csX10" fmla="*/ 0 w 2334597"/>
+                    <a:gd name="csY10" fmla="*/ 1 h 1141092"/>
+                    <a:gd name="csX11" fmla="*/ 1815251 w 2334597"/>
+                    <a:gd name="csY11" fmla="*/ 1 h 1141092"/>
+                  </a:gdLst>
+                  <a:ahLst/>
+                  <a:cxnLst>
+                    <a:cxn ang="0">
+                      <a:pos x="csX0" y="csY0"/>
+                    </a:cxn>
+                    <a:cxn ang="0">
+                      <a:pos x="csX1" y="csY1"/>
+                    </a:cxn>
+                    <a:cxn ang="0">
+                      <a:pos x="csX2" y="csY2"/>
+                    </a:cxn>
+                    <a:cxn ang="0">
+                      <a:pos x="csX3" y="csY3"/>
+                    </a:cxn>
+                    <a:cxn ang="0">
+                      <a:pos x="csX4" y="csY4"/>
+                    </a:cxn>
+                    <a:cxn ang="0">
+                      <a:pos x="csX5" y="csY5"/>
+                    </a:cxn>
+                    <a:cxn ang="0">
+                      <a:pos x="csX6" y="csY6"/>
+                    </a:cxn>
+                    <a:cxn ang="0">
+                      <a:pos x="csX7" y="csY7"/>
+                    </a:cxn>
+                    <a:cxn ang="0">
+                      <a:pos x="csX8" y="csY8"/>
+                    </a:cxn>
+                    <a:cxn ang="0">
+                      <a:pos x="csX9" y="csY9"/>
+                    </a:cxn>
+                    <a:cxn ang="0">
+                      <a:pos x="csX10" y="csY10"/>
+                    </a:cxn>
+                    <a:cxn ang="0">
+                      <a:pos x="csX11" y="csY11"/>
+                    </a:cxn>
+                  </a:cxnLst>
+                  <a:rect l="l" t="t" r="r" b="b"/>
+                  <a:pathLst>
+                    <a:path w="2334597" h="1141092">
+                      <a:moveTo>
+                        <a:pt x="1815251" y="0"/>
+                      </a:moveTo>
+                      <a:lnTo>
+                        <a:pt x="2334597" y="0"/>
+                      </a:lnTo>
+                      <a:lnTo>
+                        <a:pt x="2334597" y="1141092"/>
+                      </a:lnTo>
+                      <a:lnTo>
+                        <a:pt x="2332567" y="1141092"/>
+                      </a:lnTo>
+                      <a:lnTo>
+                        <a:pt x="1815251" y="1141092"/>
+                      </a:lnTo>
+                      <a:lnTo>
+                        <a:pt x="0" y="1141092"/>
+                      </a:lnTo>
+                      <a:lnTo>
+                        <a:pt x="0" y="778422"/>
+                      </a:lnTo>
+                      <a:lnTo>
+                        <a:pt x="1815251" y="778422"/>
+                      </a:lnTo>
+                      <a:lnTo>
+                        <a:pt x="1815251" y="362671"/>
+                      </a:lnTo>
+                      <a:lnTo>
+                        <a:pt x="0" y="362671"/>
+                      </a:lnTo>
+                      <a:lnTo>
+                        <a:pt x="0" y="1"/>
+                      </a:lnTo>
+                      <a:lnTo>
+                        <a:pt x="1815251" y="1"/>
+                      </a:lnTo>
+                      <a:close/>
+                    </a:path>
+                  </a:pathLst>
+                </a:custGeom>
+                <a:solidFill>
+                  <a:schemeClr val="accent6">
+                    <a:lumMod val="40000"/>
+                    <a:lumOff val="60000"/>
+                    <a:alpha val="51000"/>
+                  </a:schemeClr>
+                </a:solidFill>
+                <a:ln>
+                  <a:solidFill>
+                    <a:srgbClr val="FF6600"/>
+                  </a:solidFill>
+                  <a:prstDash val="dash"/>
+                </a:ln>
+              </p:spPr>
+              <p:style>
+                <a:lnRef idx="2">
+                  <a:schemeClr val="dk1"/>
+                </a:lnRef>
+                <a:fillRef idx="1">
+                  <a:schemeClr val="lt1"/>
+                </a:fillRef>
+                <a:effectRef idx="0">
+                  <a:schemeClr val="dk1"/>
+                </a:effectRef>
+                <a:fontRef idx="minor">
+                  <a:schemeClr val="dk1"/>
+                </a:fontRef>
+              </p:style>
+              <p:txBody>
+                <a:bodyPr wrap="square" rtlCol="0" anchor="ctr">
+                  <a:noAutofit/>
+                </a:bodyPr>
+                <a:lstStyle/>
+                <a:p>
+                  <a:pPr algn="ctr"/>
+                  <a:endParaRPr lang="ko-KR" altLang="en-US">
+                    <a:ln w="0"/>
+                    <a:solidFill>
+                      <a:schemeClr val="tx1"/>
+                    </a:solidFill>
+                    <a:effectLst>
+                      <a:outerShdw blurRad="38100" dist="19050" dir="2700000" algn="tl" rotWithShape="0">
+                        <a:schemeClr val="dk1">
+                          <a:alpha val="40000"/>
+                        </a:schemeClr>
+                      </a:outerShdw>
+                    </a:effectLst>
+                  </a:endParaRPr>
+                </a:p>
+              </p:txBody>
+            </p:sp>
+          </p:grpSp>
+          <p:sp>
+            <p:nvSpPr>
+              <p:cNvPr id="90" name="직사각형 89">
+                <a:extLst>
+                  <a:ext uri="{FF2B5EF4-FFF2-40B4-BE49-F238E27FC236}">
+                    <a16:creationId xmlns:a16="http://schemas.microsoft.com/office/drawing/2014/main" id="{6F61FD2A-63A4-591F-7E15-EAE37CC0E3C7}"/>
+                  </a:ext>
+                </a:extLst>
+              </p:cNvPr>
+              <p:cNvSpPr/>
+              <p:nvPr/>
+            </p:nvSpPr>
+            <p:spPr>
+              <a:xfrm>
+                <a:off x="7609842" y="4092811"/>
+                <a:ext cx="1775459" cy="329868"/>
+              </a:xfrm>
+              <a:prstGeom prst="rect">
+                <a:avLst/>
+              </a:prstGeom>
+              <a:solidFill>
+                <a:schemeClr val="accent3">
+                  <a:lumMod val="20000"/>
+                  <a:lumOff val="80000"/>
+                </a:schemeClr>
+              </a:solidFill>
+              <a:ln w="19050">
+                <a:solidFill>
+                  <a:schemeClr val="accent3">
+                    <a:lumMod val="75000"/>
+                  </a:schemeClr>
+                </a:solidFill>
+                <a:prstDash val="sysDot"/>
+              </a:ln>
+            </p:spPr>
+            <p:style>
+              <a:lnRef idx="2">
+                <a:schemeClr val="dk1"/>
+              </a:lnRef>
+              <a:fillRef idx="1">
+                <a:schemeClr val="lt1"/>
+              </a:fillRef>
+              <a:effectRef idx="0">
+                <a:schemeClr val="dk1"/>
+              </a:effectRef>
+              <a:fontRef idx="minor">
+                <a:schemeClr val="dk1"/>
+              </a:fontRef>
+            </p:style>
+            <p:txBody>
+              <a:bodyPr rtlCol="0" anchor="ctr"/>
+              <a:lstStyle/>
+              <a:p>
+                <a:pPr algn="ctr"/>
+                <a:endParaRPr lang="ko-KR" altLang="en-US"/>
+              </a:p>
+            </p:txBody>
+          </p:sp>
+        </p:grpSp>
+        <p:grpSp>
+          <p:nvGrpSpPr>
+            <p:cNvPr id="94" name="그룹 93">
+              <a:extLst>
+                <a:ext uri="{FF2B5EF4-FFF2-40B4-BE49-F238E27FC236}">
+                  <a16:creationId xmlns:a16="http://schemas.microsoft.com/office/drawing/2014/main" id="{C8146ABF-E913-B1AB-2CDA-32CA10753CB8}"/>
+                </a:ext>
+              </a:extLst>
+            </p:cNvPr>
+            <p:cNvGrpSpPr/>
+            <p:nvPr/>
+          </p:nvGrpSpPr>
+          <p:grpSpPr>
+            <a:xfrm rot="21238330">
+              <a:off x="8452894" y="3780929"/>
+              <a:ext cx="1185669" cy="387770"/>
+              <a:chOff x="6083109" y="4170560"/>
+              <a:chExt cx="1564687" cy="511727"/>
+            </a:xfrm>
+          </p:grpSpPr>
+          <p:pic>
+            <p:nvPicPr>
+              <p:cNvPr id="82" name="그림 81">
+                <a:extLst>
+                  <a:ext uri="{FF2B5EF4-FFF2-40B4-BE49-F238E27FC236}">
+                    <a16:creationId xmlns:a16="http://schemas.microsoft.com/office/drawing/2014/main" id="{A6CF955F-5F3C-4C05-0B43-7FFE00BE1A7D}"/>
+                  </a:ext>
+                </a:extLst>
+              </p:cNvPr>
+              <p:cNvPicPr>
+                <a:picLocks noChangeAspect="1"/>
+              </p:cNvPicPr>
+              <p:nvPr/>
+            </p:nvPicPr>
+            <p:blipFill>
+              <a:blip r:embed="rId3"/>
+              <a:srcRect l="10392" t="79073" r="57408" b="8050"/>
+              <a:stretch>
+                <a:fillRect/>
+              </a:stretch>
+            </p:blipFill>
+            <p:spPr>
+              <a:xfrm rot="21278377">
+                <a:off x="6083109" y="4170560"/>
+                <a:ext cx="1564077" cy="511727"/>
+              </a:xfrm>
+              <a:prstGeom prst="rect">
+                <a:avLst/>
+              </a:prstGeom>
+            </p:spPr>
+          </p:pic>
+          <p:sp>
+            <p:nvSpPr>
+              <p:cNvPr id="93" name="타원 92">
+                <a:extLst>
+                  <a:ext uri="{FF2B5EF4-FFF2-40B4-BE49-F238E27FC236}">
+                    <a16:creationId xmlns:a16="http://schemas.microsoft.com/office/drawing/2014/main" id="{346891C5-9981-E578-9C5D-045380BD025B}"/>
+                  </a:ext>
+                </a:extLst>
+              </p:cNvPr>
+              <p:cNvSpPr/>
+              <p:nvPr/>
+            </p:nvSpPr>
+            <p:spPr>
+              <a:xfrm flipH="1">
+                <a:off x="7573423" y="4308006"/>
+                <a:ext cx="74373" cy="74373"/>
+              </a:xfrm>
+              <a:prstGeom prst="ellipse">
+                <a:avLst/>
+              </a:prstGeom>
+              <a:solidFill>
+                <a:schemeClr val="accent5">
+                  <a:lumMod val="40000"/>
+                  <a:lumOff val="60000"/>
+                </a:schemeClr>
+              </a:solidFill>
+              <a:ln>
+                <a:solidFill>
+                  <a:schemeClr val="accent1"/>
+                </a:solidFill>
+              </a:ln>
+            </p:spPr>
+            <p:style>
+              <a:lnRef idx="2">
+                <a:schemeClr val="dk1"/>
+              </a:lnRef>
+              <a:fillRef idx="1">
+                <a:schemeClr val="lt1"/>
+              </a:fillRef>
+              <a:effectRef idx="0">
+                <a:schemeClr val="dk1"/>
+              </a:effectRef>
+              <a:fontRef idx="minor">
+                <a:schemeClr val="dk1"/>
+              </a:fontRef>
+            </p:style>
+            <p:txBody>
+              <a:bodyPr rtlCol="0" anchor="ctr"/>
+              <a:lstStyle/>
+              <a:p>
+                <a:pPr algn="ctr"/>
+                <a:endParaRPr lang="ko-KR" altLang="en-US"/>
+              </a:p>
+            </p:txBody>
+          </p:sp>
+        </p:grpSp>
+        <p:cxnSp>
+          <p:nvCxnSpPr>
+            <p:cNvPr id="97" name="Connector 9">
+              <a:extLst>
+                <a:ext uri="{FF2B5EF4-FFF2-40B4-BE49-F238E27FC236}">
+                  <a16:creationId xmlns:a16="http://schemas.microsoft.com/office/drawing/2014/main" id="{E275C861-9756-3EF4-6723-7A70B679B381}"/>
+                </a:ext>
+              </a:extLst>
+            </p:cNvPr>
+            <p:cNvCxnSpPr>
+              <a:cxnSpLocks/>
+            </p:cNvCxnSpPr>
+            <p:nvPr/>
+          </p:nvCxnSpPr>
+          <p:spPr>
+            <a:xfrm>
+              <a:off x="7899150" y="3440897"/>
+              <a:ext cx="1670666" cy="0"/>
+            </a:xfrm>
+            <a:prstGeom prst="line">
+              <a:avLst/>
+            </a:prstGeom>
+            <a:ln w="25400">
+              <a:solidFill>
+                <a:srgbClr val="FF6600"/>
+              </a:solidFill>
+              <a:prstDash val="dash"/>
+            </a:ln>
+            <a:effectLst/>
+          </p:spPr>
+          <p:style>
+            <a:lnRef idx="1">
+              <a:schemeClr val="dk1"/>
+            </a:lnRef>
+            <a:fillRef idx="0">
+              <a:schemeClr val="dk1"/>
+            </a:fillRef>
+            <a:effectRef idx="0">
+              <a:schemeClr val="dk1"/>
+            </a:effectRef>
+            <a:fontRef idx="minor">
+              <a:schemeClr val="tx1"/>
+            </a:fontRef>
+          </p:style>
+        </p:cxnSp>
+        <p:cxnSp>
+          <p:nvCxnSpPr>
+            <p:cNvPr id="103" name="Connector 9">
+              <a:extLst>
+                <a:ext uri="{FF2B5EF4-FFF2-40B4-BE49-F238E27FC236}">
+                  <a16:creationId xmlns:a16="http://schemas.microsoft.com/office/drawing/2014/main" id="{EE2B2BC7-052D-8386-057B-7CFE4FB23CFD}"/>
+                </a:ext>
+              </a:extLst>
+            </p:cNvPr>
+            <p:cNvCxnSpPr>
+              <a:cxnSpLocks/>
+            </p:cNvCxnSpPr>
+            <p:nvPr/>
+          </p:nvCxnSpPr>
+          <p:spPr>
+            <a:xfrm>
+              <a:off x="11419059" y="3440897"/>
+              <a:ext cx="337264" cy="0"/>
+            </a:xfrm>
+            <a:prstGeom prst="line">
+              <a:avLst/>
+            </a:prstGeom>
+            <a:ln w="25400">
+              <a:solidFill>
+                <a:srgbClr val="FF6600"/>
+              </a:solidFill>
+              <a:prstDash val="dash"/>
+            </a:ln>
+            <a:effectLst/>
+          </p:spPr>
+          <p:style>
+            <a:lnRef idx="1">
+              <a:schemeClr val="dk1"/>
+            </a:lnRef>
+            <a:fillRef idx="0">
+              <a:schemeClr val="dk1"/>
+            </a:fillRef>
+            <a:effectRef idx="0">
+              <a:schemeClr val="dk1"/>
+            </a:effectRef>
+            <a:fontRef idx="minor">
+              <a:schemeClr val="tx1"/>
+            </a:fontRef>
+          </p:style>
+        </p:cxnSp>
+        <p:sp>
+          <p:nvSpPr>
+            <p:cNvPr id="106" name="Rectangle 8">
+              <a:extLst>
+                <a:ext uri="{FF2B5EF4-FFF2-40B4-BE49-F238E27FC236}">
+                  <a16:creationId xmlns:a16="http://schemas.microsoft.com/office/drawing/2014/main" id="{D63A9DB3-3BF9-CD46-3B75-88998D35A639}"/>
+                </a:ext>
+              </a:extLst>
+            </p:cNvPr>
+            <p:cNvSpPr/>
+            <p:nvPr/>
+          </p:nvSpPr>
+          <p:spPr>
+            <a:xfrm>
+              <a:off x="7807841" y="3361380"/>
+              <a:ext cx="3948481" cy="72140"/>
+            </a:xfrm>
+            <a:prstGeom prst="rect">
+              <a:avLst/>
+            </a:prstGeom>
+            <a:solidFill>
+              <a:srgbClr val="FBE9DA"/>
+            </a:solidFill>
+            <a:ln>
+              <a:noFill/>
+            </a:ln>
+            <a:effectLst/>
+          </p:spPr>
+          <p:style>
+            <a:lnRef idx="1">
+              <a:schemeClr val="accent1"/>
+            </a:lnRef>
+            <a:fillRef idx="3">
+              <a:schemeClr val="accent1"/>
+            </a:fillRef>
+            <a:effectRef idx="2">
+              <a:schemeClr val="accent1"/>
+            </a:effectRef>
+            <a:fontRef idx="minor">
+              <a:schemeClr val="lt1"/>
+            </a:fontRef>
+          </p:style>
+          <p:txBody>
+            <a:bodyPr rtlCol="0" anchor="ctr"/>
+            <a:lstStyle/>
+            <a:p>
+              <a:pPr algn="ctr"/>
+              <a:endParaRPr/>
+            </a:p>
+          </p:txBody>
+        </p:sp>
+        <p:pic>
+          <p:nvPicPr>
+            <p:cNvPr id="127" name="그림 126">
+              <a:extLst>
+                <a:ext uri="{FF2B5EF4-FFF2-40B4-BE49-F238E27FC236}">
+                  <a16:creationId xmlns:a16="http://schemas.microsoft.com/office/drawing/2014/main" id="{9490E217-03EE-92A6-AFB3-CC4D16E14C1C}"/>
+                </a:ext>
+              </a:extLst>
+            </p:cNvPr>
+            <p:cNvPicPr>
+              <a:picLocks noChangeAspect="1"/>
+            </p:cNvPicPr>
+            <p:nvPr/>
+          </p:nvPicPr>
+          <p:blipFill>
+            <a:blip r:embed="rId3"/>
+            <a:srcRect l="10016" t="25048" r="29812" b="66394"/>
+            <a:stretch>
+              <a:fillRect/>
+            </a:stretch>
+          </p:blipFill>
+          <p:spPr>
+            <a:xfrm>
+              <a:off x="7619108" y="3028205"/>
+              <a:ext cx="4325946" cy="410168"/>
+            </a:xfrm>
+            <a:custGeom>
+              <a:avLst/>
+              <a:gdLst>
+                <a:gd name="csX0" fmla="*/ 271498 w 4325946"/>
+                <a:gd name="csY0" fmla="*/ 0 h 410168"/>
+                <a:gd name="csX1" fmla="*/ 4054448 w 4325946"/>
+                <a:gd name="csY1" fmla="*/ 0 h 410168"/>
+                <a:gd name="csX2" fmla="*/ 4325946 w 4325946"/>
+                <a:gd name="csY2" fmla="*/ 271498 h 410168"/>
+                <a:gd name="csX3" fmla="*/ 4325946 w 4325946"/>
+                <a:gd name="csY3" fmla="*/ 410168 h 410168"/>
+                <a:gd name="csX4" fmla="*/ 0 w 4325946"/>
+                <a:gd name="csY4" fmla="*/ 410168 h 410168"/>
+                <a:gd name="csX5" fmla="*/ 0 w 4325946"/>
+                <a:gd name="csY5" fmla="*/ 271498 h 410168"/>
+                <a:gd name="csX6" fmla="*/ 271498 w 4325946"/>
+                <a:gd name="csY6" fmla="*/ 0 h 410168"/>
+              </a:gdLst>
+              <a:ahLst/>
+              <a:cxnLst>
+                <a:cxn ang="0">
+                  <a:pos x="csX0" y="csY0"/>
+                </a:cxn>
+                <a:cxn ang="0">
+                  <a:pos x="csX1" y="csY1"/>
+                </a:cxn>
+                <a:cxn ang="0">
+                  <a:pos x="csX2" y="csY2"/>
+                </a:cxn>
+                <a:cxn ang="0">
+                  <a:pos x="csX3" y="csY3"/>
+                </a:cxn>
+                <a:cxn ang="0">
+                  <a:pos x="csX4" y="csY4"/>
+                </a:cxn>
+                <a:cxn ang="0">
+                  <a:pos x="csX5" y="csY5"/>
+                </a:cxn>
+                <a:cxn ang="0">
+                  <a:pos x="csX6" y="csY6"/>
+                </a:cxn>
+              </a:cxnLst>
+              <a:rect l="l" t="t" r="r" b="b"/>
+              <a:pathLst>
+                <a:path w="4325946" h="410168">
+                  <a:moveTo>
+                    <a:pt x="271498" y="0"/>
+                  </a:moveTo>
+                  <a:lnTo>
+                    <a:pt x="4054448" y="0"/>
+                  </a:lnTo>
+                  <a:cubicBezTo>
+                    <a:pt x="4204392" y="0"/>
+                    <a:pt x="4325946" y="121554"/>
+                    <a:pt x="4325946" y="271498"/>
+                  </a:cubicBezTo>
+                  <a:lnTo>
+                    <a:pt x="4325946" y="410168"/>
+                  </a:lnTo>
+                  <a:lnTo>
+                    <a:pt x="0" y="410168"/>
+                  </a:lnTo>
+                  <a:lnTo>
+                    <a:pt x="0" y="271498"/>
+                  </a:lnTo>
+                  <a:cubicBezTo>
+                    <a:pt x="0" y="121554"/>
+                    <a:pt x="121554" y="0"/>
+                    <a:pt x="271498" y="0"/>
+                  </a:cubicBezTo>
+                  <a:close/>
+                </a:path>
+              </a:pathLst>
+            </a:custGeom>
+          </p:spPr>
+        </p:pic>
+        <p:sp>
+          <p:nvSpPr>
+            <p:cNvPr id="109" name="TextBox 108">
+              <a:extLst>
+                <a:ext uri="{FF2B5EF4-FFF2-40B4-BE49-F238E27FC236}">
+                  <a16:creationId xmlns:a16="http://schemas.microsoft.com/office/drawing/2014/main" id="{943FFFBF-7D14-5601-0E75-3C81B9BE8DE1}"/>
+                </a:ext>
+              </a:extLst>
+            </p:cNvPr>
+            <p:cNvSpPr txBox="1"/>
+            <p:nvPr/>
+          </p:nvSpPr>
+          <p:spPr>
+            <a:xfrm>
+              <a:off x="9765621" y="3718142"/>
+              <a:ext cx="1209537" cy="253916"/>
+            </a:xfrm>
+            <a:prstGeom prst="rect">
+              <a:avLst/>
+            </a:prstGeom>
+            <a:noFill/>
+          </p:spPr>
+          <p:txBody>
+            <a:bodyPr wrap="square">
+              <a:spAutoFit/>
+            </a:bodyPr>
+            <a:lstStyle/>
+            <a:p>
+              <a:r>
+                <a:rPr lang="en-US" altLang="ko-KR" sz="1050" b="1" i="0" dirty="0">
+                  <a:solidFill>
+                    <a:srgbClr val="3E8E3E"/>
+                  </a:solidFill>
+                  <a:latin typeface="Arial"/>
+                </a:rPr>
+                <a:t>target set  T </a:t>
+              </a:r>
+              <a:endParaRPr lang="ko-KR" altLang="en-US" sz="1050" dirty="0"/>
+            </a:p>
+          </p:txBody>
+        </p:sp>
+      </p:grpSp>
+    </p:spTree>
+    <p:extLst>
+      <p:ext uri="{BB962C8B-B14F-4D97-AF65-F5344CB8AC3E}">
+        <p14:creationId xmlns:p14="http://schemas.microsoft.com/office/powerpoint/2010/main" val="3592759201"/>
+      </p:ext>
+    </p:extLst>
   </p:cSld>
   <p:clrMapOvr>
     <a:masterClrMapping/>

</xml_diff>

<commit_message>
Update Figure 2 and Figure 3 to revised versions, cropped tight
Co-Authored-By: Claude Opus 4.8 (1M context) <noreply@anthropic.com>
</commit_message>
<xml_diff>
--- a/Figure2_system.pptx
+++ b/Figure2_system.pptx
@@ -303,7 +303,7 @@
           <a:p>
             <a:fld id="{5BCAD085-E8A6-8845-BD4E-CB4CCA059FC4}" type="datetimeFigureOut">
               <a:rPr lang="en-US" smtClean="0"/>
-              <a:t>8/26/2026</a:t>
+              <a:t>8/27/2026</a:t>
             </a:fld>
             <a:endParaRPr lang="en-US"/>
           </a:p>
@@ -471,7 +471,7 @@
           <a:p>
             <a:fld id="{5BCAD085-E8A6-8845-BD4E-CB4CCA059FC4}" type="datetimeFigureOut">
               <a:rPr lang="en-US" smtClean="0"/>
-              <a:t>8/26/2026</a:t>
+              <a:t>8/27/2026</a:t>
             </a:fld>
             <a:endParaRPr lang="en-US"/>
           </a:p>
@@ -649,7 +649,7 @@
           <a:p>
             <a:fld id="{5BCAD085-E8A6-8845-BD4E-CB4CCA059FC4}" type="datetimeFigureOut">
               <a:rPr lang="en-US" smtClean="0"/>
-              <a:t>8/26/2026</a:t>
+              <a:t>8/27/2026</a:t>
             </a:fld>
             <a:endParaRPr lang="en-US"/>
           </a:p>
@@ -817,7 +817,7 @@
           <a:p>
             <a:fld id="{5BCAD085-E8A6-8845-BD4E-CB4CCA059FC4}" type="datetimeFigureOut">
               <a:rPr lang="en-US" smtClean="0"/>
-              <a:t>8/26/2026</a:t>
+              <a:t>8/27/2026</a:t>
             </a:fld>
             <a:endParaRPr lang="en-US"/>
           </a:p>
@@ -1062,7 +1062,7 @@
           <a:p>
             <a:fld id="{5BCAD085-E8A6-8845-BD4E-CB4CCA059FC4}" type="datetimeFigureOut">
               <a:rPr lang="en-US" smtClean="0"/>
-              <a:t>8/26/2026</a:t>
+              <a:t>8/27/2026</a:t>
             </a:fld>
             <a:endParaRPr lang="en-US"/>
           </a:p>
@@ -1347,7 +1347,7 @@
           <a:p>
             <a:fld id="{5BCAD085-E8A6-8845-BD4E-CB4CCA059FC4}" type="datetimeFigureOut">
               <a:rPr lang="en-US" smtClean="0"/>
-              <a:t>8/26/2026</a:t>
+              <a:t>8/27/2026</a:t>
             </a:fld>
             <a:endParaRPr lang="en-US"/>
           </a:p>
@@ -1766,7 +1766,7 @@
           <a:p>
             <a:fld id="{5BCAD085-E8A6-8845-BD4E-CB4CCA059FC4}" type="datetimeFigureOut">
               <a:rPr lang="en-US" smtClean="0"/>
-              <a:t>8/26/2026</a:t>
+              <a:t>8/27/2026</a:t>
             </a:fld>
             <a:endParaRPr lang="en-US"/>
           </a:p>
@@ -1883,7 +1883,7 @@
           <a:p>
             <a:fld id="{5BCAD085-E8A6-8845-BD4E-CB4CCA059FC4}" type="datetimeFigureOut">
               <a:rPr lang="en-US" smtClean="0"/>
-              <a:t>8/26/2026</a:t>
+              <a:t>8/27/2026</a:t>
             </a:fld>
             <a:endParaRPr lang="en-US"/>
           </a:p>
@@ -1978,7 +1978,7 @@
           <a:p>
             <a:fld id="{5BCAD085-E8A6-8845-BD4E-CB4CCA059FC4}" type="datetimeFigureOut">
               <a:rPr lang="en-US" smtClean="0"/>
-              <a:t>8/26/2026</a:t>
+              <a:t>8/27/2026</a:t>
             </a:fld>
             <a:endParaRPr lang="en-US"/>
           </a:p>
@@ -2253,7 +2253,7 @@
           <a:p>
             <a:fld id="{5BCAD085-E8A6-8845-BD4E-CB4CCA059FC4}" type="datetimeFigureOut">
               <a:rPr lang="en-US" smtClean="0"/>
-              <a:t>8/26/2026</a:t>
+              <a:t>8/27/2026</a:t>
             </a:fld>
             <a:endParaRPr lang="en-US"/>
           </a:p>
@@ -2505,7 +2505,7 @@
           <a:p>
             <a:fld id="{5BCAD085-E8A6-8845-BD4E-CB4CCA059FC4}" type="datetimeFigureOut">
               <a:rPr lang="en-US" smtClean="0"/>
-              <a:t>8/26/2026</a:t>
+              <a:t>8/27/2026</a:t>
             </a:fld>
             <a:endParaRPr lang="en-US"/>
           </a:p>
@@ -2716,7 +2716,7 @@
           <a:p>
             <a:fld id="{5BCAD085-E8A6-8845-BD4E-CB4CCA059FC4}" type="datetimeFigureOut">
               <a:rPr lang="en-US" smtClean="0"/>
-              <a:t>8/26/2026</a:t>
+              <a:t>8/27/2026</a:t>
             </a:fld>
             <a:endParaRPr lang="en-US"/>
           </a:p>
@@ -4616,7 +4616,7 @@
           <a:p>
             <a:pPr algn="ctr"/>
             <a:r>
-              <a:rPr sz="1200" b="1" i="0">
+              <a:rPr sz="1200" b="1" i="0" dirty="0">
                 <a:solidFill>
                   <a:srgbClr val="C0392B"/>
                 </a:solidFill>
@@ -6103,7 +6103,7 @@
               <a:lumOff val="80000"/>
             </a:schemeClr>
           </a:solidFill>
-          <a:ln w="12700">
+          <a:ln w="19050">
             <a:solidFill>
               <a:srgbClr val="316525"/>
             </a:solidFill>
@@ -6235,7 +6235,7 @@
           <a:p>
             <a:pPr algn="ctr"/>
             <a:r>
-              <a:rPr sz="1300" b="1" i="0">
+              <a:rPr sz="1300" b="1" i="0" dirty="0">
                 <a:solidFill>
                   <a:srgbClr val="304055"/>
                 </a:solidFill>
@@ -6354,7 +6354,7 @@
         </p:nvSpPr>
         <p:spPr>
           <a:xfrm>
-            <a:off x="3869053" y="3236765"/>
+            <a:off x="3589314" y="3274777"/>
             <a:ext cx="3291840" cy="161583"/>
           </a:xfrm>
           <a:prstGeom prst="rect">
@@ -6370,7 +6370,7 @@
           <a:p>
             <a:pPr algn="ctr"/>
             <a:r>
-              <a:rPr sz="1050" b="1" i="1">
+              <a:rPr sz="1050" b="1" i="1" dirty="0">
                 <a:solidFill>
                   <a:srgbClr val="3E8E3E"/>
                 </a:solidFill>
@@ -6435,6 +6435,7 @@
             <a:prstDash val="dash"/>
             <a:tailEnd type="triangle" w="med" len="med"/>
           </a:ln>
+          <a:effectLst/>
         </p:spPr>
         <p:style>
           <a:lnRef idx="1">
@@ -6474,7 +6475,7 @@
         <p:spPr>
           <a:xfrm>
             <a:off x="5454904" y="2025643"/>
-            <a:ext cx="1992376" cy="168916"/>
+            <a:ext cx="1910350" cy="168916"/>
           </a:xfrm>
           <a:custGeom>
             <a:avLst/>
@@ -6509,6 +6510,7 @@
             </a:solidFill>
             <a:prstDash val="dash"/>
           </a:ln>
+          <a:effectLst/>
         </p:spPr>
         <p:style>
           <a:lnRef idx="1">
@@ -6535,10 +6537,10 @@
       </p:sp>
       <p:grpSp>
         <p:nvGrpSpPr>
-          <p:cNvPr id="68" name="그룹 67">
+          <p:cNvPr id="3" name="그룹 2">
             <a:extLst>
               <a:ext uri="{FF2B5EF4-FFF2-40B4-BE49-F238E27FC236}">
-                <a16:creationId xmlns:a16="http://schemas.microsoft.com/office/drawing/2014/main" id="{60728377-5E44-0468-523B-1F77CF50FC76}"/>
+                <a16:creationId xmlns:a16="http://schemas.microsoft.com/office/drawing/2014/main" id="{4DFE5DB6-8F3B-3A0C-F4D3-5EB839CC1990}"/>
               </a:ext>
             </a:extLst>
           </p:cNvPr>
@@ -6549,7 +6551,7 @@
           <a:xfrm>
             <a:off x="5171156" y="2135124"/>
             <a:ext cx="201168" cy="201168"/>
-            <a:chOff x="5248656" y="2715768"/>
+            <a:chOff x="5171156" y="2135124"/>
             <a:chExt cx="201168" cy="201168"/>
           </a:xfrm>
         </p:grpSpPr>
@@ -6567,7 +6569,7 @@
           </p:nvSpPr>
           <p:spPr>
             <a:xfrm>
-              <a:off x="5248656" y="2715768"/>
+              <a:off x="5171156" y="2135124"/>
               <a:ext cx="201168" cy="201168"/>
             </a:xfrm>
             <a:prstGeom prst="ellipse">
@@ -6582,6 +6584,7 @@
               </a:solidFill>
               <a:prstDash val="dash"/>
             </a:ln>
+            <a:effectLst/>
           </p:spPr>
           <p:style>
             <a:lnRef idx="1">
@@ -6620,7 +6623,7 @@
           </p:nvSpPr>
           <p:spPr>
             <a:xfrm>
-              <a:off x="5321808" y="2788920"/>
+              <a:off x="5244308" y="2208276"/>
               <a:ext cx="54864" cy="54864"/>
             </a:xfrm>
             <a:prstGeom prst="ellipse">
@@ -6628,1155 +6631,6 @@
             </a:prstGeom>
             <a:solidFill>
               <a:srgbClr val="333333"/>
-            </a:solidFill>
-            <a:ln>
-              <a:noFill/>
-            </a:ln>
-          </p:spPr>
-          <p:style>
-            <a:lnRef idx="1">
-              <a:schemeClr val="accent1"/>
-            </a:lnRef>
-            <a:fillRef idx="3">
-              <a:schemeClr val="accent1"/>
-            </a:fillRef>
-            <a:effectRef idx="2">
-              <a:schemeClr val="accent1"/>
-            </a:effectRef>
-            <a:fontRef idx="minor">
-              <a:schemeClr val="lt1"/>
-            </a:fontRef>
-          </p:style>
-          <p:txBody>
-            <a:bodyPr rtlCol="0" anchor="ctr"/>
-            <a:lstStyle/>
-            <a:p>
-              <a:pPr algn="ctr"/>
-              <a:endParaRPr/>
-            </a:p>
-          </p:txBody>
-        </p:sp>
-      </p:grpSp>
-      <p:sp>
-        <p:nvSpPr>
-          <p:cNvPr id="18" name="TextBox 17">
-            <a:extLst>
-              <a:ext uri="{FF2B5EF4-FFF2-40B4-BE49-F238E27FC236}">
-                <a16:creationId xmlns:a16="http://schemas.microsoft.com/office/drawing/2014/main" id="{768AE48A-56F4-CDFC-A775-B2385DC65CDA}"/>
-              </a:ext>
-            </a:extLst>
-          </p:cNvPr>
-          <p:cNvSpPr txBox="1"/>
-          <p:nvPr/>
-        </p:nvSpPr>
-        <p:spPr>
-          <a:xfrm>
-            <a:off x="4448780" y="2272285"/>
-            <a:ext cx="1645920" cy="457200"/>
-          </a:xfrm>
-          <a:prstGeom prst="rect">
-            <a:avLst/>
-          </a:prstGeom>
-          <a:noFill/>
-        </p:spPr>
-        <p:txBody>
-          <a:bodyPr wrap="square" lIns="0" tIns="0" rIns="0" bIns="0" anchor="ctr">
-            <a:spAutoFit/>
-          </a:bodyPr>
-          <a:lstStyle/>
-          <a:p>
-            <a:pPr algn="ctr"/>
-            <a:r>
-              <a:rPr sz="1400" b="1" i="0" dirty="0">
-                <a:solidFill>
-                  <a:srgbClr val="2E6DA4"/>
-                </a:solidFill>
-                <a:latin typeface="Arial"/>
-              </a:rPr>
-              <a:t>DP point</a:t>
-            </a:r>
-          </a:p>
-        </p:txBody>
-      </p:sp>
-      <p:sp>
-        <p:nvSpPr>
-          <p:cNvPr id="20" name="TextBox 19">
-            <a:extLst>
-              <a:ext uri="{FF2B5EF4-FFF2-40B4-BE49-F238E27FC236}">
-                <a16:creationId xmlns:a16="http://schemas.microsoft.com/office/drawing/2014/main" id="{E8D61342-A978-517E-33B3-BBB75958B547}"/>
-              </a:ext>
-            </a:extLst>
-          </p:cNvPr>
-          <p:cNvSpPr txBox="1"/>
-          <p:nvPr/>
-        </p:nvSpPr>
-        <p:spPr>
-          <a:xfrm>
-            <a:off x="9948672" y="1737360"/>
-            <a:ext cx="1463040" cy="457200"/>
-          </a:xfrm>
-          <a:prstGeom prst="rect">
-            <a:avLst/>
-          </a:prstGeom>
-          <a:noFill/>
-        </p:spPr>
-        <p:txBody>
-          <a:bodyPr wrap="square" lIns="0" tIns="0" rIns="0" bIns="0" anchor="ctr">
-            <a:spAutoFit/>
-          </a:bodyPr>
-          <a:lstStyle/>
-          <a:p>
-            <a:pPr algn="ctr"/>
-            <a:r>
-              <a:rPr sz="1400" b="1" i="0">
-                <a:solidFill>
-                  <a:srgbClr val="333333"/>
-                </a:solidFill>
-                <a:latin typeface="Arial"/>
-              </a:rPr>
-              <a:t>Cradle</a:t>
-            </a:r>
-          </a:p>
-        </p:txBody>
-      </p:sp>
-      <p:sp>
-        <p:nvSpPr>
-          <p:cNvPr id="55" name="Rounded Rectangle 54">
-            <a:extLst>
-              <a:ext uri="{FF2B5EF4-FFF2-40B4-BE49-F238E27FC236}">
-                <a16:creationId xmlns:a16="http://schemas.microsoft.com/office/drawing/2014/main" id="{D9E1E059-E28D-B350-AA21-08D97FA463EC}"/>
-              </a:ext>
-            </a:extLst>
-          </p:cNvPr>
-          <p:cNvSpPr/>
-          <p:nvPr/>
-        </p:nvSpPr>
-        <p:spPr>
-          <a:xfrm>
-            <a:off x="2638169" y="4180136"/>
-            <a:ext cx="2646680" cy="658368"/>
-          </a:xfrm>
-          <a:prstGeom prst="roundRect">
-            <a:avLst/>
-          </a:prstGeom>
-          <a:solidFill>
-            <a:srgbClr val="FFFFFF"/>
-          </a:solidFill>
-          <a:ln w="20320">
-            <a:solidFill>
-              <a:srgbClr val="2E6DA4"/>
-            </a:solidFill>
-          </a:ln>
-        </p:spPr>
-        <p:style>
-          <a:lnRef idx="1">
-            <a:schemeClr val="accent1"/>
-          </a:lnRef>
-          <a:fillRef idx="3">
-            <a:schemeClr val="accent1"/>
-          </a:fillRef>
-          <a:effectRef idx="2">
-            <a:schemeClr val="accent1"/>
-          </a:effectRef>
-          <a:fontRef idx="minor">
-            <a:schemeClr val="lt1"/>
-          </a:fontRef>
-        </p:style>
-        <p:txBody>
-          <a:bodyPr wrap="square" lIns="45720" rIns="45720" rtlCol="0" anchor="ctr"/>
-          <a:lstStyle/>
-          <a:p>
-            <a:pPr algn="l"/>
-            <a:r>
-              <a:rPr sz="1350" b="1">
-                <a:solidFill>
-                  <a:srgbClr val="2E6DA4"/>
-                </a:solidFill>
-                <a:latin typeface="Arial"/>
-              </a:rPr>
-              <a:t>Phase 1 · Approach / DP</a:t>
-            </a:r>
-          </a:p>
-          <a:p>
-            <a:pPr algn="l"/>
-            <a:r>
-              <a:rPr sz="1100">
-                <a:solidFill>
-                  <a:srgbClr val="333333"/>
-                </a:solidFill>
-                <a:latin typeface="Arial"/>
-              </a:rPr>
-              <a:t>Method : DOB-MPC w RaCBF</a:t>
-            </a:r>
-          </a:p>
-        </p:txBody>
-      </p:sp>
-      <p:cxnSp>
-        <p:nvCxnSpPr>
-          <p:cNvPr id="56" name="Connector 55">
-            <a:extLst>
-              <a:ext uri="{FF2B5EF4-FFF2-40B4-BE49-F238E27FC236}">
-                <a16:creationId xmlns:a16="http://schemas.microsoft.com/office/drawing/2014/main" id="{54173DD8-5377-CE1C-9721-7A58896FF512}"/>
-              </a:ext>
-            </a:extLst>
-          </p:cNvPr>
-          <p:cNvCxnSpPr>
-            <a:cxnSpLocks/>
-            <a:stCxn id="55" idx="0"/>
-          </p:cNvCxnSpPr>
-          <p:nvPr/>
-        </p:nvCxnSpPr>
-        <p:spPr>
-          <a:xfrm flipV="1">
-            <a:off x="3961509" y="2798762"/>
-            <a:ext cx="53894" cy="1381374"/>
-          </a:xfrm>
-          <a:prstGeom prst="line">
-            <a:avLst/>
-          </a:prstGeom>
-          <a:ln w="12700">
-            <a:solidFill>
-              <a:srgbClr val="2E6DA4"/>
-            </a:solidFill>
-          </a:ln>
-        </p:spPr>
-        <p:style>
-          <a:lnRef idx="2">
-            <a:schemeClr val="accent1"/>
-          </a:lnRef>
-          <a:fillRef idx="0">
-            <a:schemeClr val="accent1"/>
-          </a:fillRef>
-          <a:effectRef idx="1">
-            <a:schemeClr val="accent1"/>
-          </a:effectRef>
-          <a:fontRef idx="minor">
-            <a:schemeClr val="tx1"/>
-          </a:fontRef>
-        </p:style>
-      </p:cxnSp>
-      <p:sp>
-        <p:nvSpPr>
-          <p:cNvPr id="57" name="Rounded Rectangle 56">
-            <a:extLst>
-              <a:ext uri="{FF2B5EF4-FFF2-40B4-BE49-F238E27FC236}">
-                <a16:creationId xmlns:a16="http://schemas.microsoft.com/office/drawing/2014/main" id="{AF4B4A3A-D2E5-23BB-30B6-D08550498433}"/>
-              </a:ext>
-            </a:extLst>
-          </p:cNvPr>
-          <p:cNvSpPr/>
-          <p:nvPr/>
-        </p:nvSpPr>
-        <p:spPr>
-          <a:xfrm>
-            <a:off x="6206520" y="4166098"/>
-            <a:ext cx="2646680" cy="658368"/>
-          </a:xfrm>
-          <a:prstGeom prst="roundRect">
-            <a:avLst/>
-          </a:prstGeom>
-          <a:solidFill>
-            <a:srgbClr val="FFFFFF"/>
-          </a:solidFill>
-          <a:ln w="20320">
-            <a:solidFill>
-              <a:srgbClr val="C0392B"/>
-            </a:solidFill>
-          </a:ln>
-        </p:spPr>
-        <p:style>
-          <a:lnRef idx="1">
-            <a:schemeClr val="accent1"/>
-          </a:lnRef>
-          <a:fillRef idx="3">
-            <a:schemeClr val="accent1"/>
-          </a:fillRef>
-          <a:effectRef idx="2">
-            <a:schemeClr val="accent1"/>
-          </a:effectRef>
-          <a:fontRef idx="minor">
-            <a:schemeClr val="lt1"/>
-          </a:fontRef>
-        </p:style>
-        <p:txBody>
-          <a:bodyPr wrap="square" lIns="45720" rIns="45720" rtlCol="0" anchor="ctr"/>
-          <a:lstStyle/>
-          <a:p>
-            <a:pPr algn="l"/>
-            <a:r>
-              <a:rPr sz="1350" b="1">
-                <a:solidFill>
-                  <a:srgbClr val="C0392B"/>
-                </a:solidFill>
-                <a:latin typeface="Arial"/>
-              </a:rPr>
-              <a:t>Phase 2 · Docking</a:t>
-            </a:r>
-          </a:p>
-          <a:p>
-            <a:pPr algn="l"/>
-            <a:r>
-              <a:rPr sz="1100">
-                <a:solidFill>
-                  <a:srgbClr val="333333"/>
-                </a:solidFill>
-                <a:latin typeface="Arial"/>
-              </a:rPr>
-              <a:t>Method : Robust reach avoid RL</a:t>
-            </a:r>
-          </a:p>
-        </p:txBody>
-      </p:sp>
-      <p:cxnSp>
-        <p:nvCxnSpPr>
-          <p:cNvPr id="58" name="Connector 57">
-            <a:extLst>
-              <a:ext uri="{FF2B5EF4-FFF2-40B4-BE49-F238E27FC236}">
-                <a16:creationId xmlns:a16="http://schemas.microsoft.com/office/drawing/2014/main" id="{B95ECA1F-BDEF-A98B-EDA9-BA7F9635612A}"/>
-              </a:ext>
-            </a:extLst>
-          </p:cNvPr>
-          <p:cNvCxnSpPr>
-            <a:cxnSpLocks/>
-            <a:stCxn id="57" idx="0"/>
-          </p:cNvCxnSpPr>
-          <p:nvPr/>
-        </p:nvCxnSpPr>
-        <p:spPr>
-          <a:xfrm flipH="1" flipV="1">
-            <a:off x="6330029" y="2333223"/>
-            <a:ext cx="1199831" cy="1832875"/>
-          </a:xfrm>
-          <a:prstGeom prst="line">
-            <a:avLst/>
-          </a:prstGeom>
-          <a:ln w="12700">
-            <a:solidFill>
-              <a:srgbClr val="C0392B"/>
-            </a:solidFill>
-          </a:ln>
-        </p:spPr>
-        <p:style>
-          <a:lnRef idx="2">
-            <a:schemeClr val="accent1"/>
-          </a:lnRef>
-          <a:fillRef idx="0">
-            <a:schemeClr val="accent1"/>
-          </a:fillRef>
-          <a:effectRef idx="1">
-            <a:schemeClr val="accent1"/>
-          </a:effectRef>
-          <a:fontRef idx="minor">
-            <a:schemeClr val="tx1"/>
-          </a:fontRef>
-        </p:style>
-      </p:cxnSp>
-      <p:pic>
-        <p:nvPicPr>
-          <p:cNvPr id="61" name="그림 60">
-            <a:extLst>
-              <a:ext uri="{FF2B5EF4-FFF2-40B4-BE49-F238E27FC236}">
-                <a16:creationId xmlns:a16="http://schemas.microsoft.com/office/drawing/2014/main" id="{883BAE08-957C-1E71-D49A-D6A98D467135}"/>
-              </a:ext>
-            </a:extLst>
-          </p:cNvPr>
-          <p:cNvPicPr>
-            <a:picLocks noChangeAspect="1"/>
-          </p:cNvPicPr>
-          <p:nvPr/>
-        </p:nvPicPr>
-        <p:blipFill>
-          <a:blip r:embed="rId3"/>
-          <a:srcRect l="3415" t="5994" r="4938" b="66394"/>
-          <a:stretch>
-            <a:fillRect/>
-          </a:stretch>
-        </p:blipFill>
-        <p:spPr>
-          <a:xfrm>
-            <a:off x="4294066" y="398512"/>
-            <a:ext cx="6186746" cy="1242589"/>
-          </a:xfrm>
-          <a:prstGeom prst="rect">
-            <a:avLst/>
-          </a:prstGeom>
-        </p:spPr>
-      </p:pic>
-      <p:pic>
-        <p:nvPicPr>
-          <p:cNvPr id="63" name="그림 62">
-            <a:extLst>
-              <a:ext uri="{FF2B5EF4-FFF2-40B4-BE49-F238E27FC236}">
-                <a16:creationId xmlns:a16="http://schemas.microsoft.com/office/drawing/2014/main" id="{71AE7082-E866-3631-951D-8CDCD1750943}"/>
-              </a:ext>
-            </a:extLst>
-          </p:cNvPr>
-          <p:cNvPicPr>
-            <a:picLocks noChangeAspect="1"/>
-          </p:cNvPicPr>
-          <p:nvPr/>
-        </p:nvPicPr>
-        <p:blipFill>
-          <a:blip r:embed="rId3"/>
-          <a:srcRect l="10392" t="79073" r="57408" b="8050"/>
-          <a:stretch>
-            <a:fillRect/>
-          </a:stretch>
-        </p:blipFill>
-        <p:spPr>
-          <a:xfrm rot="20514241">
-            <a:off x="1642438" y="3627212"/>
-            <a:ext cx="1008240" cy="329871"/>
-          </a:xfrm>
-          <a:prstGeom prst="rect">
-            <a:avLst/>
-          </a:prstGeom>
-        </p:spPr>
-      </p:pic>
-      <p:pic>
-        <p:nvPicPr>
-          <p:cNvPr id="65" name="그림 64">
-            <a:extLst>
-              <a:ext uri="{FF2B5EF4-FFF2-40B4-BE49-F238E27FC236}">
-                <a16:creationId xmlns:a16="http://schemas.microsoft.com/office/drawing/2014/main" id="{93F66D66-3BE8-07A9-831B-46B5EFB8C37C}"/>
-              </a:ext>
-            </a:extLst>
-          </p:cNvPr>
-          <p:cNvPicPr>
-            <a:picLocks noChangeAspect="1"/>
-          </p:cNvPicPr>
-          <p:nvPr/>
-        </p:nvPicPr>
-        <p:blipFill>
-          <a:blip r:embed="rId3"/>
-          <a:srcRect l="10392" t="79073" r="57408" b="8050"/>
-          <a:stretch>
-            <a:fillRect/>
-          </a:stretch>
-        </p:blipFill>
-        <p:spPr>
-          <a:xfrm rot="20594310">
-            <a:off x="3103357" y="2549342"/>
-            <a:ext cx="1008240" cy="329871"/>
-          </a:xfrm>
-          <a:prstGeom prst="rect">
-            <a:avLst/>
-          </a:prstGeom>
-        </p:spPr>
-      </p:pic>
-      <p:pic>
-        <p:nvPicPr>
-          <p:cNvPr id="67" name="그림 66">
-            <a:extLst>
-              <a:ext uri="{FF2B5EF4-FFF2-40B4-BE49-F238E27FC236}">
-                <a16:creationId xmlns:a16="http://schemas.microsoft.com/office/drawing/2014/main" id="{63E96745-3C56-DF2E-2B29-542D44D0CC96}"/>
-              </a:ext>
-            </a:extLst>
-          </p:cNvPr>
-          <p:cNvPicPr>
-            <a:picLocks noChangeAspect="1"/>
-          </p:cNvPicPr>
-          <p:nvPr/>
-        </p:nvPicPr>
-        <p:blipFill>
-          <a:blip r:embed="rId3"/>
-          <a:srcRect l="10392" t="79073" r="57408" b="8050"/>
-          <a:stretch>
-            <a:fillRect/>
-          </a:stretch>
-        </p:blipFill>
-        <p:spPr>
-          <a:xfrm rot="21263084">
-            <a:off x="5843188" y="1916738"/>
-            <a:ext cx="1008240" cy="329871"/>
-          </a:xfrm>
-          <a:prstGeom prst="rect">
-            <a:avLst/>
-          </a:prstGeom>
-        </p:spPr>
-      </p:pic>
-      <p:grpSp>
-        <p:nvGrpSpPr>
-          <p:cNvPr id="128" name="그룹 127">
-            <a:extLst>
-              <a:ext uri="{FF2B5EF4-FFF2-40B4-BE49-F238E27FC236}">
-                <a16:creationId xmlns:a16="http://schemas.microsoft.com/office/drawing/2014/main" id="{EC4D1173-50B8-FB43-9ABD-E5B3C1C6773C}"/>
-              </a:ext>
-            </a:extLst>
-          </p:cNvPr>
-          <p:cNvGrpSpPr/>
-          <p:nvPr/>
-        </p:nvGrpSpPr>
-        <p:grpSpPr>
-          <a:xfrm>
-            <a:off x="8344916" y="2515132"/>
-            <a:ext cx="3538489" cy="1328342"/>
-            <a:chOff x="7619108" y="3018448"/>
-            <a:chExt cx="4374738" cy="1642268"/>
-          </a:xfrm>
-        </p:grpSpPr>
-        <p:sp>
-          <p:nvSpPr>
-            <p:cNvPr id="124" name="사각형: 둥근 모서리 123">
-              <a:extLst>
-                <a:ext uri="{FF2B5EF4-FFF2-40B4-BE49-F238E27FC236}">
-                  <a16:creationId xmlns:a16="http://schemas.microsoft.com/office/drawing/2014/main" id="{0EEBA7F7-2C90-20E4-BFDE-273BCA72CB8A}"/>
-                </a:ext>
-              </a:extLst>
-            </p:cNvPr>
-            <p:cNvSpPr/>
-            <p:nvPr/>
-          </p:nvSpPr>
-          <p:spPr>
-            <a:xfrm>
-              <a:off x="7619108" y="3018448"/>
-              <a:ext cx="4325946" cy="1628953"/>
-            </a:xfrm>
-            <a:prstGeom prst="roundRect">
-              <a:avLst/>
-            </a:prstGeom>
-            <a:noFill/>
-            <a:ln w="19050">
-              <a:solidFill>
-                <a:schemeClr val="tx1"/>
-              </a:solidFill>
-              <a:prstDash val="dash"/>
-            </a:ln>
-            <a:effectLst/>
-          </p:spPr>
-          <p:style>
-            <a:lnRef idx="1">
-              <a:schemeClr val="accent1"/>
-            </a:lnRef>
-            <a:fillRef idx="3">
-              <a:schemeClr val="accent1"/>
-            </a:fillRef>
-            <a:effectRef idx="2">
-              <a:schemeClr val="accent1"/>
-            </a:effectRef>
-            <a:fontRef idx="minor">
-              <a:schemeClr val="lt1"/>
-            </a:fontRef>
-          </p:style>
-          <p:txBody>
-            <a:bodyPr rtlCol="0" anchor="ctr"/>
-            <a:lstStyle/>
-            <a:p>
-              <a:pPr algn="ctr"/>
-              <a:endParaRPr lang="ko-KR" altLang="en-US"/>
-            </a:p>
-          </p:txBody>
-        </p:sp>
-        <p:sp>
-          <p:nvSpPr>
-            <p:cNvPr id="44" name="TextBox 43">
-              <a:extLst>
-                <a:ext uri="{FF2B5EF4-FFF2-40B4-BE49-F238E27FC236}">
-                  <a16:creationId xmlns:a16="http://schemas.microsoft.com/office/drawing/2014/main" id="{638202AF-2449-538A-8694-561A42B05DC2}"/>
-                </a:ext>
-              </a:extLst>
-            </p:cNvPr>
-            <p:cNvSpPr txBox="1"/>
-            <p:nvPr/>
-          </p:nvSpPr>
-          <p:spPr>
-            <a:xfrm>
-              <a:off x="7675879" y="3468445"/>
-              <a:ext cx="1563928" cy="199770"/>
-            </a:xfrm>
-            <a:prstGeom prst="rect">
-              <a:avLst/>
-            </a:prstGeom>
-            <a:noFill/>
-          </p:spPr>
-          <p:txBody>
-            <a:bodyPr wrap="square" lIns="0" tIns="0" rIns="0" bIns="0" anchor="ctr">
-              <a:spAutoFit/>
-            </a:bodyPr>
-            <a:lstStyle/>
-            <a:p>
-              <a:pPr algn="ctr"/>
-              <a:r>
-                <a:rPr sz="1050" b="1" i="1" dirty="0">
-                  <a:solidFill>
-                    <a:srgbClr val="C0392B"/>
-                  </a:solidFill>
-                  <a:latin typeface="Arial"/>
-                </a:rPr>
-                <a:t>side boundary ∈ F</a:t>
-              </a:r>
-            </a:p>
-          </p:txBody>
-        </p:sp>
-        <p:sp>
-          <p:nvSpPr>
-            <p:cNvPr id="51" name="TextBox 50">
-              <a:extLst>
-                <a:ext uri="{FF2B5EF4-FFF2-40B4-BE49-F238E27FC236}">
-                  <a16:creationId xmlns:a16="http://schemas.microsoft.com/office/drawing/2014/main" id="{5FA0D53B-4563-1417-900B-0BEF02EEE23A}"/>
-                </a:ext>
-              </a:extLst>
-            </p:cNvPr>
-            <p:cNvSpPr txBox="1"/>
-            <p:nvPr/>
-          </p:nvSpPr>
-          <p:spPr>
-            <a:xfrm>
-              <a:off x="10256486" y="4203516"/>
-              <a:ext cx="1737360" cy="457200"/>
-            </a:xfrm>
-            <a:prstGeom prst="rect">
-              <a:avLst/>
-            </a:prstGeom>
-            <a:noFill/>
-          </p:spPr>
-          <p:txBody>
-            <a:bodyPr wrap="square" lIns="0" tIns="0" rIns="0" bIns="0" anchor="ctr">
-              <a:spAutoFit/>
-            </a:bodyPr>
-            <a:lstStyle/>
-            <a:p>
-              <a:pPr algn="ctr"/>
-              <a:r>
-                <a:rPr sz="1100" b="1" i="0" dirty="0">
-                  <a:solidFill>
-                    <a:srgbClr val="C0392B"/>
-                  </a:solidFill>
-                  <a:latin typeface="Arial"/>
-                </a:rPr>
-                <a:t>cradle walls  ∈ F</a:t>
-              </a:r>
-            </a:p>
-          </p:txBody>
-        </p:sp>
-        <p:grpSp>
-          <p:nvGrpSpPr>
-            <p:cNvPr id="91" name="그룹 90">
-              <a:extLst>
-                <a:ext uri="{FF2B5EF4-FFF2-40B4-BE49-F238E27FC236}">
-                  <a16:creationId xmlns:a16="http://schemas.microsoft.com/office/drawing/2014/main" id="{F0450F82-CC08-EA1E-8777-9CFA82134FD8}"/>
-                </a:ext>
-              </a:extLst>
-            </p:cNvPr>
-            <p:cNvGrpSpPr/>
-            <p:nvPr/>
-          </p:nvGrpSpPr>
-          <p:grpSpPr>
-            <a:xfrm>
-              <a:off x="9610317" y="3440897"/>
-              <a:ext cx="1772290" cy="871097"/>
-              <a:chOff x="7609842" y="3689133"/>
-              <a:chExt cx="2338830" cy="1149557"/>
-            </a:xfrm>
-          </p:grpSpPr>
-          <p:grpSp>
-            <p:nvGrpSpPr>
-              <p:cNvPr id="89" name="그룹 88">
-                <a:extLst>
-                  <a:ext uri="{FF2B5EF4-FFF2-40B4-BE49-F238E27FC236}">
-                    <a16:creationId xmlns:a16="http://schemas.microsoft.com/office/drawing/2014/main" id="{DBD66AA6-2578-D289-6CCA-E422E1496EF0}"/>
-                  </a:ext>
-                </a:extLst>
-              </p:cNvPr>
-              <p:cNvGrpSpPr/>
-              <p:nvPr/>
-            </p:nvGrpSpPr>
-            <p:grpSpPr>
-              <a:xfrm>
-                <a:off x="7614075" y="3689133"/>
-                <a:ext cx="2334597" cy="1149557"/>
-                <a:chOff x="7447280" y="3841662"/>
-                <a:chExt cx="2334597" cy="1149557"/>
-              </a:xfrm>
-            </p:grpSpPr>
-            <p:pic>
-              <p:nvPicPr>
-                <p:cNvPr id="73" name="그림 72">
-                  <a:extLst>
-                    <a:ext uri="{FF2B5EF4-FFF2-40B4-BE49-F238E27FC236}">
-                      <a16:creationId xmlns:a16="http://schemas.microsoft.com/office/drawing/2014/main" id="{D25F8341-DA89-F3A7-409F-81BFE6AF6937}"/>
-                    </a:ext>
-                  </a:extLst>
-                </p:cNvPr>
-                <p:cNvPicPr>
-                  <a:picLocks noChangeAspect="1"/>
-                </p:cNvPicPr>
-                <p:nvPr/>
-              </p:nvPicPr>
-              <p:blipFill>
-                <a:blip r:embed="rId2"/>
-                <a:srcRect t="20686" b="23574"/>
-                <a:stretch>
-                  <a:fillRect/>
-                </a:stretch>
-              </p:blipFill>
-              <p:spPr>
-                <a:xfrm rot="10800000">
-                  <a:off x="7447280" y="3850128"/>
-                  <a:ext cx="2272876" cy="1141091"/>
-                </a:xfrm>
-                <a:prstGeom prst="rect">
-                  <a:avLst/>
-                </a:prstGeom>
-              </p:spPr>
-            </p:pic>
-            <p:sp>
-              <p:nvSpPr>
-                <p:cNvPr id="87" name="자유형: 도형 86">
-                  <a:extLst>
-                    <a:ext uri="{FF2B5EF4-FFF2-40B4-BE49-F238E27FC236}">
-                      <a16:creationId xmlns:a16="http://schemas.microsoft.com/office/drawing/2014/main" id="{512C4FC6-179E-7D9D-64E8-27A745264EB8}"/>
-                    </a:ext>
-                  </a:extLst>
-                </p:cNvPr>
-                <p:cNvSpPr/>
-                <p:nvPr/>
-              </p:nvSpPr>
-              <p:spPr>
-                <a:xfrm>
-                  <a:off x="7447280" y="3841662"/>
-                  <a:ext cx="2334597" cy="1141092"/>
-                </a:xfrm>
-                <a:custGeom>
-                  <a:avLst/>
-                  <a:gdLst>
-                    <a:gd name="csX0" fmla="*/ 1815251 w 2334597"/>
-                    <a:gd name="csY0" fmla="*/ 0 h 1141092"/>
-                    <a:gd name="csX1" fmla="*/ 2334597 w 2334597"/>
-                    <a:gd name="csY1" fmla="*/ 0 h 1141092"/>
-                    <a:gd name="csX2" fmla="*/ 2334597 w 2334597"/>
-                    <a:gd name="csY2" fmla="*/ 1141092 h 1141092"/>
-                    <a:gd name="csX3" fmla="*/ 2332567 w 2334597"/>
-                    <a:gd name="csY3" fmla="*/ 1141092 h 1141092"/>
-                    <a:gd name="csX4" fmla="*/ 1815251 w 2334597"/>
-                    <a:gd name="csY4" fmla="*/ 1141092 h 1141092"/>
-                    <a:gd name="csX5" fmla="*/ 0 w 2334597"/>
-                    <a:gd name="csY5" fmla="*/ 1141092 h 1141092"/>
-                    <a:gd name="csX6" fmla="*/ 0 w 2334597"/>
-                    <a:gd name="csY6" fmla="*/ 778422 h 1141092"/>
-                    <a:gd name="csX7" fmla="*/ 1815251 w 2334597"/>
-                    <a:gd name="csY7" fmla="*/ 778422 h 1141092"/>
-                    <a:gd name="csX8" fmla="*/ 1815251 w 2334597"/>
-                    <a:gd name="csY8" fmla="*/ 362671 h 1141092"/>
-                    <a:gd name="csX9" fmla="*/ 0 w 2334597"/>
-                    <a:gd name="csY9" fmla="*/ 362671 h 1141092"/>
-                    <a:gd name="csX10" fmla="*/ 0 w 2334597"/>
-                    <a:gd name="csY10" fmla="*/ 1 h 1141092"/>
-                    <a:gd name="csX11" fmla="*/ 1815251 w 2334597"/>
-                    <a:gd name="csY11" fmla="*/ 1 h 1141092"/>
-                  </a:gdLst>
-                  <a:ahLst/>
-                  <a:cxnLst>
-                    <a:cxn ang="0">
-                      <a:pos x="csX0" y="csY0"/>
-                    </a:cxn>
-                    <a:cxn ang="0">
-                      <a:pos x="csX1" y="csY1"/>
-                    </a:cxn>
-                    <a:cxn ang="0">
-                      <a:pos x="csX2" y="csY2"/>
-                    </a:cxn>
-                    <a:cxn ang="0">
-                      <a:pos x="csX3" y="csY3"/>
-                    </a:cxn>
-                    <a:cxn ang="0">
-                      <a:pos x="csX4" y="csY4"/>
-                    </a:cxn>
-                    <a:cxn ang="0">
-                      <a:pos x="csX5" y="csY5"/>
-                    </a:cxn>
-                    <a:cxn ang="0">
-                      <a:pos x="csX6" y="csY6"/>
-                    </a:cxn>
-                    <a:cxn ang="0">
-                      <a:pos x="csX7" y="csY7"/>
-                    </a:cxn>
-                    <a:cxn ang="0">
-                      <a:pos x="csX8" y="csY8"/>
-                    </a:cxn>
-                    <a:cxn ang="0">
-                      <a:pos x="csX9" y="csY9"/>
-                    </a:cxn>
-                    <a:cxn ang="0">
-                      <a:pos x="csX10" y="csY10"/>
-                    </a:cxn>
-                    <a:cxn ang="0">
-                      <a:pos x="csX11" y="csY11"/>
-                    </a:cxn>
-                  </a:cxnLst>
-                  <a:rect l="l" t="t" r="r" b="b"/>
-                  <a:pathLst>
-                    <a:path w="2334597" h="1141092">
-                      <a:moveTo>
-                        <a:pt x="1815251" y="0"/>
-                      </a:moveTo>
-                      <a:lnTo>
-                        <a:pt x="2334597" y="0"/>
-                      </a:lnTo>
-                      <a:lnTo>
-                        <a:pt x="2334597" y="1141092"/>
-                      </a:lnTo>
-                      <a:lnTo>
-                        <a:pt x="2332567" y="1141092"/>
-                      </a:lnTo>
-                      <a:lnTo>
-                        <a:pt x="1815251" y="1141092"/>
-                      </a:lnTo>
-                      <a:lnTo>
-                        <a:pt x="0" y="1141092"/>
-                      </a:lnTo>
-                      <a:lnTo>
-                        <a:pt x="0" y="778422"/>
-                      </a:lnTo>
-                      <a:lnTo>
-                        <a:pt x="1815251" y="778422"/>
-                      </a:lnTo>
-                      <a:lnTo>
-                        <a:pt x="1815251" y="362671"/>
-                      </a:lnTo>
-                      <a:lnTo>
-                        <a:pt x="0" y="362671"/>
-                      </a:lnTo>
-                      <a:lnTo>
-                        <a:pt x="0" y="1"/>
-                      </a:lnTo>
-                      <a:lnTo>
-                        <a:pt x="1815251" y="1"/>
-                      </a:lnTo>
-                      <a:close/>
-                    </a:path>
-                  </a:pathLst>
-                </a:custGeom>
-                <a:solidFill>
-                  <a:schemeClr val="accent6">
-                    <a:lumMod val="40000"/>
-                    <a:lumOff val="60000"/>
-                    <a:alpha val="51000"/>
-                  </a:schemeClr>
-                </a:solidFill>
-                <a:ln>
-                  <a:solidFill>
-                    <a:srgbClr val="FF6600"/>
-                  </a:solidFill>
-                  <a:prstDash val="dash"/>
-                </a:ln>
-              </p:spPr>
-              <p:style>
-                <a:lnRef idx="2">
-                  <a:schemeClr val="dk1"/>
-                </a:lnRef>
-                <a:fillRef idx="1">
-                  <a:schemeClr val="lt1"/>
-                </a:fillRef>
-                <a:effectRef idx="0">
-                  <a:schemeClr val="dk1"/>
-                </a:effectRef>
-                <a:fontRef idx="minor">
-                  <a:schemeClr val="dk1"/>
-                </a:fontRef>
-              </p:style>
-              <p:txBody>
-                <a:bodyPr wrap="square" rtlCol="0" anchor="ctr">
-                  <a:noAutofit/>
-                </a:bodyPr>
-                <a:lstStyle/>
-                <a:p>
-                  <a:pPr algn="ctr"/>
-                  <a:endParaRPr lang="ko-KR" altLang="en-US">
-                    <a:ln w="0"/>
-                    <a:solidFill>
-                      <a:schemeClr val="tx1"/>
-                    </a:solidFill>
-                    <a:effectLst>
-                      <a:outerShdw blurRad="38100" dist="19050" dir="2700000" algn="tl" rotWithShape="0">
-                        <a:schemeClr val="dk1">
-                          <a:alpha val="40000"/>
-                        </a:schemeClr>
-                      </a:outerShdw>
-                    </a:effectLst>
-                  </a:endParaRPr>
-                </a:p>
-              </p:txBody>
-            </p:sp>
-          </p:grpSp>
-          <p:sp>
-            <p:nvSpPr>
-              <p:cNvPr id="90" name="직사각형 89">
-                <a:extLst>
-                  <a:ext uri="{FF2B5EF4-FFF2-40B4-BE49-F238E27FC236}">
-                    <a16:creationId xmlns:a16="http://schemas.microsoft.com/office/drawing/2014/main" id="{6F61FD2A-63A4-591F-7E15-EAE37CC0E3C7}"/>
-                  </a:ext>
-                </a:extLst>
-              </p:cNvPr>
-              <p:cNvSpPr/>
-              <p:nvPr/>
-            </p:nvSpPr>
-            <p:spPr>
-              <a:xfrm>
-                <a:off x="7609842" y="4092811"/>
-                <a:ext cx="1775459" cy="329868"/>
-              </a:xfrm>
-              <a:prstGeom prst="rect">
-                <a:avLst/>
-              </a:prstGeom>
-              <a:solidFill>
-                <a:schemeClr val="accent3">
-                  <a:lumMod val="20000"/>
-                  <a:lumOff val="80000"/>
-                </a:schemeClr>
-              </a:solidFill>
-              <a:ln w="19050">
-                <a:solidFill>
-                  <a:schemeClr val="accent3">
-                    <a:lumMod val="75000"/>
-                  </a:schemeClr>
-                </a:solidFill>
-                <a:prstDash val="sysDot"/>
-              </a:ln>
-            </p:spPr>
-            <p:style>
-              <a:lnRef idx="2">
-                <a:schemeClr val="dk1"/>
-              </a:lnRef>
-              <a:fillRef idx="1">
-                <a:schemeClr val="lt1"/>
-              </a:fillRef>
-              <a:effectRef idx="0">
-                <a:schemeClr val="dk1"/>
-              </a:effectRef>
-              <a:fontRef idx="minor">
-                <a:schemeClr val="dk1"/>
-              </a:fontRef>
-            </p:style>
-            <p:txBody>
-              <a:bodyPr rtlCol="0" anchor="ctr"/>
-              <a:lstStyle/>
-              <a:p>
-                <a:pPr algn="ctr"/>
-                <a:endParaRPr lang="ko-KR" altLang="en-US"/>
-              </a:p>
-            </p:txBody>
-          </p:sp>
-        </p:grpSp>
-        <p:grpSp>
-          <p:nvGrpSpPr>
-            <p:cNvPr id="94" name="그룹 93">
-              <a:extLst>
-                <a:ext uri="{FF2B5EF4-FFF2-40B4-BE49-F238E27FC236}">
-                  <a16:creationId xmlns:a16="http://schemas.microsoft.com/office/drawing/2014/main" id="{C8146ABF-E913-B1AB-2CDA-32CA10753CB8}"/>
-                </a:ext>
-              </a:extLst>
-            </p:cNvPr>
-            <p:cNvGrpSpPr/>
-            <p:nvPr/>
-          </p:nvGrpSpPr>
-          <p:grpSpPr>
-            <a:xfrm rot="21238330">
-              <a:off x="8452894" y="3780929"/>
-              <a:ext cx="1185669" cy="387770"/>
-              <a:chOff x="6083109" y="4170560"/>
-              <a:chExt cx="1564687" cy="511727"/>
-            </a:xfrm>
-          </p:grpSpPr>
-          <p:pic>
-            <p:nvPicPr>
-              <p:cNvPr id="82" name="그림 81">
-                <a:extLst>
-                  <a:ext uri="{FF2B5EF4-FFF2-40B4-BE49-F238E27FC236}">
-                    <a16:creationId xmlns:a16="http://schemas.microsoft.com/office/drawing/2014/main" id="{A6CF955F-5F3C-4C05-0B43-7FFE00BE1A7D}"/>
-                  </a:ext>
-                </a:extLst>
-              </p:cNvPr>
-              <p:cNvPicPr>
-                <a:picLocks noChangeAspect="1"/>
-              </p:cNvPicPr>
-              <p:nvPr/>
-            </p:nvPicPr>
-            <p:blipFill>
-              <a:blip r:embed="rId3"/>
-              <a:srcRect l="10392" t="79073" r="57408" b="8050"/>
-              <a:stretch>
-                <a:fillRect/>
-              </a:stretch>
-            </p:blipFill>
-            <p:spPr>
-              <a:xfrm rot="21278377">
-                <a:off x="6083109" y="4170560"/>
-                <a:ext cx="1564077" cy="511727"/>
-              </a:xfrm>
-              <a:prstGeom prst="rect">
-                <a:avLst/>
-              </a:prstGeom>
-            </p:spPr>
-          </p:pic>
-          <p:sp>
-            <p:nvSpPr>
-              <p:cNvPr id="93" name="타원 92">
-                <a:extLst>
-                  <a:ext uri="{FF2B5EF4-FFF2-40B4-BE49-F238E27FC236}">
-                    <a16:creationId xmlns:a16="http://schemas.microsoft.com/office/drawing/2014/main" id="{346891C5-9981-E578-9C5D-045380BD025B}"/>
-                  </a:ext>
-                </a:extLst>
-              </p:cNvPr>
-              <p:cNvSpPr/>
-              <p:nvPr/>
-            </p:nvSpPr>
-            <p:spPr>
-              <a:xfrm flipH="1">
-                <a:off x="7573423" y="4308006"/>
-                <a:ext cx="74373" cy="74373"/>
-              </a:xfrm>
-              <a:prstGeom prst="ellipse">
-                <a:avLst/>
-              </a:prstGeom>
-              <a:solidFill>
-                <a:schemeClr val="accent5">
-                  <a:lumMod val="40000"/>
-                  <a:lumOff val="60000"/>
-                </a:schemeClr>
-              </a:solidFill>
-              <a:ln>
-                <a:solidFill>
-                  <a:schemeClr val="accent1"/>
-                </a:solidFill>
-              </a:ln>
-            </p:spPr>
-            <p:style>
-              <a:lnRef idx="2">
-                <a:schemeClr val="dk1"/>
-              </a:lnRef>
-              <a:fillRef idx="1">
-                <a:schemeClr val="lt1"/>
-              </a:fillRef>
-              <a:effectRef idx="0">
-                <a:schemeClr val="dk1"/>
-              </a:effectRef>
-              <a:fontRef idx="minor">
-                <a:schemeClr val="dk1"/>
-              </a:fontRef>
-            </p:style>
-            <p:txBody>
-              <a:bodyPr rtlCol="0" anchor="ctr"/>
-              <a:lstStyle/>
-              <a:p>
-                <a:pPr algn="ctr"/>
-                <a:endParaRPr lang="ko-KR" altLang="en-US"/>
-              </a:p>
-            </p:txBody>
-          </p:sp>
-        </p:grpSp>
-        <p:cxnSp>
-          <p:nvCxnSpPr>
-            <p:cNvPr id="97" name="Connector 9">
-              <a:extLst>
-                <a:ext uri="{FF2B5EF4-FFF2-40B4-BE49-F238E27FC236}">
-                  <a16:creationId xmlns:a16="http://schemas.microsoft.com/office/drawing/2014/main" id="{E275C861-9756-3EF4-6723-7A70B679B381}"/>
-                </a:ext>
-              </a:extLst>
-            </p:cNvPr>
-            <p:cNvCxnSpPr>
-              <a:cxnSpLocks/>
-            </p:cNvCxnSpPr>
-            <p:nvPr/>
-          </p:nvCxnSpPr>
-          <p:spPr>
-            <a:xfrm>
-              <a:off x="7899150" y="3440897"/>
-              <a:ext cx="1670666" cy="0"/>
-            </a:xfrm>
-            <a:prstGeom prst="line">
-              <a:avLst/>
-            </a:prstGeom>
-            <a:ln w="25400">
-              <a:solidFill>
-                <a:srgbClr val="FF6600"/>
-              </a:solidFill>
-              <a:prstDash val="dash"/>
-            </a:ln>
-            <a:effectLst/>
-          </p:spPr>
-          <p:style>
-            <a:lnRef idx="1">
-              <a:schemeClr val="dk1"/>
-            </a:lnRef>
-            <a:fillRef idx="0">
-              <a:schemeClr val="dk1"/>
-            </a:fillRef>
-            <a:effectRef idx="0">
-              <a:schemeClr val="dk1"/>
-            </a:effectRef>
-            <a:fontRef idx="minor">
-              <a:schemeClr val="tx1"/>
-            </a:fontRef>
-          </p:style>
-        </p:cxnSp>
-        <p:cxnSp>
-          <p:nvCxnSpPr>
-            <p:cNvPr id="103" name="Connector 9">
-              <a:extLst>
-                <a:ext uri="{FF2B5EF4-FFF2-40B4-BE49-F238E27FC236}">
-                  <a16:creationId xmlns:a16="http://schemas.microsoft.com/office/drawing/2014/main" id="{EE2B2BC7-052D-8386-057B-7CFE4FB23CFD}"/>
-                </a:ext>
-              </a:extLst>
-            </p:cNvPr>
-            <p:cNvCxnSpPr>
-              <a:cxnSpLocks/>
-            </p:cNvCxnSpPr>
-            <p:nvPr/>
-          </p:nvCxnSpPr>
-          <p:spPr>
-            <a:xfrm>
-              <a:off x="11419059" y="3440897"/>
-              <a:ext cx="337264" cy="0"/>
-            </a:xfrm>
-            <a:prstGeom prst="line">
-              <a:avLst/>
-            </a:prstGeom>
-            <a:ln w="25400">
-              <a:solidFill>
-                <a:srgbClr val="FF6600"/>
-              </a:solidFill>
-              <a:prstDash val="dash"/>
-            </a:ln>
-            <a:effectLst/>
-          </p:spPr>
-          <p:style>
-            <a:lnRef idx="1">
-              <a:schemeClr val="dk1"/>
-            </a:lnRef>
-            <a:fillRef idx="0">
-              <a:schemeClr val="dk1"/>
-            </a:fillRef>
-            <a:effectRef idx="0">
-              <a:schemeClr val="dk1"/>
-            </a:effectRef>
-            <a:fontRef idx="minor">
-              <a:schemeClr val="tx1"/>
-            </a:fontRef>
-          </p:style>
-        </p:cxnSp>
-        <p:sp>
-          <p:nvSpPr>
-            <p:cNvPr id="106" name="Rectangle 8">
-              <a:extLst>
-                <a:ext uri="{FF2B5EF4-FFF2-40B4-BE49-F238E27FC236}">
-                  <a16:creationId xmlns:a16="http://schemas.microsoft.com/office/drawing/2014/main" id="{D63A9DB3-3BF9-CD46-3B75-88998D35A639}"/>
-                </a:ext>
-              </a:extLst>
-            </p:cNvPr>
-            <p:cNvSpPr/>
-            <p:nvPr/>
-          </p:nvSpPr>
-          <p:spPr>
-            <a:xfrm>
-              <a:off x="7807841" y="3361380"/>
-              <a:ext cx="3948481" cy="72140"/>
-            </a:xfrm>
-            <a:prstGeom prst="rect">
-              <a:avLst/>
-            </a:prstGeom>
-            <a:solidFill>
-              <a:srgbClr val="FBE9DA"/>
             </a:solidFill>
             <a:ln>
               <a:noFill/>
@@ -7806,114 +6660,1628 @@
             </a:p>
           </p:txBody>
         </p:sp>
-        <p:pic>
-          <p:nvPicPr>
-            <p:cNvPr id="127" name="그림 126">
+      </p:grpSp>
+      <p:sp>
+        <p:nvSpPr>
+          <p:cNvPr id="18" name="TextBox 17">
+            <a:extLst>
+              <a:ext uri="{FF2B5EF4-FFF2-40B4-BE49-F238E27FC236}">
+                <a16:creationId xmlns:a16="http://schemas.microsoft.com/office/drawing/2014/main" id="{768AE48A-56F4-CDFC-A775-B2385DC65CDA}"/>
+              </a:ext>
+            </a:extLst>
+          </p:cNvPr>
+          <p:cNvSpPr txBox="1"/>
+          <p:nvPr/>
+        </p:nvSpPr>
+        <p:spPr>
+          <a:xfrm>
+            <a:off x="4448780" y="2420093"/>
+            <a:ext cx="1645920" cy="161583"/>
+          </a:xfrm>
+          <a:prstGeom prst="rect">
+            <a:avLst/>
+          </a:prstGeom>
+          <a:noFill/>
+        </p:spPr>
+        <p:txBody>
+          <a:bodyPr wrap="square" lIns="0" tIns="0" rIns="0" bIns="0" anchor="ctr">
+            <a:spAutoFit/>
+          </a:bodyPr>
+          <a:lstStyle/>
+          <a:p>
+            <a:pPr algn="ctr"/>
+            <a:r>
+              <a:rPr sz="1050" b="1" i="0" dirty="0">
+                <a:solidFill>
+                  <a:srgbClr val="2E6DA4"/>
+                </a:solidFill>
+                <a:latin typeface="Arial"/>
+              </a:rPr>
+              <a:t>DP point</a:t>
+            </a:r>
+          </a:p>
+        </p:txBody>
+      </p:sp>
+      <p:sp>
+        <p:nvSpPr>
+          <p:cNvPr id="55" name="Rounded Rectangle 54">
+            <a:extLst>
+              <a:ext uri="{FF2B5EF4-FFF2-40B4-BE49-F238E27FC236}">
+                <a16:creationId xmlns:a16="http://schemas.microsoft.com/office/drawing/2014/main" id="{D9E1E059-E28D-B350-AA21-08D97FA463EC}"/>
+              </a:ext>
+            </a:extLst>
+          </p:cNvPr>
+          <p:cNvSpPr/>
+          <p:nvPr/>
+        </p:nvSpPr>
+        <p:spPr>
+          <a:xfrm>
+            <a:off x="2233542" y="4197266"/>
+            <a:ext cx="2646680" cy="658368"/>
+          </a:xfrm>
+          <a:prstGeom prst="roundRect">
+            <a:avLst/>
+          </a:prstGeom>
+          <a:solidFill>
+            <a:srgbClr val="FFFFFF"/>
+          </a:solidFill>
+          <a:ln w="20320">
+            <a:solidFill>
+              <a:srgbClr val="2E6DA4"/>
+            </a:solidFill>
+          </a:ln>
+        </p:spPr>
+        <p:style>
+          <a:lnRef idx="1">
+            <a:schemeClr val="accent1"/>
+          </a:lnRef>
+          <a:fillRef idx="3">
+            <a:schemeClr val="accent1"/>
+          </a:fillRef>
+          <a:effectRef idx="2">
+            <a:schemeClr val="accent1"/>
+          </a:effectRef>
+          <a:fontRef idx="minor">
+            <a:schemeClr val="lt1"/>
+          </a:fontRef>
+        </p:style>
+        <p:txBody>
+          <a:bodyPr wrap="square" lIns="45720" rIns="45720" rtlCol="0" anchor="ctr"/>
+          <a:lstStyle/>
+          <a:p>
+            <a:pPr algn="l"/>
+            <a:r>
+              <a:rPr sz="1350" b="1">
+                <a:solidFill>
+                  <a:srgbClr val="2E6DA4"/>
+                </a:solidFill>
+                <a:latin typeface="Arial"/>
+              </a:rPr>
+              <a:t>Phase 1 · Approach / DP</a:t>
+            </a:r>
+          </a:p>
+          <a:p>
+            <a:pPr algn="l"/>
+            <a:r>
+              <a:rPr sz="1100">
+                <a:solidFill>
+                  <a:srgbClr val="333333"/>
+                </a:solidFill>
+                <a:latin typeface="Arial"/>
+              </a:rPr>
+              <a:t>Method : DOB-MPC w RaCBF</a:t>
+            </a:r>
+          </a:p>
+        </p:txBody>
+      </p:sp>
+      <p:cxnSp>
+        <p:nvCxnSpPr>
+          <p:cNvPr id="56" name="Connector 55">
+            <a:extLst>
+              <a:ext uri="{FF2B5EF4-FFF2-40B4-BE49-F238E27FC236}">
+                <a16:creationId xmlns:a16="http://schemas.microsoft.com/office/drawing/2014/main" id="{54173DD8-5377-CE1C-9721-7A58896FF512}"/>
+              </a:ext>
+            </a:extLst>
+          </p:cNvPr>
+          <p:cNvCxnSpPr>
+            <a:cxnSpLocks/>
+            <a:stCxn id="55" idx="0"/>
+          </p:cNvCxnSpPr>
+          <p:nvPr/>
+        </p:nvCxnSpPr>
+        <p:spPr>
+          <a:xfrm flipH="1" flipV="1">
+            <a:off x="3250141" y="3129422"/>
+            <a:ext cx="306741" cy="1067844"/>
+          </a:xfrm>
+          <a:prstGeom prst="line">
+            <a:avLst/>
+          </a:prstGeom>
+          <a:ln w="12700">
+            <a:solidFill>
+              <a:srgbClr val="2E6DA4"/>
+            </a:solidFill>
+          </a:ln>
+        </p:spPr>
+        <p:style>
+          <a:lnRef idx="2">
+            <a:schemeClr val="accent1"/>
+          </a:lnRef>
+          <a:fillRef idx="0">
+            <a:schemeClr val="accent1"/>
+          </a:fillRef>
+          <a:effectRef idx="1">
+            <a:schemeClr val="accent1"/>
+          </a:effectRef>
+          <a:fontRef idx="minor">
+            <a:schemeClr val="tx1"/>
+          </a:fontRef>
+        </p:style>
+      </p:cxnSp>
+      <p:sp>
+        <p:nvSpPr>
+          <p:cNvPr id="57" name="Rounded Rectangle 56">
+            <a:extLst>
+              <a:ext uri="{FF2B5EF4-FFF2-40B4-BE49-F238E27FC236}">
+                <a16:creationId xmlns:a16="http://schemas.microsoft.com/office/drawing/2014/main" id="{AF4B4A3A-D2E5-23BB-30B6-D08550498433}"/>
+              </a:ext>
+            </a:extLst>
+          </p:cNvPr>
+          <p:cNvSpPr/>
+          <p:nvPr/>
+        </p:nvSpPr>
+        <p:spPr>
+          <a:xfrm>
+            <a:off x="5716840" y="4105510"/>
+            <a:ext cx="2646680" cy="658368"/>
+          </a:xfrm>
+          <a:prstGeom prst="roundRect">
+            <a:avLst/>
+          </a:prstGeom>
+          <a:solidFill>
+            <a:srgbClr val="FFFFFF"/>
+          </a:solidFill>
+          <a:ln w="20320">
+            <a:solidFill>
+              <a:srgbClr val="C0392B"/>
+            </a:solidFill>
+          </a:ln>
+        </p:spPr>
+        <p:style>
+          <a:lnRef idx="1">
+            <a:schemeClr val="accent1"/>
+          </a:lnRef>
+          <a:fillRef idx="3">
+            <a:schemeClr val="accent1"/>
+          </a:fillRef>
+          <a:effectRef idx="2">
+            <a:schemeClr val="accent1"/>
+          </a:effectRef>
+          <a:fontRef idx="minor">
+            <a:schemeClr val="lt1"/>
+          </a:fontRef>
+        </p:style>
+        <p:txBody>
+          <a:bodyPr wrap="square" lIns="45720" rIns="45720" rtlCol="0" anchor="ctr"/>
+          <a:lstStyle/>
+          <a:p>
+            <a:pPr algn="l"/>
+            <a:r>
+              <a:rPr sz="1350" b="1">
+                <a:solidFill>
+                  <a:srgbClr val="C0392B"/>
+                </a:solidFill>
+                <a:latin typeface="Arial"/>
+              </a:rPr>
+              <a:t>Phase 2 · Docking</a:t>
+            </a:r>
+          </a:p>
+          <a:p>
+            <a:pPr algn="l"/>
+            <a:r>
+              <a:rPr sz="1100">
+                <a:solidFill>
+                  <a:srgbClr val="333333"/>
+                </a:solidFill>
+                <a:latin typeface="Arial"/>
+              </a:rPr>
+              <a:t>Method : Robust reach avoid RL</a:t>
+            </a:r>
+          </a:p>
+        </p:txBody>
+      </p:sp>
+      <p:cxnSp>
+        <p:nvCxnSpPr>
+          <p:cNvPr id="58" name="Connector 57">
+            <a:extLst>
+              <a:ext uri="{FF2B5EF4-FFF2-40B4-BE49-F238E27FC236}">
+                <a16:creationId xmlns:a16="http://schemas.microsoft.com/office/drawing/2014/main" id="{B95ECA1F-BDEF-A98B-EDA9-BA7F9635612A}"/>
+              </a:ext>
+            </a:extLst>
+          </p:cNvPr>
+          <p:cNvCxnSpPr>
+            <a:cxnSpLocks/>
+            <a:stCxn id="57" idx="0"/>
+          </p:cNvCxnSpPr>
+          <p:nvPr/>
+        </p:nvCxnSpPr>
+        <p:spPr>
+          <a:xfrm flipH="1" flipV="1">
+            <a:off x="6163869" y="2377626"/>
+            <a:ext cx="876311" cy="1727884"/>
+          </a:xfrm>
+          <a:prstGeom prst="line">
+            <a:avLst/>
+          </a:prstGeom>
+          <a:ln w="12700">
+            <a:solidFill>
+              <a:srgbClr val="C0392B"/>
+            </a:solidFill>
+          </a:ln>
+        </p:spPr>
+        <p:style>
+          <a:lnRef idx="2">
+            <a:schemeClr val="accent1"/>
+          </a:lnRef>
+          <a:fillRef idx="0">
+            <a:schemeClr val="accent1"/>
+          </a:fillRef>
+          <a:effectRef idx="1">
+            <a:schemeClr val="accent1"/>
+          </a:effectRef>
+          <a:fontRef idx="minor">
+            <a:schemeClr val="tx1"/>
+          </a:fontRef>
+        </p:style>
+      </p:cxnSp>
+      <p:pic>
+        <p:nvPicPr>
+          <p:cNvPr id="61" name="그림 60">
+            <a:extLst>
+              <a:ext uri="{FF2B5EF4-FFF2-40B4-BE49-F238E27FC236}">
+                <a16:creationId xmlns:a16="http://schemas.microsoft.com/office/drawing/2014/main" id="{883BAE08-957C-1E71-D49A-D6A98D467135}"/>
+              </a:ext>
+            </a:extLst>
+          </p:cNvPr>
+          <p:cNvPicPr>
+            <a:picLocks noChangeAspect="1"/>
+          </p:cNvPicPr>
+          <p:nvPr/>
+        </p:nvPicPr>
+        <p:blipFill>
+          <a:blip r:embed="rId3"/>
+          <a:srcRect l="3415" t="5994" r="4938" b="66394"/>
+          <a:stretch>
+            <a:fillRect/>
+          </a:stretch>
+        </p:blipFill>
+        <p:spPr>
+          <a:xfrm>
+            <a:off x="4294066" y="398512"/>
+            <a:ext cx="6186746" cy="1242589"/>
+          </a:xfrm>
+          <a:prstGeom prst="rect">
+            <a:avLst/>
+          </a:prstGeom>
+        </p:spPr>
+      </p:pic>
+      <p:pic>
+        <p:nvPicPr>
+          <p:cNvPr id="63" name="그림 62">
+            <a:extLst>
+              <a:ext uri="{FF2B5EF4-FFF2-40B4-BE49-F238E27FC236}">
+                <a16:creationId xmlns:a16="http://schemas.microsoft.com/office/drawing/2014/main" id="{71AE7082-E866-3631-951D-8CDCD1750943}"/>
+              </a:ext>
+            </a:extLst>
+          </p:cNvPr>
+          <p:cNvPicPr>
+            <a:picLocks noChangeAspect="1"/>
+          </p:cNvPicPr>
+          <p:nvPr/>
+        </p:nvPicPr>
+        <p:blipFill>
+          <a:blip r:embed="rId3"/>
+          <a:srcRect l="10392" t="79073" r="57408" b="8050"/>
+          <a:stretch>
+            <a:fillRect/>
+          </a:stretch>
+        </p:blipFill>
+        <p:spPr>
+          <a:xfrm rot="20514241">
+            <a:off x="1642438" y="3627212"/>
+            <a:ext cx="1008240" cy="329871"/>
+          </a:xfrm>
+          <a:prstGeom prst="rect">
+            <a:avLst/>
+          </a:prstGeom>
+        </p:spPr>
+      </p:pic>
+      <p:pic>
+        <p:nvPicPr>
+          <p:cNvPr id="65" name="그림 64">
+            <a:extLst>
+              <a:ext uri="{FF2B5EF4-FFF2-40B4-BE49-F238E27FC236}">
+                <a16:creationId xmlns:a16="http://schemas.microsoft.com/office/drawing/2014/main" id="{93F66D66-3BE8-07A9-831B-46B5EFB8C37C}"/>
+              </a:ext>
+            </a:extLst>
+          </p:cNvPr>
+          <p:cNvPicPr>
+            <a:picLocks noChangeAspect="1"/>
+          </p:cNvPicPr>
+          <p:nvPr/>
+        </p:nvPicPr>
+        <p:blipFill>
+          <a:blip r:embed="rId3"/>
+          <a:srcRect l="10392" t="79073" r="57408" b="8050"/>
+          <a:stretch>
+            <a:fillRect/>
+          </a:stretch>
+        </p:blipFill>
+        <p:spPr>
+          <a:xfrm rot="20594310">
+            <a:off x="3103357" y="2549342"/>
+            <a:ext cx="1008240" cy="329871"/>
+          </a:xfrm>
+          <a:prstGeom prst="rect">
+            <a:avLst/>
+          </a:prstGeom>
+        </p:spPr>
+      </p:pic>
+      <p:pic>
+        <p:nvPicPr>
+          <p:cNvPr id="67" name="그림 66">
+            <a:extLst>
+              <a:ext uri="{FF2B5EF4-FFF2-40B4-BE49-F238E27FC236}">
+                <a16:creationId xmlns:a16="http://schemas.microsoft.com/office/drawing/2014/main" id="{63E96745-3C56-DF2E-2B29-542D44D0CC96}"/>
+              </a:ext>
+            </a:extLst>
+          </p:cNvPr>
+          <p:cNvPicPr>
+            <a:picLocks noChangeAspect="1"/>
+          </p:cNvPicPr>
+          <p:nvPr/>
+        </p:nvPicPr>
+        <p:blipFill>
+          <a:blip r:embed="rId3"/>
+          <a:srcRect l="10392" t="79073" r="57408" b="8050"/>
+          <a:stretch>
+            <a:fillRect/>
+          </a:stretch>
+        </p:blipFill>
+        <p:spPr>
+          <a:xfrm rot="21263084">
+            <a:off x="5843188" y="1916738"/>
+            <a:ext cx="1008240" cy="329871"/>
+          </a:xfrm>
+          <a:prstGeom prst="rect">
+            <a:avLst/>
+          </a:prstGeom>
+        </p:spPr>
+      </p:pic>
+      <p:sp>
+        <p:nvSpPr>
+          <p:cNvPr id="5" name="5-Point Star 28">
+            <a:extLst>
+              <a:ext uri="{FF2B5EF4-FFF2-40B4-BE49-F238E27FC236}">
+                <a16:creationId xmlns:a16="http://schemas.microsoft.com/office/drawing/2014/main" id="{38B5A19D-B33C-CF49-3238-0AEFE048C768}"/>
+              </a:ext>
+            </a:extLst>
+          </p:cNvPr>
+          <p:cNvSpPr/>
+          <p:nvPr/>
+        </p:nvSpPr>
+        <p:spPr>
+          <a:xfrm>
+            <a:off x="7387438" y="1918710"/>
+            <a:ext cx="181368" cy="181368"/>
+          </a:xfrm>
+          <a:prstGeom prst="star5">
+            <a:avLst/>
+          </a:prstGeom>
+          <a:solidFill>
+            <a:srgbClr val="C0392B"/>
+          </a:solidFill>
+          <a:ln>
+            <a:noFill/>
+          </a:ln>
+          <a:effectLst/>
+        </p:spPr>
+        <p:style>
+          <a:lnRef idx="1">
+            <a:schemeClr val="accent1"/>
+          </a:lnRef>
+          <a:fillRef idx="3">
+            <a:schemeClr val="accent1"/>
+          </a:fillRef>
+          <a:effectRef idx="2">
+            <a:schemeClr val="accent1"/>
+          </a:effectRef>
+          <a:fontRef idx="minor">
+            <a:schemeClr val="lt1"/>
+          </a:fontRef>
+        </p:style>
+        <p:txBody>
+          <a:bodyPr rtlCol="0" anchor="ctr"/>
+          <a:lstStyle/>
+          <a:p>
+            <a:pPr algn="ctr"/>
+            <a:endParaRPr/>
+          </a:p>
+        </p:txBody>
+      </p:sp>
+      <p:sp>
+        <p:nvSpPr>
+          <p:cNvPr id="11" name="TextBox 10">
+            <a:extLst>
+              <a:ext uri="{FF2B5EF4-FFF2-40B4-BE49-F238E27FC236}">
+                <a16:creationId xmlns:a16="http://schemas.microsoft.com/office/drawing/2014/main" id="{BB00DDFE-266B-C89A-159A-F3786E6FA098}"/>
+              </a:ext>
+            </a:extLst>
+          </p:cNvPr>
+          <p:cNvSpPr txBox="1"/>
+          <p:nvPr/>
+        </p:nvSpPr>
+        <p:spPr>
+          <a:xfrm>
+            <a:off x="6983533" y="2336647"/>
+            <a:ext cx="1072333" cy="161583"/>
+          </a:xfrm>
+          <a:prstGeom prst="rect">
+            <a:avLst/>
+          </a:prstGeom>
+          <a:noFill/>
+        </p:spPr>
+        <p:txBody>
+          <a:bodyPr wrap="square" lIns="0" tIns="0" rIns="0" bIns="0" anchor="ctr">
+            <a:spAutoFit/>
+          </a:bodyPr>
+          <a:lstStyle/>
+          <a:p>
+            <a:pPr algn="ctr"/>
+            <a:r>
+              <a:rPr lang="en-US" sz="1050" b="1" i="0" dirty="0">
+                <a:solidFill>
+                  <a:srgbClr val="C0392B"/>
+                </a:solidFill>
+                <a:latin typeface="Arial"/>
+              </a:rPr>
+              <a:t>C</a:t>
+            </a:r>
+            <a:r>
+              <a:rPr sz="1050" b="1" i="0" dirty="0">
+                <a:solidFill>
+                  <a:srgbClr val="C0392B"/>
+                </a:solidFill>
+                <a:latin typeface="Arial"/>
+              </a:rPr>
+              <a:t>radle center</a:t>
+            </a:r>
+          </a:p>
+        </p:txBody>
+      </p:sp>
+      <p:grpSp>
+        <p:nvGrpSpPr>
+          <p:cNvPr id="23" name="그룹 22">
+            <a:extLst>
+              <a:ext uri="{FF2B5EF4-FFF2-40B4-BE49-F238E27FC236}">
+                <a16:creationId xmlns:a16="http://schemas.microsoft.com/office/drawing/2014/main" id="{775D8C7B-4C79-EB61-F916-B4080EA2B54C}"/>
+              </a:ext>
+            </a:extLst>
+          </p:cNvPr>
+          <p:cNvGrpSpPr/>
+          <p:nvPr/>
+        </p:nvGrpSpPr>
+        <p:grpSpPr>
+          <a:xfrm>
+            <a:off x="8167992" y="2425199"/>
+            <a:ext cx="4679957" cy="1681164"/>
+            <a:chOff x="8167992" y="2460759"/>
+            <a:chExt cx="4679957" cy="1681164"/>
+          </a:xfrm>
+        </p:grpSpPr>
+        <p:grpSp>
+          <p:nvGrpSpPr>
+            <p:cNvPr id="128" name="그룹 127">
               <a:extLst>
                 <a:ext uri="{FF2B5EF4-FFF2-40B4-BE49-F238E27FC236}">
-                  <a16:creationId xmlns:a16="http://schemas.microsoft.com/office/drawing/2014/main" id="{9490E217-03EE-92A6-AFB3-CC4D16E14C1C}"/>
+                  <a16:creationId xmlns:a16="http://schemas.microsoft.com/office/drawing/2014/main" id="{EC4D1173-50B8-FB43-9ABD-E5B3C1C6773C}"/>
                 </a:ext>
               </a:extLst>
             </p:cNvPr>
-            <p:cNvPicPr>
-              <a:picLocks noChangeAspect="1"/>
-            </p:cNvPicPr>
+            <p:cNvGrpSpPr/>
             <p:nvPr/>
-          </p:nvPicPr>
-          <p:blipFill>
-            <a:blip r:embed="rId3"/>
-            <a:srcRect l="10016" t="25048" r="29812" b="66394"/>
-            <a:stretch>
-              <a:fillRect/>
-            </a:stretch>
-          </p:blipFill>
-          <p:spPr>
+          </p:nvGrpSpPr>
+          <p:grpSpPr>
             <a:xfrm>
-              <a:off x="7619108" y="3028205"/>
-              <a:ext cx="4325946" cy="410168"/>
+              <a:off x="8167992" y="2460759"/>
+              <a:ext cx="3892338" cy="1449329"/>
+              <a:chOff x="7619108" y="3018448"/>
+              <a:chExt cx="4374738" cy="1628953"/>
             </a:xfrm>
-            <a:custGeom>
-              <a:avLst/>
-              <a:gdLst>
-                <a:gd name="csX0" fmla="*/ 271498 w 4325946"/>
-                <a:gd name="csY0" fmla="*/ 0 h 410168"/>
-                <a:gd name="csX1" fmla="*/ 4054448 w 4325946"/>
-                <a:gd name="csY1" fmla="*/ 0 h 410168"/>
-                <a:gd name="csX2" fmla="*/ 4325946 w 4325946"/>
-                <a:gd name="csY2" fmla="*/ 271498 h 410168"/>
-                <a:gd name="csX3" fmla="*/ 4325946 w 4325946"/>
-                <a:gd name="csY3" fmla="*/ 410168 h 410168"/>
-                <a:gd name="csX4" fmla="*/ 0 w 4325946"/>
-                <a:gd name="csY4" fmla="*/ 410168 h 410168"/>
-                <a:gd name="csX5" fmla="*/ 0 w 4325946"/>
-                <a:gd name="csY5" fmla="*/ 271498 h 410168"/>
-                <a:gd name="csX6" fmla="*/ 271498 w 4325946"/>
-                <a:gd name="csY6" fmla="*/ 0 h 410168"/>
-              </a:gdLst>
-              <a:ahLst/>
-              <a:cxnLst>
-                <a:cxn ang="0">
-                  <a:pos x="csX0" y="csY0"/>
-                </a:cxn>
-                <a:cxn ang="0">
-                  <a:pos x="csX1" y="csY1"/>
-                </a:cxn>
-                <a:cxn ang="0">
-                  <a:pos x="csX2" y="csY2"/>
-                </a:cxn>
-                <a:cxn ang="0">
-                  <a:pos x="csX3" y="csY3"/>
-                </a:cxn>
-                <a:cxn ang="0">
-                  <a:pos x="csX4" y="csY4"/>
-                </a:cxn>
-                <a:cxn ang="0">
-                  <a:pos x="csX5" y="csY5"/>
-                </a:cxn>
-                <a:cxn ang="0">
-                  <a:pos x="csX6" y="csY6"/>
-                </a:cxn>
-              </a:cxnLst>
-              <a:rect l="l" t="t" r="r" b="b"/>
-              <a:pathLst>
-                <a:path w="4325946" h="410168">
-                  <a:moveTo>
-                    <a:pt x="271498" y="0"/>
-                  </a:moveTo>
-                  <a:lnTo>
-                    <a:pt x="4054448" y="0"/>
-                  </a:lnTo>
-                  <a:cubicBezTo>
-                    <a:pt x="4204392" y="0"/>
-                    <a:pt x="4325946" y="121554"/>
-                    <a:pt x="4325946" y="271498"/>
-                  </a:cubicBezTo>
-                  <a:lnTo>
-                    <a:pt x="4325946" y="410168"/>
-                  </a:lnTo>
-                  <a:lnTo>
-                    <a:pt x="0" y="410168"/>
-                  </a:lnTo>
-                  <a:lnTo>
-                    <a:pt x="0" y="271498"/>
-                  </a:lnTo>
-                  <a:cubicBezTo>
-                    <a:pt x="0" y="121554"/>
-                    <a:pt x="121554" y="0"/>
-                    <a:pt x="271498" y="0"/>
-                  </a:cubicBezTo>
-                  <a:close/>
-                </a:path>
-              </a:pathLst>
-            </a:custGeom>
-          </p:spPr>
-        </p:pic>
+          </p:grpSpPr>
+          <p:sp>
+            <p:nvSpPr>
+              <p:cNvPr id="124" name="사각형: 둥근 모서리 123">
+                <a:extLst>
+                  <a:ext uri="{FF2B5EF4-FFF2-40B4-BE49-F238E27FC236}">
+                    <a16:creationId xmlns:a16="http://schemas.microsoft.com/office/drawing/2014/main" id="{0EEBA7F7-2C90-20E4-BFDE-273BCA72CB8A}"/>
+                  </a:ext>
+                </a:extLst>
+              </p:cNvPr>
+              <p:cNvSpPr/>
+              <p:nvPr/>
+            </p:nvSpPr>
+            <p:spPr>
+              <a:xfrm>
+                <a:off x="7619108" y="3018448"/>
+                <a:ext cx="4325946" cy="1628953"/>
+              </a:xfrm>
+              <a:prstGeom prst="roundRect">
+                <a:avLst/>
+              </a:prstGeom>
+              <a:noFill/>
+              <a:ln w="19050">
+                <a:solidFill>
+                  <a:schemeClr val="tx1"/>
+                </a:solidFill>
+                <a:prstDash val="dash"/>
+              </a:ln>
+              <a:effectLst/>
+            </p:spPr>
+            <p:style>
+              <a:lnRef idx="1">
+                <a:schemeClr val="accent1"/>
+              </a:lnRef>
+              <a:fillRef idx="3">
+                <a:schemeClr val="accent1"/>
+              </a:fillRef>
+              <a:effectRef idx="2">
+                <a:schemeClr val="accent1"/>
+              </a:effectRef>
+              <a:fontRef idx="minor">
+                <a:schemeClr val="lt1"/>
+              </a:fontRef>
+            </p:style>
+            <p:txBody>
+              <a:bodyPr rtlCol="0" anchor="ctr"/>
+              <a:lstStyle/>
+              <a:p>
+                <a:pPr algn="ctr"/>
+                <a:endParaRPr lang="ko-KR" altLang="en-US"/>
+              </a:p>
+            </p:txBody>
+          </p:sp>
+          <mc:AlternateContent xmlns:mc="http://schemas.openxmlformats.org/markup-compatibility/2006">
+            <mc:Choice xmlns:a14="http://schemas.microsoft.com/office/drawing/2010/main" Requires="a14">
+              <p:sp>
+                <p:nvSpPr>
+                  <p:cNvPr id="44" name="TextBox 43">
+                    <a:extLst>
+                      <a:ext uri="{FF2B5EF4-FFF2-40B4-BE49-F238E27FC236}">
+                        <a16:creationId xmlns:a16="http://schemas.microsoft.com/office/drawing/2014/main" id="{638202AF-2449-538A-8694-561A42B05DC2}"/>
+                      </a:ext>
+                    </a:extLst>
+                  </p:cNvPr>
+                  <p:cNvSpPr txBox="1"/>
+                  <p:nvPr/>
+                </p:nvSpPr>
+                <p:spPr>
+                  <a:xfrm>
+                    <a:off x="7675879" y="3477525"/>
+                    <a:ext cx="1563929" cy="181609"/>
+                  </a:xfrm>
+                  <a:prstGeom prst="rect">
+                    <a:avLst/>
+                  </a:prstGeom>
+                  <a:noFill/>
+                </p:spPr>
+                <p:txBody>
+                  <a:bodyPr wrap="square" lIns="0" tIns="0" rIns="0" bIns="0" anchor="ctr">
+                    <a:spAutoFit/>
+                  </a:bodyPr>
+                  <a:lstStyle/>
+                  <a:p>
+                    <a:pPr algn="ctr"/>
+                    <a:r>
+                      <a:rPr lang="en-US" sz="1050" b="1" i="1" dirty="0">
+                        <a:solidFill>
+                          <a:srgbClr val="C0392B"/>
+                        </a:solidFill>
+                        <a:latin typeface="Arial"/>
+                      </a:rPr>
+                      <a:t>S</a:t>
+                    </a:r>
+                    <a:r>
+                      <a:rPr sz="1050" b="1" i="1" dirty="0">
+                        <a:solidFill>
+                          <a:srgbClr val="C0392B"/>
+                        </a:solidFill>
+                        <a:latin typeface="Arial"/>
+                      </a:rPr>
+                      <a:t>ide boundary</a:t>
+                    </a:r>
+                    <a:r>
+                      <a:rPr lang="en-US" sz="1050" b="1" i="1" dirty="0">
+                        <a:solidFill>
+                          <a:srgbClr val="C0392B"/>
+                        </a:solidFill>
+                        <a:latin typeface="Arial"/>
+                      </a:rPr>
+                      <a:t> </a:t>
+                    </a:r>
+                    <a14:m>
+                      <m:oMath xmlns:m="http://schemas.openxmlformats.org/officeDocument/2006/math">
+                        <m:r>
+                          <a:rPr lang="ko-KR" altLang="en-US" sz="1050" b="1" i="1" smtClean="0">
+                            <a:solidFill>
+                              <a:srgbClr val="C0392B"/>
+                            </a:solidFill>
+                            <a:latin typeface="Cambria Math" panose="02040503050406030204" pitchFamily="18" charset="0"/>
+                          </a:rPr>
+                          <m:t>∈</m:t>
+                        </m:r>
+                        <m:r>
+                          <a:rPr lang="ko-KR" altLang="en-US" sz="1050" b="1" i="1" smtClean="0">
+                            <a:solidFill>
+                              <a:srgbClr val="C0392B"/>
+                            </a:solidFill>
+                            <a:latin typeface="Cambria Math" panose="02040503050406030204" pitchFamily="18" charset="0"/>
+                            <a:ea typeface="Cambria Math" panose="02040503050406030204" pitchFamily="18" charset="0"/>
+                          </a:rPr>
+                          <m:t>𝓕</m:t>
+                        </m:r>
+                      </m:oMath>
+                    </a14:m>
+                    <a:endParaRPr sz="1050" b="1" i="1" dirty="0">
+                      <a:solidFill>
+                        <a:srgbClr val="C0392B"/>
+                      </a:solidFill>
+                      <a:latin typeface="Arial"/>
+                    </a:endParaRPr>
+                  </a:p>
+                </p:txBody>
+              </p:sp>
+            </mc:Choice>
+            <mc:Fallback>
+              <p:sp>
+                <p:nvSpPr>
+                  <p:cNvPr id="44" name="TextBox 43">
+                    <a:extLst>
+                      <a:ext uri="{FF2B5EF4-FFF2-40B4-BE49-F238E27FC236}">
+                        <a16:creationId xmlns:a16="http://schemas.microsoft.com/office/drawing/2014/main" id="{638202AF-2449-538A-8694-561A42B05DC2}"/>
+                      </a:ext>
+                    </a:extLst>
+                  </p:cNvPr>
+                  <p:cNvSpPr txBox="1">
+                    <a:spLocks noRot="1" noChangeAspect="1" noMove="1" noResize="1" noEditPoints="1" noAdjustHandles="1" noChangeArrowheads="1" noChangeShapeType="1" noTextEdit="1"/>
+                  </p:cNvSpPr>
+                  <p:nvPr/>
+                </p:nvSpPr>
+                <p:spPr>
+                  <a:xfrm>
+                    <a:off x="7675879" y="3477525"/>
+                    <a:ext cx="1563929" cy="181609"/>
+                  </a:xfrm>
+                  <a:prstGeom prst="rect">
+                    <a:avLst/>
+                  </a:prstGeom>
+                  <a:blipFill>
+                    <a:blip r:embed="rId4"/>
+                    <a:stretch>
+                      <a:fillRect t="-26923" b="-50000"/>
+                    </a:stretch>
+                  </a:blipFill>
+                </p:spPr>
+                <p:txBody>
+                  <a:bodyPr/>
+                  <a:lstStyle/>
+                  <a:p>
+                    <a:r>
+                      <a:rPr lang="ko-KR" altLang="en-US">
+                        <a:noFill/>
+                      </a:rPr>
+                      <a:t> </a:t>
+                    </a:r>
+                  </a:p>
+                </p:txBody>
+              </p:sp>
+            </mc:Fallback>
+          </mc:AlternateContent>
+          <mc:AlternateContent xmlns:mc="http://schemas.openxmlformats.org/markup-compatibility/2006">
+            <mc:Choice xmlns:a14="http://schemas.microsoft.com/office/drawing/2010/main" Requires="a14">
+              <p:sp>
+                <p:nvSpPr>
+                  <p:cNvPr id="51" name="TextBox 50">
+                    <a:extLst>
+                      <a:ext uri="{FF2B5EF4-FFF2-40B4-BE49-F238E27FC236}">
+                        <a16:creationId xmlns:a16="http://schemas.microsoft.com/office/drawing/2014/main" id="{5FA0D53B-4563-1417-900B-0BEF02EEE23A}"/>
+                      </a:ext>
+                    </a:extLst>
+                  </p:cNvPr>
+                  <p:cNvSpPr txBox="1"/>
+                  <p:nvPr/>
+                </p:nvSpPr>
+                <p:spPr>
+                  <a:xfrm>
+                    <a:off x="10256486" y="4341312"/>
+                    <a:ext cx="1737360" cy="181609"/>
+                  </a:xfrm>
+                  <a:prstGeom prst="rect">
+                    <a:avLst/>
+                  </a:prstGeom>
+                  <a:noFill/>
+                </p:spPr>
+                <p:txBody>
+                  <a:bodyPr wrap="square" lIns="0" tIns="0" rIns="0" bIns="0" anchor="ctr">
+                    <a:spAutoFit/>
+                  </a:bodyPr>
+                  <a:lstStyle/>
+                  <a:p>
+                    <a:pPr algn="ctr"/>
+                    <a:r>
+                      <a:rPr lang="en-US" sz="1050" b="1" i="0" dirty="0">
+                        <a:solidFill>
+                          <a:srgbClr val="C0392B"/>
+                        </a:solidFill>
+                        <a:latin typeface="Arial"/>
+                      </a:rPr>
+                      <a:t>C</a:t>
+                    </a:r>
+                    <a:r>
+                      <a:rPr sz="1050" b="1" i="0" dirty="0">
+                        <a:solidFill>
+                          <a:srgbClr val="C0392B"/>
+                        </a:solidFill>
+                        <a:latin typeface="Arial"/>
+                      </a:rPr>
+                      <a:t>radle walls </a:t>
+                    </a:r>
+                    <a14:m>
+                      <m:oMath xmlns:m="http://schemas.openxmlformats.org/officeDocument/2006/math">
+                        <m:r>
+                          <a:rPr lang="ko-KR" altLang="en-US" sz="1050" b="1" i="1">
+                            <a:solidFill>
+                              <a:srgbClr val="C0392B"/>
+                            </a:solidFill>
+                            <a:latin typeface="Cambria Math" panose="02040503050406030204" pitchFamily="18" charset="0"/>
+                          </a:rPr>
+                          <m:t>∈</m:t>
+                        </m:r>
+                        <m:r>
+                          <a:rPr lang="ko-KR" altLang="en-US" sz="1050" b="1" i="1">
+                            <a:solidFill>
+                              <a:srgbClr val="C0392B"/>
+                            </a:solidFill>
+                            <a:latin typeface="Cambria Math" panose="02040503050406030204" pitchFamily="18" charset="0"/>
+                            <a:ea typeface="Cambria Math" panose="02040503050406030204" pitchFamily="18" charset="0"/>
+                          </a:rPr>
+                          <m:t>𝓕</m:t>
+                        </m:r>
+                      </m:oMath>
+                    </a14:m>
+                    <a:endParaRPr sz="1050" b="1" i="0" dirty="0">
+                      <a:solidFill>
+                        <a:srgbClr val="C0392B"/>
+                      </a:solidFill>
+                      <a:latin typeface="Arial"/>
+                    </a:endParaRPr>
+                  </a:p>
+                </p:txBody>
+              </p:sp>
+            </mc:Choice>
+            <mc:Fallback>
+              <p:sp>
+                <p:nvSpPr>
+                  <p:cNvPr id="51" name="TextBox 50">
+                    <a:extLst>
+                      <a:ext uri="{FF2B5EF4-FFF2-40B4-BE49-F238E27FC236}">
+                        <a16:creationId xmlns:a16="http://schemas.microsoft.com/office/drawing/2014/main" id="{5FA0D53B-4563-1417-900B-0BEF02EEE23A}"/>
+                      </a:ext>
+                    </a:extLst>
+                  </p:cNvPr>
+                  <p:cNvSpPr txBox="1">
+                    <a:spLocks noRot="1" noChangeAspect="1" noMove="1" noResize="1" noEditPoints="1" noAdjustHandles="1" noChangeArrowheads="1" noChangeShapeType="1" noTextEdit="1"/>
+                  </p:cNvSpPr>
+                  <p:nvPr/>
+                </p:nvSpPr>
+                <p:spPr>
+                  <a:xfrm>
+                    <a:off x="10256486" y="4341312"/>
+                    <a:ext cx="1737360" cy="181609"/>
+                  </a:xfrm>
+                  <a:prstGeom prst="rect">
+                    <a:avLst/>
+                  </a:prstGeom>
+                  <a:blipFill>
+                    <a:blip r:embed="rId5"/>
+                    <a:stretch>
+                      <a:fillRect t="-26923" b="-53846"/>
+                    </a:stretch>
+                  </a:blipFill>
+                </p:spPr>
+                <p:txBody>
+                  <a:bodyPr/>
+                  <a:lstStyle/>
+                  <a:p>
+                    <a:r>
+                      <a:rPr lang="ko-KR" altLang="en-US">
+                        <a:noFill/>
+                      </a:rPr>
+                      <a:t> </a:t>
+                    </a:r>
+                  </a:p>
+                </p:txBody>
+              </p:sp>
+            </mc:Fallback>
+          </mc:AlternateContent>
+          <p:grpSp>
+            <p:nvGrpSpPr>
+              <p:cNvPr id="91" name="그룹 90">
+                <a:extLst>
+                  <a:ext uri="{FF2B5EF4-FFF2-40B4-BE49-F238E27FC236}">
+                    <a16:creationId xmlns:a16="http://schemas.microsoft.com/office/drawing/2014/main" id="{F0450F82-CC08-EA1E-8777-9CFA82134FD8}"/>
+                  </a:ext>
+                </a:extLst>
+              </p:cNvPr>
+              <p:cNvGrpSpPr/>
+              <p:nvPr/>
+            </p:nvGrpSpPr>
+            <p:grpSpPr>
+              <a:xfrm>
+                <a:off x="9610317" y="3440897"/>
+                <a:ext cx="1772290" cy="871097"/>
+                <a:chOff x="7609842" y="3689133"/>
+                <a:chExt cx="2338830" cy="1149557"/>
+              </a:xfrm>
+            </p:grpSpPr>
+            <p:grpSp>
+              <p:nvGrpSpPr>
+                <p:cNvPr id="89" name="그룹 88">
+                  <a:extLst>
+                    <a:ext uri="{FF2B5EF4-FFF2-40B4-BE49-F238E27FC236}">
+                      <a16:creationId xmlns:a16="http://schemas.microsoft.com/office/drawing/2014/main" id="{DBD66AA6-2578-D289-6CCA-E422E1496EF0}"/>
+                    </a:ext>
+                  </a:extLst>
+                </p:cNvPr>
+                <p:cNvGrpSpPr/>
+                <p:nvPr/>
+              </p:nvGrpSpPr>
+              <p:grpSpPr>
+                <a:xfrm>
+                  <a:off x="7614075" y="3689133"/>
+                  <a:ext cx="2334597" cy="1149557"/>
+                  <a:chOff x="7447280" y="3841662"/>
+                  <a:chExt cx="2334597" cy="1149557"/>
+                </a:xfrm>
+              </p:grpSpPr>
+              <p:pic>
+                <p:nvPicPr>
+                  <p:cNvPr id="73" name="그림 72">
+                    <a:extLst>
+                      <a:ext uri="{FF2B5EF4-FFF2-40B4-BE49-F238E27FC236}">
+                        <a16:creationId xmlns:a16="http://schemas.microsoft.com/office/drawing/2014/main" id="{D25F8341-DA89-F3A7-409F-81BFE6AF6937}"/>
+                      </a:ext>
+                    </a:extLst>
+                  </p:cNvPr>
+                  <p:cNvPicPr>
+                    <a:picLocks noChangeAspect="1"/>
+                  </p:cNvPicPr>
+                  <p:nvPr/>
+                </p:nvPicPr>
+                <p:blipFill>
+                  <a:blip r:embed="rId2"/>
+                  <a:srcRect t="20686" b="23574"/>
+                  <a:stretch>
+                    <a:fillRect/>
+                  </a:stretch>
+                </p:blipFill>
+                <p:spPr>
+                  <a:xfrm rot="10800000">
+                    <a:off x="7447280" y="3850128"/>
+                    <a:ext cx="2272876" cy="1141091"/>
+                  </a:xfrm>
+                  <a:prstGeom prst="rect">
+                    <a:avLst/>
+                  </a:prstGeom>
+                </p:spPr>
+              </p:pic>
+              <p:sp>
+                <p:nvSpPr>
+                  <p:cNvPr id="87" name="자유형: 도형 86">
+                    <a:extLst>
+                      <a:ext uri="{FF2B5EF4-FFF2-40B4-BE49-F238E27FC236}">
+                        <a16:creationId xmlns:a16="http://schemas.microsoft.com/office/drawing/2014/main" id="{512C4FC6-179E-7D9D-64E8-27A745264EB8}"/>
+                      </a:ext>
+                    </a:extLst>
+                  </p:cNvPr>
+                  <p:cNvSpPr/>
+                  <p:nvPr/>
+                </p:nvSpPr>
+                <p:spPr>
+                  <a:xfrm>
+                    <a:off x="7447280" y="3841662"/>
+                    <a:ext cx="2334597" cy="1141092"/>
+                  </a:xfrm>
+                  <a:custGeom>
+                    <a:avLst/>
+                    <a:gdLst>
+                      <a:gd name="csX0" fmla="*/ 1815251 w 2334597"/>
+                      <a:gd name="csY0" fmla="*/ 0 h 1141092"/>
+                      <a:gd name="csX1" fmla="*/ 2334597 w 2334597"/>
+                      <a:gd name="csY1" fmla="*/ 0 h 1141092"/>
+                      <a:gd name="csX2" fmla="*/ 2334597 w 2334597"/>
+                      <a:gd name="csY2" fmla="*/ 1141092 h 1141092"/>
+                      <a:gd name="csX3" fmla="*/ 2332567 w 2334597"/>
+                      <a:gd name="csY3" fmla="*/ 1141092 h 1141092"/>
+                      <a:gd name="csX4" fmla="*/ 1815251 w 2334597"/>
+                      <a:gd name="csY4" fmla="*/ 1141092 h 1141092"/>
+                      <a:gd name="csX5" fmla="*/ 0 w 2334597"/>
+                      <a:gd name="csY5" fmla="*/ 1141092 h 1141092"/>
+                      <a:gd name="csX6" fmla="*/ 0 w 2334597"/>
+                      <a:gd name="csY6" fmla="*/ 778422 h 1141092"/>
+                      <a:gd name="csX7" fmla="*/ 1815251 w 2334597"/>
+                      <a:gd name="csY7" fmla="*/ 778422 h 1141092"/>
+                      <a:gd name="csX8" fmla="*/ 1815251 w 2334597"/>
+                      <a:gd name="csY8" fmla="*/ 362671 h 1141092"/>
+                      <a:gd name="csX9" fmla="*/ 0 w 2334597"/>
+                      <a:gd name="csY9" fmla="*/ 362671 h 1141092"/>
+                      <a:gd name="csX10" fmla="*/ 0 w 2334597"/>
+                      <a:gd name="csY10" fmla="*/ 1 h 1141092"/>
+                      <a:gd name="csX11" fmla="*/ 1815251 w 2334597"/>
+                      <a:gd name="csY11" fmla="*/ 1 h 1141092"/>
+                    </a:gdLst>
+                    <a:ahLst/>
+                    <a:cxnLst>
+                      <a:cxn ang="0">
+                        <a:pos x="csX0" y="csY0"/>
+                      </a:cxn>
+                      <a:cxn ang="0">
+                        <a:pos x="csX1" y="csY1"/>
+                      </a:cxn>
+                      <a:cxn ang="0">
+                        <a:pos x="csX2" y="csY2"/>
+                      </a:cxn>
+                      <a:cxn ang="0">
+                        <a:pos x="csX3" y="csY3"/>
+                      </a:cxn>
+                      <a:cxn ang="0">
+                        <a:pos x="csX4" y="csY4"/>
+                      </a:cxn>
+                      <a:cxn ang="0">
+                        <a:pos x="csX5" y="csY5"/>
+                      </a:cxn>
+                      <a:cxn ang="0">
+                        <a:pos x="csX6" y="csY6"/>
+                      </a:cxn>
+                      <a:cxn ang="0">
+                        <a:pos x="csX7" y="csY7"/>
+                      </a:cxn>
+                      <a:cxn ang="0">
+                        <a:pos x="csX8" y="csY8"/>
+                      </a:cxn>
+                      <a:cxn ang="0">
+                        <a:pos x="csX9" y="csY9"/>
+                      </a:cxn>
+                      <a:cxn ang="0">
+                        <a:pos x="csX10" y="csY10"/>
+                      </a:cxn>
+                      <a:cxn ang="0">
+                        <a:pos x="csX11" y="csY11"/>
+                      </a:cxn>
+                    </a:cxnLst>
+                    <a:rect l="l" t="t" r="r" b="b"/>
+                    <a:pathLst>
+                      <a:path w="2334597" h="1141092">
+                        <a:moveTo>
+                          <a:pt x="1815251" y="0"/>
+                        </a:moveTo>
+                        <a:lnTo>
+                          <a:pt x="2334597" y="0"/>
+                        </a:lnTo>
+                        <a:lnTo>
+                          <a:pt x="2334597" y="1141092"/>
+                        </a:lnTo>
+                        <a:lnTo>
+                          <a:pt x="2332567" y="1141092"/>
+                        </a:lnTo>
+                        <a:lnTo>
+                          <a:pt x="1815251" y="1141092"/>
+                        </a:lnTo>
+                        <a:lnTo>
+                          <a:pt x="0" y="1141092"/>
+                        </a:lnTo>
+                        <a:lnTo>
+                          <a:pt x="0" y="778422"/>
+                        </a:lnTo>
+                        <a:lnTo>
+                          <a:pt x="1815251" y="778422"/>
+                        </a:lnTo>
+                        <a:lnTo>
+                          <a:pt x="1815251" y="362671"/>
+                        </a:lnTo>
+                        <a:lnTo>
+                          <a:pt x="0" y="362671"/>
+                        </a:lnTo>
+                        <a:lnTo>
+                          <a:pt x="0" y="1"/>
+                        </a:lnTo>
+                        <a:lnTo>
+                          <a:pt x="1815251" y="1"/>
+                        </a:lnTo>
+                        <a:close/>
+                      </a:path>
+                    </a:pathLst>
+                  </a:custGeom>
+                  <a:solidFill>
+                    <a:schemeClr val="accent6">
+                      <a:lumMod val="40000"/>
+                      <a:lumOff val="60000"/>
+                      <a:alpha val="51000"/>
+                    </a:schemeClr>
+                  </a:solidFill>
+                  <a:ln>
+                    <a:solidFill>
+                      <a:srgbClr val="FF6600"/>
+                    </a:solidFill>
+                    <a:prstDash val="dash"/>
+                  </a:ln>
+                </p:spPr>
+                <p:style>
+                  <a:lnRef idx="2">
+                    <a:schemeClr val="dk1"/>
+                  </a:lnRef>
+                  <a:fillRef idx="1">
+                    <a:schemeClr val="lt1"/>
+                  </a:fillRef>
+                  <a:effectRef idx="0">
+                    <a:schemeClr val="dk1"/>
+                  </a:effectRef>
+                  <a:fontRef idx="minor">
+                    <a:schemeClr val="dk1"/>
+                  </a:fontRef>
+                </p:style>
+                <p:txBody>
+                  <a:bodyPr wrap="square" rtlCol="0" anchor="ctr">
+                    <a:noAutofit/>
+                  </a:bodyPr>
+                  <a:lstStyle/>
+                  <a:p>
+                    <a:pPr algn="ctr"/>
+                    <a:endParaRPr lang="ko-KR" altLang="en-US">
+                      <a:ln w="0"/>
+                      <a:solidFill>
+                        <a:schemeClr val="tx1"/>
+                      </a:solidFill>
+                      <a:effectLst>
+                        <a:outerShdw blurRad="38100" dist="19050" dir="2700000" algn="tl" rotWithShape="0">
+                          <a:schemeClr val="dk1">
+                            <a:alpha val="40000"/>
+                          </a:schemeClr>
+                        </a:outerShdw>
+                      </a:effectLst>
+                    </a:endParaRPr>
+                  </a:p>
+                </p:txBody>
+              </p:sp>
+            </p:grpSp>
+            <p:sp>
+              <p:nvSpPr>
+                <p:cNvPr id="90" name="직사각형 89">
+                  <a:extLst>
+                    <a:ext uri="{FF2B5EF4-FFF2-40B4-BE49-F238E27FC236}">
+                      <a16:creationId xmlns:a16="http://schemas.microsoft.com/office/drawing/2014/main" id="{6F61FD2A-63A4-591F-7E15-EAE37CC0E3C7}"/>
+                    </a:ext>
+                  </a:extLst>
+                </p:cNvPr>
+                <p:cNvSpPr/>
+                <p:nvPr/>
+              </p:nvSpPr>
+              <p:spPr>
+                <a:xfrm>
+                  <a:off x="7609842" y="4092811"/>
+                  <a:ext cx="1775459" cy="329868"/>
+                </a:xfrm>
+                <a:prstGeom prst="rect">
+                  <a:avLst/>
+                </a:prstGeom>
+                <a:solidFill>
+                  <a:schemeClr val="accent3">
+                    <a:lumMod val="20000"/>
+                    <a:lumOff val="80000"/>
+                  </a:schemeClr>
+                </a:solidFill>
+                <a:ln w="19050">
+                  <a:solidFill>
+                    <a:schemeClr val="accent3">
+                      <a:lumMod val="75000"/>
+                    </a:schemeClr>
+                  </a:solidFill>
+                  <a:prstDash val="sysDot"/>
+                </a:ln>
+              </p:spPr>
+              <p:style>
+                <a:lnRef idx="2">
+                  <a:schemeClr val="dk1"/>
+                </a:lnRef>
+                <a:fillRef idx="1">
+                  <a:schemeClr val="lt1"/>
+                </a:fillRef>
+                <a:effectRef idx="0">
+                  <a:schemeClr val="dk1"/>
+                </a:effectRef>
+                <a:fontRef idx="minor">
+                  <a:schemeClr val="dk1"/>
+                </a:fontRef>
+              </p:style>
+              <p:txBody>
+                <a:bodyPr rtlCol="0" anchor="ctr"/>
+                <a:lstStyle/>
+                <a:p>
+                  <a:pPr algn="ctr"/>
+                  <a:endParaRPr lang="ko-KR" altLang="en-US"/>
+                </a:p>
+              </p:txBody>
+            </p:sp>
+          </p:grpSp>
+          <p:grpSp>
+            <p:nvGrpSpPr>
+              <p:cNvPr id="94" name="그룹 93">
+                <a:extLst>
+                  <a:ext uri="{FF2B5EF4-FFF2-40B4-BE49-F238E27FC236}">
+                    <a16:creationId xmlns:a16="http://schemas.microsoft.com/office/drawing/2014/main" id="{C8146ABF-E913-B1AB-2CDA-32CA10753CB8}"/>
+                  </a:ext>
+                </a:extLst>
+              </p:cNvPr>
+              <p:cNvGrpSpPr/>
+              <p:nvPr/>
+            </p:nvGrpSpPr>
+            <p:grpSpPr>
+              <a:xfrm rot="21238330">
+                <a:off x="8452894" y="3780929"/>
+                <a:ext cx="1185669" cy="387770"/>
+                <a:chOff x="6083109" y="4170560"/>
+                <a:chExt cx="1564687" cy="511727"/>
+              </a:xfrm>
+            </p:grpSpPr>
+            <p:pic>
+              <p:nvPicPr>
+                <p:cNvPr id="82" name="그림 81">
+                  <a:extLst>
+                    <a:ext uri="{FF2B5EF4-FFF2-40B4-BE49-F238E27FC236}">
+                      <a16:creationId xmlns:a16="http://schemas.microsoft.com/office/drawing/2014/main" id="{A6CF955F-5F3C-4C05-0B43-7FFE00BE1A7D}"/>
+                    </a:ext>
+                  </a:extLst>
+                </p:cNvPr>
+                <p:cNvPicPr>
+                  <a:picLocks noChangeAspect="1"/>
+                </p:cNvPicPr>
+                <p:nvPr/>
+              </p:nvPicPr>
+              <p:blipFill>
+                <a:blip r:embed="rId3"/>
+                <a:srcRect l="10392" t="79073" r="57408" b="8050"/>
+                <a:stretch>
+                  <a:fillRect/>
+                </a:stretch>
+              </p:blipFill>
+              <p:spPr>
+                <a:xfrm rot="21278377">
+                  <a:off x="6083109" y="4170560"/>
+                  <a:ext cx="1564077" cy="511727"/>
+                </a:xfrm>
+                <a:prstGeom prst="rect">
+                  <a:avLst/>
+                </a:prstGeom>
+              </p:spPr>
+            </p:pic>
+            <p:sp>
+              <p:nvSpPr>
+                <p:cNvPr id="93" name="타원 92">
+                  <a:extLst>
+                    <a:ext uri="{FF2B5EF4-FFF2-40B4-BE49-F238E27FC236}">
+                      <a16:creationId xmlns:a16="http://schemas.microsoft.com/office/drawing/2014/main" id="{346891C5-9981-E578-9C5D-045380BD025B}"/>
+                    </a:ext>
+                  </a:extLst>
+                </p:cNvPr>
+                <p:cNvSpPr/>
+                <p:nvPr/>
+              </p:nvSpPr>
+              <p:spPr>
+                <a:xfrm flipH="1">
+                  <a:off x="7573423" y="4308006"/>
+                  <a:ext cx="74373" cy="74373"/>
+                </a:xfrm>
+                <a:prstGeom prst="ellipse">
+                  <a:avLst/>
+                </a:prstGeom>
+                <a:solidFill>
+                  <a:schemeClr val="accent5">
+                    <a:lumMod val="40000"/>
+                    <a:lumOff val="60000"/>
+                  </a:schemeClr>
+                </a:solidFill>
+                <a:ln>
+                  <a:solidFill>
+                    <a:schemeClr val="accent1"/>
+                  </a:solidFill>
+                </a:ln>
+              </p:spPr>
+              <p:style>
+                <a:lnRef idx="2">
+                  <a:schemeClr val="dk1"/>
+                </a:lnRef>
+                <a:fillRef idx="1">
+                  <a:schemeClr val="lt1"/>
+                </a:fillRef>
+                <a:effectRef idx="0">
+                  <a:schemeClr val="dk1"/>
+                </a:effectRef>
+                <a:fontRef idx="minor">
+                  <a:schemeClr val="dk1"/>
+                </a:fontRef>
+              </p:style>
+              <p:txBody>
+                <a:bodyPr rtlCol="0" anchor="ctr"/>
+                <a:lstStyle/>
+                <a:p>
+                  <a:pPr algn="ctr"/>
+                  <a:endParaRPr lang="ko-KR" altLang="en-US"/>
+                </a:p>
+              </p:txBody>
+            </p:sp>
+          </p:grpSp>
+          <p:cxnSp>
+            <p:nvCxnSpPr>
+              <p:cNvPr id="97" name="Connector 9">
+                <a:extLst>
+                  <a:ext uri="{FF2B5EF4-FFF2-40B4-BE49-F238E27FC236}">
+                    <a16:creationId xmlns:a16="http://schemas.microsoft.com/office/drawing/2014/main" id="{E275C861-9756-3EF4-6723-7A70B679B381}"/>
+                  </a:ext>
+                </a:extLst>
+              </p:cNvPr>
+              <p:cNvCxnSpPr>
+                <a:cxnSpLocks/>
+              </p:cNvCxnSpPr>
+              <p:nvPr/>
+            </p:nvCxnSpPr>
+            <p:spPr>
+              <a:xfrm>
+                <a:off x="7899150" y="3440897"/>
+                <a:ext cx="1670666" cy="0"/>
+              </a:xfrm>
+              <a:prstGeom prst="line">
+                <a:avLst/>
+              </a:prstGeom>
+              <a:ln w="25400">
+                <a:solidFill>
+                  <a:srgbClr val="FF6600"/>
+                </a:solidFill>
+                <a:prstDash val="dash"/>
+              </a:ln>
+              <a:effectLst/>
+            </p:spPr>
+            <p:style>
+              <a:lnRef idx="1">
+                <a:schemeClr val="dk1"/>
+              </a:lnRef>
+              <a:fillRef idx="0">
+                <a:schemeClr val="dk1"/>
+              </a:fillRef>
+              <a:effectRef idx="0">
+                <a:schemeClr val="dk1"/>
+              </a:effectRef>
+              <a:fontRef idx="minor">
+                <a:schemeClr val="tx1"/>
+              </a:fontRef>
+            </p:style>
+          </p:cxnSp>
+          <p:cxnSp>
+            <p:nvCxnSpPr>
+              <p:cNvPr id="103" name="Connector 9">
+                <a:extLst>
+                  <a:ext uri="{FF2B5EF4-FFF2-40B4-BE49-F238E27FC236}">
+                    <a16:creationId xmlns:a16="http://schemas.microsoft.com/office/drawing/2014/main" id="{EE2B2BC7-052D-8386-057B-7CFE4FB23CFD}"/>
+                  </a:ext>
+                </a:extLst>
+              </p:cNvPr>
+              <p:cNvCxnSpPr>
+                <a:cxnSpLocks/>
+              </p:cNvCxnSpPr>
+              <p:nvPr/>
+            </p:nvCxnSpPr>
+            <p:spPr>
+              <a:xfrm>
+                <a:off x="11419059" y="3440897"/>
+                <a:ext cx="337264" cy="0"/>
+              </a:xfrm>
+              <a:prstGeom prst="line">
+                <a:avLst/>
+              </a:prstGeom>
+              <a:ln w="25400">
+                <a:solidFill>
+                  <a:srgbClr val="FF6600"/>
+                </a:solidFill>
+                <a:prstDash val="dash"/>
+              </a:ln>
+              <a:effectLst/>
+            </p:spPr>
+            <p:style>
+              <a:lnRef idx="1">
+                <a:schemeClr val="dk1"/>
+              </a:lnRef>
+              <a:fillRef idx="0">
+                <a:schemeClr val="dk1"/>
+              </a:fillRef>
+              <a:effectRef idx="0">
+                <a:schemeClr val="dk1"/>
+              </a:effectRef>
+              <a:fontRef idx="minor">
+                <a:schemeClr val="tx1"/>
+              </a:fontRef>
+            </p:style>
+          </p:cxnSp>
+          <p:sp>
+            <p:nvSpPr>
+              <p:cNvPr id="106" name="Rectangle 8">
+                <a:extLst>
+                  <a:ext uri="{FF2B5EF4-FFF2-40B4-BE49-F238E27FC236}">
+                    <a16:creationId xmlns:a16="http://schemas.microsoft.com/office/drawing/2014/main" id="{D63A9DB3-3BF9-CD46-3B75-88998D35A639}"/>
+                  </a:ext>
+                </a:extLst>
+              </p:cNvPr>
+              <p:cNvSpPr/>
+              <p:nvPr/>
+            </p:nvSpPr>
+            <p:spPr>
+              <a:xfrm>
+                <a:off x="7807841" y="3361380"/>
+                <a:ext cx="3948481" cy="72140"/>
+              </a:xfrm>
+              <a:prstGeom prst="rect">
+                <a:avLst/>
+              </a:prstGeom>
+              <a:solidFill>
+                <a:srgbClr val="FBE9DA"/>
+              </a:solidFill>
+              <a:ln>
+                <a:noFill/>
+              </a:ln>
+              <a:effectLst/>
+            </p:spPr>
+            <p:style>
+              <a:lnRef idx="1">
+                <a:schemeClr val="accent1"/>
+              </a:lnRef>
+              <a:fillRef idx="3">
+                <a:schemeClr val="accent1"/>
+              </a:fillRef>
+              <a:effectRef idx="2">
+                <a:schemeClr val="accent1"/>
+              </a:effectRef>
+              <a:fontRef idx="minor">
+                <a:schemeClr val="lt1"/>
+              </a:fontRef>
+            </p:style>
+            <p:txBody>
+              <a:bodyPr rtlCol="0" anchor="ctr"/>
+              <a:lstStyle/>
+              <a:p>
+                <a:pPr algn="ctr"/>
+                <a:endParaRPr/>
+              </a:p>
+            </p:txBody>
+          </p:sp>
+          <p:pic>
+            <p:nvPicPr>
+              <p:cNvPr id="127" name="그림 126">
+                <a:extLst>
+                  <a:ext uri="{FF2B5EF4-FFF2-40B4-BE49-F238E27FC236}">
+                    <a16:creationId xmlns:a16="http://schemas.microsoft.com/office/drawing/2014/main" id="{9490E217-03EE-92A6-AFB3-CC4D16E14C1C}"/>
+                  </a:ext>
+                </a:extLst>
+              </p:cNvPr>
+              <p:cNvPicPr>
+                <a:picLocks noChangeAspect="1"/>
+              </p:cNvPicPr>
+              <p:nvPr/>
+            </p:nvPicPr>
+            <p:blipFill>
+              <a:blip r:embed="rId3"/>
+              <a:srcRect l="10016" t="25048" r="29812" b="66394"/>
+              <a:stretch>
+                <a:fillRect/>
+              </a:stretch>
+            </p:blipFill>
+            <p:spPr>
+              <a:xfrm>
+                <a:off x="7619108" y="3028205"/>
+                <a:ext cx="4325946" cy="410168"/>
+              </a:xfrm>
+              <a:custGeom>
+                <a:avLst/>
+                <a:gdLst>
+                  <a:gd name="csX0" fmla="*/ 271498 w 4325946"/>
+                  <a:gd name="csY0" fmla="*/ 0 h 410168"/>
+                  <a:gd name="csX1" fmla="*/ 4054448 w 4325946"/>
+                  <a:gd name="csY1" fmla="*/ 0 h 410168"/>
+                  <a:gd name="csX2" fmla="*/ 4325946 w 4325946"/>
+                  <a:gd name="csY2" fmla="*/ 271498 h 410168"/>
+                  <a:gd name="csX3" fmla="*/ 4325946 w 4325946"/>
+                  <a:gd name="csY3" fmla="*/ 410168 h 410168"/>
+                  <a:gd name="csX4" fmla="*/ 0 w 4325946"/>
+                  <a:gd name="csY4" fmla="*/ 410168 h 410168"/>
+                  <a:gd name="csX5" fmla="*/ 0 w 4325946"/>
+                  <a:gd name="csY5" fmla="*/ 271498 h 410168"/>
+                  <a:gd name="csX6" fmla="*/ 271498 w 4325946"/>
+                  <a:gd name="csY6" fmla="*/ 0 h 410168"/>
+                </a:gdLst>
+                <a:ahLst/>
+                <a:cxnLst>
+                  <a:cxn ang="0">
+                    <a:pos x="csX0" y="csY0"/>
+                  </a:cxn>
+                  <a:cxn ang="0">
+                    <a:pos x="csX1" y="csY1"/>
+                  </a:cxn>
+                  <a:cxn ang="0">
+                    <a:pos x="csX2" y="csY2"/>
+                  </a:cxn>
+                  <a:cxn ang="0">
+                    <a:pos x="csX3" y="csY3"/>
+                  </a:cxn>
+                  <a:cxn ang="0">
+                    <a:pos x="csX4" y="csY4"/>
+                  </a:cxn>
+                  <a:cxn ang="0">
+                    <a:pos x="csX5" y="csY5"/>
+                  </a:cxn>
+                  <a:cxn ang="0">
+                    <a:pos x="csX6" y="csY6"/>
+                  </a:cxn>
+                </a:cxnLst>
+                <a:rect l="l" t="t" r="r" b="b"/>
+                <a:pathLst>
+                  <a:path w="4325946" h="410168">
+                    <a:moveTo>
+                      <a:pt x="271498" y="0"/>
+                    </a:moveTo>
+                    <a:lnTo>
+                      <a:pt x="4054448" y="0"/>
+                    </a:lnTo>
+                    <a:cubicBezTo>
+                      <a:pt x="4204392" y="0"/>
+                      <a:pt x="4325946" y="121554"/>
+                      <a:pt x="4325946" y="271498"/>
+                    </a:cubicBezTo>
+                    <a:lnTo>
+                      <a:pt x="4325946" y="410168"/>
+                    </a:lnTo>
+                    <a:lnTo>
+                      <a:pt x="0" y="410168"/>
+                    </a:lnTo>
+                    <a:lnTo>
+                      <a:pt x="0" y="271498"/>
+                    </a:lnTo>
+                    <a:cubicBezTo>
+                      <a:pt x="0" y="121554"/>
+                      <a:pt x="121554" y="0"/>
+                      <a:pt x="271498" y="0"/>
+                    </a:cubicBezTo>
+                    <a:close/>
+                  </a:path>
+                </a:pathLst>
+              </a:custGeom>
+            </p:spPr>
+          </p:pic>
+          <mc:AlternateContent xmlns:mc="http://schemas.openxmlformats.org/markup-compatibility/2006">
+            <mc:Choice xmlns:a14="http://schemas.microsoft.com/office/drawing/2010/main" Requires="a14">
+              <p:sp>
+                <p:nvSpPr>
+                  <p:cNvPr id="109" name="TextBox 108">
+                    <a:extLst>
+                      <a:ext uri="{FF2B5EF4-FFF2-40B4-BE49-F238E27FC236}">
+                        <a16:creationId xmlns:a16="http://schemas.microsoft.com/office/drawing/2014/main" id="{943FFFBF-7D14-5601-0E75-3C81B9BE8DE1}"/>
+                      </a:ext>
+                    </a:extLst>
+                  </p:cNvPr>
+                  <p:cNvSpPr txBox="1"/>
+                  <p:nvPr/>
+                </p:nvSpPr>
+                <p:spPr>
+                  <a:xfrm>
+                    <a:off x="9765621" y="3723852"/>
+                    <a:ext cx="1209537" cy="285385"/>
+                  </a:xfrm>
+                  <a:prstGeom prst="rect">
+                    <a:avLst/>
+                  </a:prstGeom>
+                  <a:noFill/>
+                </p:spPr>
+                <p:txBody>
+                  <a:bodyPr wrap="square">
+                    <a:spAutoFit/>
+                  </a:bodyPr>
+                  <a:lstStyle/>
+                  <a:p>
+                    <a:r>
+                      <a:rPr lang="en-US" altLang="ko-KR" sz="1050" b="1" i="0" dirty="0">
+                        <a:solidFill>
+                          <a:srgbClr val="3E8E3E"/>
+                        </a:solidFill>
+                        <a:latin typeface="Arial"/>
+                      </a:rPr>
+                      <a:t>Target set  </a:t>
+                    </a:r>
+                    <a14:m>
+                      <m:oMath xmlns:m="http://schemas.openxmlformats.org/officeDocument/2006/math">
+                        <m:r>
+                          <a:rPr lang="ko-KR" altLang="en-US" sz="1050" b="1" i="1" smtClean="0">
+                            <a:solidFill>
+                              <a:srgbClr val="3E8E3E"/>
+                            </a:solidFill>
+                            <a:latin typeface="Cambria Math" panose="02040503050406030204" pitchFamily="18" charset="0"/>
+                          </a:rPr>
+                          <m:t>𝓣</m:t>
+                        </m:r>
+                      </m:oMath>
+                    </a14:m>
+                    <a:endParaRPr lang="ko-KR" altLang="en-US" sz="1050" dirty="0"/>
+                  </a:p>
+                </p:txBody>
+              </p:sp>
+            </mc:Choice>
+            <mc:Fallback>
+              <p:sp>
+                <p:nvSpPr>
+                  <p:cNvPr id="109" name="TextBox 108">
+                    <a:extLst>
+                      <a:ext uri="{FF2B5EF4-FFF2-40B4-BE49-F238E27FC236}">
+                        <a16:creationId xmlns:a16="http://schemas.microsoft.com/office/drawing/2014/main" id="{943FFFBF-7D14-5601-0E75-3C81B9BE8DE1}"/>
+                      </a:ext>
+                    </a:extLst>
+                  </p:cNvPr>
+                  <p:cNvSpPr txBox="1">
+                    <a:spLocks noRot="1" noChangeAspect="1" noMove="1" noResize="1" noEditPoints="1" noAdjustHandles="1" noChangeArrowheads="1" noChangeShapeType="1" noTextEdit="1"/>
+                  </p:cNvSpPr>
+                  <p:nvPr/>
+                </p:nvSpPr>
+                <p:spPr>
+                  <a:xfrm>
+                    <a:off x="9765621" y="3723852"/>
+                    <a:ext cx="1209537" cy="285385"/>
+                  </a:xfrm>
+                  <a:prstGeom prst="rect">
+                    <a:avLst/>
+                  </a:prstGeom>
+                  <a:blipFill>
+                    <a:blip r:embed="rId6"/>
+                    <a:stretch>
+                      <a:fillRect b="-14634"/>
+                    </a:stretch>
+                  </a:blipFill>
+                </p:spPr>
+                <p:txBody>
+                  <a:bodyPr/>
+                  <a:lstStyle/>
+                  <a:p>
+                    <a:r>
+                      <a:rPr lang="ko-KR" altLang="en-US">
+                        <a:noFill/>
+                      </a:rPr>
+                      <a:t> </a:t>
+                    </a:r>
+                  </a:p>
+                </p:txBody>
+              </p:sp>
+            </mc:Fallback>
+          </mc:AlternateContent>
+        </p:grpSp>
         <p:sp>
           <p:nvSpPr>
-            <p:cNvPr id="109" name="TextBox 108">
+            <p:cNvPr id="22" name="TextBox 21">
               <a:extLst>
                 <a:ext uri="{FF2B5EF4-FFF2-40B4-BE49-F238E27FC236}">
-                  <a16:creationId xmlns:a16="http://schemas.microsoft.com/office/drawing/2014/main" id="{943FFFBF-7D14-5601-0E75-3C81B9BE8DE1}"/>
+                  <a16:creationId xmlns:a16="http://schemas.microsoft.com/office/drawing/2014/main" id="{47D8579C-7832-7169-F716-5C5DAC5BE2FB}"/>
                 </a:ext>
               </a:extLst>
             </p:cNvPr>
@@ -7922,8 +8290,8 @@
           </p:nvSpPr>
           <p:spPr>
             <a:xfrm>
-              <a:off x="9765621" y="3718142"/>
-              <a:ext cx="1209537" cy="253916"/>
+              <a:off x="9344094" y="3972646"/>
+              <a:ext cx="3503855" cy="169277"/>
             </a:xfrm>
             <a:prstGeom prst="rect">
               <a:avLst/>
@@ -7931,21 +8299,27 @@
             <a:noFill/>
           </p:spPr>
           <p:txBody>
-            <a:bodyPr wrap="square">
+            <a:bodyPr wrap="square" lIns="0" tIns="0" rIns="0" bIns="0" anchor="ctr">
               <a:spAutoFit/>
             </a:bodyPr>
             <a:lstStyle/>
             <a:p>
+              <a:pPr algn="ctr"/>
               <a:r>
-                <a:rPr lang="en-US" altLang="ko-KR" sz="1050" b="1" i="0" dirty="0">
+                <a:rPr lang="en-US" sz="1100" b="1" i="0" dirty="0">
                   <a:solidFill>
-                    <a:srgbClr val="3E8E3E"/>
+                    <a:srgbClr val="304055"/>
                   </a:solidFill>
                   <a:latin typeface="Arial"/>
                 </a:rPr>
-                <a:t>target set  T </a:t>
+                <a:t>Target and collision sets</a:t>
               </a:r>
-              <a:endParaRPr lang="ko-KR" altLang="en-US" sz="1050" dirty="0"/>
+              <a:endParaRPr sz="1100" b="1" i="0" dirty="0">
+                <a:solidFill>
+                  <a:srgbClr val="304055"/>
+                </a:solidFill>
+                <a:latin typeface="Arial"/>
+              </a:endParaRPr>
             </a:p>
           </p:txBody>
         </p:sp>

</xml_diff>

<commit_message>
Update Figure 2 to revised version, cropped tight
Co-Authored-By: Claude Opus 4.8 (1M context) <noreply@anthropic.com>
</commit_message>
<xml_diff>
--- a/Figure2_system.pptx
+++ b/Figure2_system.pptx
@@ -7173,7 +7173,7 @@
         </p:nvGrpSpPr>
         <p:grpSpPr>
           <a:xfrm>
-            <a:off x="8167992" y="2425199"/>
+            <a:off x="8292057" y="2447992"/>
             <a:ext cx="4679957" cy="1681164"/>
             <a:chOff x="8167992" y="2460759"/>
             <a:chExt cx="4679957" cy="1681164"/>
@@ -7251,8 +7251,8 @@
               </a:p>
             </p:txBody>
           </p:sp>
-          <mc:AlternateContent xmlns:mc="http://schemas.openxmlformats.org/markup-compatibility/2006">
-            <mc:Choice xmlns:a14="http://schemas.microsoft.com/office/drawing/2010/main" Requires="a14">
+          <mc:AlternateContent xmlns:mc="http://schemas.openxmlformats.org/markup-compatibility/2006" xmlns:a14="http://schemas.microsoft.com/office/drawing/2010/main">
+            <mc:Choice Requires="a14">
               <p:sp>
                 <p:nvSpPr>
                   <p:cNvPr id="44" name="TextBox 43">
@@ -7342,7 +7342,7 @@
                 </p:txBody>
               </p:sp>
             </mc:Choice>
-            <mc:Fallback>
+            <mc:Fallback xmlns="">
               <p:sp>
                 <p:nvSpPr>
                   <p:cNvPr id="44" name="TextBox 43">
@@ -7387,8 +7387,8 @@
               </p:sp>
             </mc:Fallback>
           </mc:AlternateContent>
-          <mc:AlternateContent xmlns:mc="http://schemas.openxmlformats.org/markup-compatibility/2006">
-            <mc:Choice xmlns:a14="http://schemas.microsoft.com/office/drawing/2010/main" Requires="a14">
+          <mc:AlternateContent xmlns:mc="http://schemas.openxmlformats.org/markup-compatibility/2006" xmlns:a14="http://schemas.microsoft.com/office/drawing/2010/main">
+            <mc:Choice Requires="a14">
               <p:sp>
                 <p:nvSpPr>
                   <p:cNvPr id="51" name="TextBox 50">
@@ -7469,7 +7469,7 @@
                 </p:txBody>
               </p:sp>
             </mc:Choice>
-            <mc:Fallback>
+            <mc:Fallback xmlns="">
               <p:sp>
                 <p:nvSpPr>
                   <p:cNvPr id="51" name="TextBox 50">
@@ -8173,8 +8173,8 @@
               </a:custGeom>
             </p:spPr>
           </p:pic>
-          <mc:AlternateContent xmlns:mc="http://schemas.openxmlformats.org/markup-compatibility/2006">
-            <mc:Choice xmlns:a14="http://schemas.microsoft.com/office/drawing/2010/main" Requires="a14">
+          <mc:AlternateContent xmlns:mc="http://schemas.openxmlformats.org/markup-compatibility/2006" xmlns:a14="http://schemas.microsoft.com/office/drawing/2010/main">
+            <mc:Choice Requires="a14">
               <p:sp>
                 <p:nvSpPr>
                   <p:cNvPr id="109" name="TextBox 108">
@@ -8230,7 +8230,7 @@
                 </p:txBody>
               </p:sp>
             </mc:Choice>
-            <mc:Fallback>
+            <mc:Fallback xmlns="">
               <p:sp>
                 <p:nvSpPr>
                   <p:cNvPr id="109" name="TextBox 108">

</xml_diff>

<commit_message>
Update Figure 2 recovery scenario from the revised slide
Co-Authored-By: Claude Opus 4.8 (1M context) <noreply@anthropic.com>
</commit_message>
<xml_diff>
--- a/Figure2_system.pptx
+++ b/Figure2_system.pptx
@@ -6,7 +6,7 @@
   </p:sldMasterIdLst>
   <p:sldIdLst>
     <p:sldId id="256" r:id="rId2"/>
-    <p:sldId id="257" r:id="rId3"/>
+    <p:sldId id="258" r:id="rId3"/>
   </p:sldIdLst>
   <p:sldSz cx="12188825" cy="6035675"/>
   <p:notesSz cx="6858000" cy="9144000"/>
@@ -303,7 +303,7 @@
           <a:p>
             <a:fld id="{5BCAD085-E8A6-8845-BD4E-CB4CCA059FC4}" type="datetimeFigureOut">
               <a:rPr lang="en-US" smtClean="0"/>
-              <a:t>8/27/2026</a:t>
+              <a:t>9/1/2026</a:t>
             </a:fld>
             <a:endParaRPr lang="en-US"/>
           </a:p>
@@ -471,7 +471,7 @@
           <a:p>
             <a:fld id="{5BCAD085-E8A6-8845-BD4E-CB4CCA059FC4}" type="datetimeFigureOut">
               <a:rPr lang="en-US" smtClean="0"/>
-              <a:t>8/27/2026</a:t>
+              <a:t>9/1/2026</a:t>
             </a:fld>
             <a:endParaRPr lang="en-US"/>
           </a:p>
@@ -649,7 +649,7 @@
           <a:p>
             <a:fld id="{5BCAD085-E8A6-8845-BD4E-CB4CCA059FC4}" type="datetimeFigureOut">
               <a:rPr lang="en-US" smtClean="0"/>
-              <a:t>8/27/2026</a:t>
+              <a:t>9/1/2026</a:t>
             </a:fld>
             <a:endParaRPr lang="en-US"/>
           </a:p>
@@ -817,7 +817,7 @@
           <a:p>
             <a:fld id="{5BCAD085-E8A6-8845-BD4E-CB4CCA059FC4}" type="datetimeFigureOut">
               <a:rPr lang="en-US" smtClean="0"/>
-              <a:t>8/27/2026</a:t>
+              <a:t>9/1/2026</a:t>
             </a:fld>
             <a:endParaRPr lang="en-US"/>
           </a:p>
@@ -1062,7 +1062,7 @@
           <a:p>
             <a:fld id="{5BCAD085-E8A6-8845-BD4E-CB4CCA059FC4}" type="datetimeFigureOut">
               <a:rPr lang="en-US" smtClean="0"/>
-              <a:t>8/27/2026</a:t>
+              <a:t>9/1/2026</a:t>
             </a:fld>
             <a:endParaRPr lang="en-US"/>
           </a:p>
@@ -1347,7 +1347,7 @@
           <a:p>
             <a:fld id="{5BCAD085-E8A6-8845-BD4E-CB4CCA059FC4}" type="datetimeFigureOut">
               <a:rPr lang="en-US" smtClean="0"/>
-              <a:t>8/27/2026</a:t>
+              <a:t>9/1/2026</a:t>
             </a:fld>
             <a:endParaRPr lang="en-US"/>
           </a:p>
@@ -1766,7 +1766,7 @@
           <a:p>
             <a:fld id="{5BCAD085-E8A6-8845-BD4E-CB4CCA059FC4}" type="datetimeFigureOut">
               <a:rPr lang="en-US" smtClean="0"/>
-              <a:t>8/27/2026</a:t>
+              <a:t>9/1/2026</a:t>
             </a:fld>
             <a:endParaRPr lang="en-US"/>
           </a:p>
@@ -1883,7 +1883,7 @@
           <a:p>
             <a:fld id="{5BCAD085-E8A6-8845-BD4E-CB4CCA059FC4}" type="datetimeFigureOut">
               <a:rPr lang="en-US" smtClean="0"/>
-              <a:t>8/27/2026</a:t>
+              <a:t>9/1/2026</a:t>
             </a:fld>
             <a:endParaRPr lang="en-US"/>
           </a:p>
@@ -1978,7 +1978,7 @@
           <a:p>
             <a:fld id="{5BCAD085-E8A6-8845-BD4E-CB4CCA059FC4}" type="datetimeFigureOut">
               <a:rPr lang="en-US" smtClean="0"/>
-              <a:t>8/27/2026</a:t>
+              <a:t>9/1/2026</a:t>
             </a:fld>
             <a:endParaRPr lang="en-US"/>
           </a:p>
@@ -2253,7 +2253,7 @@
           <a:p>
             <a:fld id="{5BCAD085-E8A6-8845-BD4E-CB4CCA059FC4}" type="datetimeFigureOut">
               <a:rPr lang="en-US" smtClean="0"/>
-              <a:t>8/27/2026</a:t>
+              <a:t>9/1/2026</a:t>
             </a:fld>
             <a:endParaRPr lang="en-US"/>
           </a:p>
@@ -2505,7 +2505,7 @@
           <a:p>
             <a:fld id="{5BCAD085-E8A6-8845-BD4E-CB4CCA059FC4}" type="datetimeFigureOut">
               <a:rPr lang="en-US" smtClean="0"/>
-              <a:t>8/27/2026</a:t>
+              <a:t>9/1/2026</a:t>
             </a:fld>
             <a:endParaRPr lang="en-US"/>
           </a:p>
@@ -2716,7 +2716,7 @@
           <a:p>
             <a:fld id="{5BCAD085-E8A6-8845-BD4E-CB4CCA059FC4}" type="datetimeFigureOut">
               <a:rPr lang="en-US" smtClean="0"/>
-              <a:t>8/27/2026</a:t>
+              <a:t>9/1/2026</a:t>
             </a:fld>
             <a:endParaRPr lang="en-US"/>
           </a:p>
@@ -5887,7 +5887,7 @@
         <p:cNvPr id="1" name="">
           <a:extLst>
             <a:ext uri="{FF2B5EF4-FFF2-40B4-BE49-F238E27FC236}">
-              <a16:creationId xmlns:a16="http://schemas.microsoft.com/office/drawing/2014/main" id="{0A4E6A28-E52B-B835-9768-FF77F1905746}"/>
+              <a16:creationId xmlns:a16="http://schemas.microsoft.com/office/drawing/2014/main" id="{7C96ED32-F2C3-DBF9-8AE2-B55F9F40B215}"/>
             </a:ext>
           </a:extLst>
         </p:cNvPr>
@@ -5907,7 +5907,7 @@
           <p:cNvPr id="131" name="자유형: 도형 130">
             <a:extLst>
               <a:ext uri="{FF2B5EF4-FFF2-40B4-BE49-F238E27FC236}">
-                <a16:creationId xmlns:a16="http://schemas.microsoft.com/office/drawing/2014/main" id="{D0F675B2-8E45-E963-5A6C-6526A778AB9C}"/>
+                <a16:creationId xmlns:a16="http://schemas.microsoft.com/office/drawing/2014/main" id="{E4A61423-3500-6E07-BD28-4FB17B7581AD}"/>
               </a:ext>
             </a:extLst>
           </p:cNvPr>
@@ -6138,7 +6138,7 @@
           <p:cNvPr id="70" name="그림 69">
             <a:extLst>
               <a:ext uri="{FF2B5EF4-FFF2-40B4-BE49-F238E27FC236}">
-                <a16:creationId xmlns:a16="http://schemas.microsoft.com/office/drawing/2014/main" id="{13FACF93-DC75-6639-648F-474054E7DFC6}"/>
+                <a16:creationId xmlns:a16="http://schemas.microsoft.com/office/drawing/2014/main" id="{D54DD139-3E13-F9D4-CB08-CD7F48BC355D}"/>
               </a:ext>
             </a:extLst>
           </p:cNvPr>
@@ -6168,7 +6168,7 @@
           <p:cNvPr id="7" name="Connector 6">
             <a:extLst>
               <a:ext uri="{FF2B5EF4-FFF2-40B4-BE49-F238E27FC236}">
-                <a16:creationId xmlns:a16="http://schemas.microsoft.com/office/drawing/2014/main" id="{13FEFD46-0815-C9F4-0D3E-1A3852F63231}"/>
+                <a16:creationId xmlns:a16="http://schemas.microsoft.com/office/drawing/2014/main" id="{97B32A1A-CCF2-CEB0-E947-2E48E794A7D3}"/>
               </a:ext>
             </a:extLst>
           </p:cNvPr>
@@ -6177,7 +6177,7 @@
         </p:nvCxnSpPr>
         <p:spPr>
           <a:xfrm>
-            <a:off x="5212080" y="269240"/>
+            <a:off x="5212080" y="277706"/>
             <a:ext cx="2743200" cy="0"/>
           </a:xfrm>
           <a:prstGeom prst="line">
@@ -6210,7 +6210,7 @@
           <p:cNvPr id="8" name="TextBox 7">
             <a:extLst>
               <a:ext uri="{FF2B5EF4-FFF2-40B4-BE49-F238E27FC236}">
-                <a16:creationId xmlns:a16="http://schemas.microsoft.com/office/drawing/2014/main" id="{4AA435FE-8618-A334-8C16-2369EDB72E31}"/>
+                <a16:creationId xmlns:a16="http://schemas.microsoft.com/office/drawing/2014/main" id="{8C7E656F-0399-1943-7F21-11F849B66764}"/>
               </a:ext>
             </a:extLst>
           </p:cNvPr>
@@ -6219,7 +6219,7 @@
         </p:nvSpPr>
         <p:spPr>
           <a:xfrm>
-            <a:off x="4663440" y="-114808"/>
+            <a:off x="4663440" y="-106342"/>
             <a:ext cx="3840480" cy="457200"/>
           </a:xfrm>
           <a:prstGeom prst="rect">
@@ -6251,7 +6251,7 @@
           <p:cNvPr id="9" name="Rectangle 8">
             <a:extLst>
               <a:ext uri="{FF2B5EF4-FFF2-40B4-BE49-F238E27FC236}">
-                <a16:creationId xmlns:a16="http://schemas.microsoft.com/office/drawing/2014/main" id="{E6BB39B8-992D-A1D7-83F1-2D5DF624FE2E}"/>
+                <a16:creationId xmlns:a16="http://schemas.microsoft.com/office/drawing/2014/main" id="{9AA522A9-0103-5795-4A26-92A991F394DB}"/>
               </a:ext>
             </a:extLst>
           </p:cNvPr>
@@ -6301,7 +6301,7 @@
           <p:cNvPr id="10" name="Connector 9">
             <a:extLst>
               <a:ext uri="{FF2B5EF4-FFF2-40B4-BE49-F238E27FC236}">
-                <a16:creationId xmlns:a16="http://schemas.microsoft.com/office/drawing/2014/main" id="{7F11AEEF-9A02-EC64-71D1-FF4A6FD0F7B8}"/>
+                <a16:creationId xmlns:a16="http://schemas.microsoft.com/office/drawing/2014/main" id="{EF2486CF-D779-BDA7-16DB-7A677C34419D}"/>
               </a:ext>
             </a:extLst>
           </p:cNvPr>
@@ -6345,7 +6345,7 @@
           <p:cNvPr id="13" name="TextBox 12">
             <a:extLst>
               <a:ext uri="{FF2B5EF4-FFF2-40B4-BE49-F238E27FC236}">
-                <a16:creationId xmlns:a16="http://schemas.microsoft.com/office/drawing/2014/main" id="{B3373DAF-BEA1-4EB3-7F0E-FE2CF2EB5749}"/>
+                <a16:creationId xmlns:a16="http://schemas.microsoft.com/office/drawing/2014/main" id="{3B1DDFFC-FBEC-8AEB-E71C-7354076F3989}"/>
               </a:ext>
             </a:extLst>
           </p:cNvPr>
@@ -6386,7 +6386,7 @@
           <p:cNvPr id="14" name="Freeform 13">
             <a:extLst>
               <a:ext uri="{FF2B5EF4-FFF2-40B4-BE49-F238E27FC236}">
-                <a16:creationId xmlns:a16="http://schemas.microsoft.com/office/drawing/2014/main" id="{B8E3F948-9B4E-B0E7-EDF5-08701C06A17F}"/>
+                <a16:creationId xmlns:a16="http://schemas.microsoft.com/office/drawing/2014/main" id="{0BB6F5BC-9E47-32AE-60F0-7EE5C96ABF72}"/>
               </a:ext>
             </a:extLst>
           </p:cNvPr>
@@ -6465,7 +6465,7 @@
           <p:cNvPr id="15" name="Freeform 14">
             <a:extLst>
               <a:ext uri="{FF2B5EF4-FFF2-40B4-BE49-F238E27FC236}">
-                <a16:creationId xmlns:a16="http://schemas.microsoft.com/office/drawing/2014/main" id="{CDE39922-CCB5-D878-E98F-396D9B746BA5}"/>
+                <a16:creationId xmlns:a16="http://schemas.microsoft.com/office/drawing/2014/main" id="{EB3F04B7-12A1-7CBE-84BC-12E468053F23}"/>
               </a:ext>
             </a:extLst>
           </p:cNvPr>
@@ -6540,7 +6540,7 @@
           <p:cNvPr id="3" name="그룹 2">
             <a:extLst>
               <a:ext uri="{FF2B5EF4-FFF2-40B4-BE49-F238E27FC236}">
-                <a16:creationId xmlns:a16="http://schemas.microsoft.com/office/drawing/2014/main" id="{4DFE5DB6-8F3B-3A0C-F4D3-5EB839CC1990}"/>
+                <a16:creationId xmlns:a16="http://schemas.microsoft.com/office/drawing/2014/main" id="{36C3B56E-9918-C008-DF9E-39C2C59E6F25}"/>
               </a:ext>
             </a:extLst>
           </p:cNvPr>
@@ -6560,7 +6560,7 @@
             <p:cNvPr id="16" name="Oval 15">
               <a:extLst>
                 <a:ext uri="{FF2B5EF4-FFF2-40B4-BE49-F238E27FC236}">
-                  <a16:creationId xmlns:a16="http://schemas.microsoft.com/office/drawing/2014/main" id="{53E86195-FD30-6CCE-1514-416AD0ED3218}"/>
+                  <a16:creationId xmlns:a16="http://schemas.microsoft.com/office/drawing/2014/main" id="{EA56BE68-0FD1-76FE-84EF-D40E839A21CD}"/>
                 </a:ext>
               </a:extLst>
             </p:cNvPr>
@@ -6614,7 +6614,7 @@
             <p:cNvPr id="17" name="Oval 16">
               <a:extLst>
                 <a:ext uri="{FF2B5EF4-FFF2-40B4-BE49-F238E27FC236}">
-                  <a16:creationId xmlns:a16="http://schemas.microsoft.com/office/drawing/2014/main" id="{250536D7-CEC7-DB8D-98C4-B1C750B52A9C}"/>
+                  <a16:creationId xmlns:a16="http://schemas.microsoft.com/office/drawing/2014/main" id="{2BB73102-2535-74CA-63F6-26EB859BA15D}"/>
                 </a:ext>
               </a:extLst>
             </p:cNvPr>
@@ -6666,7 +6666,7 @@
           <p:cNvPr id="18" name="TextBox 17">
             <a:extLst>
               <a:ext uri="{FF2B5EF4-FFF2-40B4-BE49-F238E27FC236}">
-                <a16:creationId xmlns:a16="http://schemas.microsoft.com/office/drawing/2014/main" id="{768AE48A-56F4-CDFC-A775-B2385DC65CDA}"/>
+                <a16:creationId xmlns:a16="http://schemas.microsoft.com/office/drawing/2014/main" id="{E014BAC1-4F44-8F37-1DF5-C34A5E00FB94}"/>
               </a:ext>
             </a:extLst>
           </p:cNvPr>
@@ -6707,7 +6707,7 @@
           <p:cNvPr id="55" name="Rounded Rectangle 54">
             <a:extLst>
               <a:ext uri="{FF2B5EF4-FFF2-40B4-BE49-F238E27FC236}">
-                <a16:creationId xmlns:a16="http://schemas.microsoft.com/office/drawing/2014/main" id="{D9E1E059-E28D-B350-AA21-08D97FA463EC}"/>
+                <a16:creationId xmlns:a16="http://schemas.microsoft.com/office/drawing/2014/main" id="{C3AFAB72-2503-F202-CBF2-2AB063E63E5C}"/>
               </a:ext>
             </a:extLst>
           </p:cNvPr>
@@ -6779,7 +6779,7 @@
           <p:cNvPr id="56" name="Connector 55">
             <a:extLst>
               <a:ext uri="{FF2B5EF4-FFF2-40B4-BE49-F238E27FC236}">
-                <a16:creationId xmlns:a16="http://schemas.microsoft.com/office/drawing/2014/main" id="{54173DD8-5377-CE1C-9721-7A58896FF512}"/>
+                <a16:creationId xmlns:a16="http://schemas.microsoft.com/office/drawing/2014/main" id="{25B00592-6700-5C22-CC2D-E6A59081AAD1}"/>
               </a:ext>
             </a:extLst>
           </p:cNvPr>
@@ -6823,7 +6823,7 @@
           <p:cNvPr id="57" name="Rounded Rectangle 56">
             <a:extLst>
               <a:ext uri="{FF2B5EF4-FFF2-40B4-BE49-F238E27FC236}">
-                <a16:creationId xmlns:a16="http://schemas.microsoft.com/office/drawing/2014/main" id="{AF4B4A3A-D2E5-23BB-30B6-D08550498433}"/>
+                <a16:creationId xmlns:a16="http://schemas.microsoft.com/office/drawing/2014/main" id="{94ED9652-D6DE-1F2D-F820-B570EC0403B8}"/>
               </a:ext>
             </a:extLst>
           </p:cNvPr>
@@ -6895,7 +6895,7 @@
           <p:cNvPr id="58" name="Connector 57">
             <a:extLst>
               <a:ext uri="{FF2B5EF4-FFF2-40B4-BE49-F238E27FC236}">
-                <a16:creationId xmlns:a16="http://schemas.microsoft.com/office/drawing/2014/main" id="{B95ECA1F-BDEF-A98B-EDA9-BA7F9635612A}"/>
+                <a16:creationId xmlns:a16="http://schemas.microsoft.com/office/drawing/2014/main" id="{43636A71-469F-68FC-FF8D-CB9470E3C9F5}"/>
               </a:ext>
             </a:extLst>
           </p:cNvPr>
@@ -6936,41 +6936,10 @@
       </p:cxnSp>
       <p:pic>
         <p:nvPicPr>
-          <p:cNvPr id="61" name="그림 60">
-            <a:extLst>
-              <a:ext uri="{FF2B5EF4-FFF2-40B4-BE49-F238E27FC236}">
-                <a16:creationId xmlns:a16="http://schemas.microsoft.com/office/drawing/2014/main" id="{883BAE08-957C-1E71-D49A-D6A98D467135}"/>
-              </a:ext>
-            </a:extLst>
-          </p:cNvPr>
-          <p:cNvPicPr>
-            <a:picLocks noChangeAspect="1"/>
-          </p:cNvPicPr>
-          <p:nvPr/>
-        </p:nvPicPr>
-        <p:blipFill>
-          <a:blip r:embed="rId3"/>
-          <a:srcRect l="3415" t="5994" r="4938" b="66394"/>
-          <a:stretch>
-            <a:fillRect/>
-          </a:stretch>
-        </p:blipFill>
-        <p:spPr>
-          <a:xfrm>
-            <a:off x="4294066" y="398512"/>
-            <a:ext cx="6186746" cy="1242589"/>
-          </a:xfrm>
-          <a:prstGeom prst="rect">
-            <a:avLst/>
-          </a:prstGeom>
-        </p:spPr>
-      </p:pic>
-      <p:pic>
-        <p:nvPicPr>
           <p:cNvPr id="63" name="그림 62">
             <a:extLst>
               <a:ext uri="{FF2B5EF4-FFF2-40B4-BE49-F238E27FC236}">
-                <a16:creationId xmlns:a16="http://schemas.microsoft.com/office/drawing/2014/main" id="{71AE7082-E866-3631-951D-8CDCD1750943}"/>
+                <a16:creationId xmlns:a16="http://schemas.microsoft.com/office/drawing/2014/main" id="{86CA1B39-5F49-A082-3480-95D1C9EBC5BF}"/>
               </a:ext>
             </a:extLst>
           </p:cNvPr>
@@ -7001,7 +6970,7 @@
           <p:cNvPr id="65" name="그림 64">
             <a:extLst>
               <a:ext uri="{FF2B5EF4-FFF2-40B4-BE49-F238E27FC236}">
-                <a16:creationId xmlns:a16="http://schemas.microsoft.com/office/drawing/2014/main" id="{93F66D66-3BE8-07A9-831B-46B5EFB8C37C}"/>
+                <a16:creationId xmlns:a16="http://schemas.microsoft.com/office/drawing/2014/main" id="{A4767D09-3278-787E-12F0-A1E03383E858}"/>
               </a:ext>
             </a:extLst>
           </p:cNvPr>
@@ -7032,7 +7001,7 @@
           <p:cNvPr id="67" name="그림 66">
             <a:extLst>
               <a:ext uri="{FF2B5EF4-FFF2-40B4-BE49-F238E27FC236}">
-                <a16:creationId xmlns:a16="http://schemas.microsoft.com/office/drawing/2014/main" id="{63E96745-3C56-DF2E-2B29-542D44D0CC96}"/>
+                <a16:creationId xmlns:a16="http://schemas.microsoft.com/office/drawing/2014/main" id="{798C3C3A-92BC-B87C-1C40-3FE600EE5A75}"/>
               </a:ext>
             </a:extLst>
           </p:cNvPr>
@@ -7063,7 +7032,7 @@
           <p:cNvPr id="5" name="5-Point Star 28">
             <a:extLst>
               <a:ext uri="{FF2B5EF4-FFF2-40B4-BE49-F238E27FC236}">
-                <a16:creationId xmlns:a16="http://schemas.microsoft.com/office/drawing/2014/main" id="{38B5A19D-B33C-CF49-3238-0AEFE048C768}"/>
+                <a16:creationId xmlns:a16="http://schemas.microsoft.com/office/drawing/2014/main" id="{6B30BE2E-E870-EDDF-5A44-999E61224C81}"/>
               </a:ext>
             </a:extLst>
           </p:cNvPr>
@@ -7114,7 +7083,7 @@
           <p:cNvPr id="11" name="TextBox 10">
             <a:extLst>
               <a:ext uri="{FF2B5EF4-FFF2-40B4-BE49-F238E27FC236}">
-                <a16:creationId xmlns:a16="http://schemas.microsoft.com/office/drawing/2014/main" id="{BB00DDFE-266B-C89A-159A-F3786E6FA098}"/>
+                <a16:creationId xmlns:a16="http://schemas.microsoft.com/office/drawing/2014/main" id="{D6B33A7F-76BA-16A9-FDB4-A61F486DD4E3}"/>
               </a:ext>
             </a:extLst>
           </p:cNvPr>
@@ -7159,12 +7128,275 @@
           </a:p>
         </p:txBody>
       </p:sp>
+      <mc:AlternateContent xmlns:mc="http://schemas.openxmlformats.org/markup-compatibility/2006">
+        <mc:Choice xmlns:a14="http://schemas.microsoft.com/office/drawing/2010/main" Requires="a14">
+          <p:sp>
+            <p:nvSpPr>
+              <p:cNvPr id="44" name="TextBox 43">
+                <a:extLst>
+                  <a:ext uri="{FF2B5EF4-FFF2-40B4-BE49-F238E27FC236}">
+                    <a16:creationId xmlns:a16="http://schemas.microsoft.com/office/drawing/2014/main" id="{3F6CD0E1-377D-FBEE-9151-0596401843CD}"/>
+                  </a:ext>
+                </a:extLst>
+              </p:cNvPr>
+              <p:cNvSpPr txBox="1"/>
+              <p:nvPr/>
+            </p:nvSpPr>
+            <p:spPr>
+              <a:xfrm>
+                <a:off x="8342568" y="2856447"/>
+                <a:ext cx="1391475" cy="161583"/>
+              </a:xfrm>
+              <a:prstGeom prst="rect">
+                <a:avLst/>
+              </a:prstGeom>
+              <a:noFill/>
+            </p:spPr>
+            <p:txBody>
+              <a:bodyPr wrap="square" lIns="0" tIns="0" rIns="0" bIns="0" anchor="ctr">
+                <a:spAutoFit/>
+              </a:bodyPr>
+              <a:lstStyle/>
+              <a:p>
+                <a:pPr algn="ctr"/>
+                <a:r>
+                  <a:rPr lang="en-US" sz="1050" b="1" i="1" dirty="0">
+                    <a:solidFill>
+                      <a:srgbClr val="C0392B"/>
+                    </a:solidFill>
+                    <a:latin typeface="Arial"/>
+                  </a:rPr>
+                  <a:t>S</a:t>
+                </a:r>
+                <a:r>
+                  <a:rPr sz="1050" b="1" i="1" dirty="0">
+                    <a:solidFill>
+                      <a:srgbClr val="C0392B"/>
+                    </a:solidFill>
+                    <a:latin typeface="Arial"/>
+                  </a:rPr>
+                  <a:t>ide boundary</a:t>
+                </a:r>
+                <a:r>
+                  <a:rPr lang="en-US" sz="1050" b="1" i="1" dirty="0">
+                    <a:solidFill>
+                      <a:srgbClr val="C0392B"/>
+                    </a:solidFill>
+                    <a:latin typeface="Arial"/>
+                  </a:rPr>
+                  <a:t> </a:t>
+                </a:r>
+                <a14:m>
+                  <m:oMath xmlns:m="http://schemas.openxmlformats.org/officeDocument/2006/math">
+                    <m:r>
+                      <a:rPr lang="ko-KR" altLang="en-US" sz="1050" b="1" i="1" smtClean="0">
+                        <a:solidFill>
+                          <a:srgbClr val="C0392B"/>
+                        </a:solidFill>
+                        <a:latin typeface="Cambria Math" panose="02040503050406030204" pitchFamily="18" charset="0"/>
+                      </a:rPr>
+                      <m:t>∈</m:t>
+                    </m:r>
+                    <m:r>
+                      <a:rPr lang="ko-KR" altLang="en-US" sz="1050" b="1" i="1" smtClean="0">
+                        <a:solidFill>
+                          <a:srgbClr val="C0392B"/>
+                        </a:solidFill>
+                        <a:latin typeface="Cambria Math" panose="02040503050406030204" pitchFamily="18" charset="0"/>
+                        <a:ea typeface="Cambria Math" panose="02040503050406030204" pitchFamily="18" charset="0"/>
+                      </a:rPr>
+                      <m:t>𝓕</m:t>
+                    </m:r>
+                  </m:oMath>
+                </a14:m>
+                <a:endParaRPr sz="1050" b="1" i="1" dirty="0">
+                  <a:solidFill>
+                    <a:srgbClr val="C0392B"/>
+                  </a:solidFill>
+                  <a:latin typeface="Arial"/>
+                </a:endParaRPr>
+              </a:p>
+            </p:txBody>
+          </p:sp>
+        </mc:Choice>
+        <mc:Fallback>
+          <p:sp>
+            <p:nvSpPr>
+              <p:cNvPr id="44" name="TextBox 43">
+                <a:extLst>
+                  <a:ext uri="{FF2B5EF4-FFF2-40B4-BE49-F238E27FC236}">
+                    <a16:creationId xmlns:a16="http://schemas.microsoft.com/office/drawing/2014/main" id="{3F6CD0E1-377D-FBEE-9151-0596401843CD}"/>
+                  </a:ext>
+                </a:extLst>
+              </p:cNvPr>
+              <p:cNvSpPr txBox="1">
+                <a:spLocks noRot="1" noChangeAspect="1" noMove="1" noResize="1" noEditPoints="1" noAdjustHandles="1" noChangeArrowheads="1" noChangeShapeType="1" noTextEdit="1"/>
+              </p:cNvSpPr>
+              <p:nvPr/>
+            </p:nvSpPr>
+            <p:spPr>
+              <a:xfrm>
+                <a:off x="8342568" y="2856447"/>
+                <a:ext cx="1391475" cy="161583"/>
+              </a:xfrm>
+              <a:prstGeom prst="rect">
+                <a:avLst/>
+              </a:prstGeom>
+              <a:blipFill>
+                <a:blip r:embed="rId4"/>
+                <a:stretch>
+                  <a:fillRect t="-26923" b="-50000"/>
+                </a:stretch>
+              </a:blipFill>
+            </p:spPr>
+            <p:txBody>
+              <a:bodyPr/>
+              <a:lstStyle/>
+              <a:p>
+                <a:r>
+                  <a:rPr lang="ko-KR" altLang="en-US">
+                    <a:noFill/>
+                  </a:rPr>
+                  <a:t> </a:t>
+                </a:r>
+              </a:p>
+            </p:txBody>
+          </p:sp>
+        </mc:Fallback>
+      </mc:AlternateContent>
+      <mc:AlternateContent xmlns:mc="http://schemas.openxmlformats.org/markup-compatibility/2006">
+        <mc:Choice xmlns:a14="http://schemas.microsoft.com/office/drawing/2010/main" Requires="a14">
+          <p:sp>
+            <p:nvSpPr>
+              <p:cNvPr id="51" name="TextBox 50">
+                <a:extLst>
+                  <a:ext uri="{FF2B5EF4-FFF2-40B4-BE49-F238E27FC236}">
+                    <a16:creationId xmlns:a16="http://schemas.microsoft.com/office/drawing/2014/main" id="{25EC1E74-9F5F-CCF8-D38B-7EE0027FE753}"/>
+                  </a:ext>
+                </a:extLst>
+              </p:cNvPr>
+              <p:cNvSpPr txBox="1"/>
+              <p:nvPr/>
+            </p:nvSpPr>
+            <p:spPr>
+              <a:xfrm>
+                <a:off x="10638613" y="3624984"/>
+                <a:ext cx="1545782" cy="161583"/>
+              </a:xfrm>
+              <a:prstGeom prst="rect">
+                <a:avLst/>
+              </a:prstGeom>
+              <a:noFill/>
+            </p:spPr>
+            <p:txBody>
+              <a:bodyPr wrap="square" lIns="0" tIns="0" rIns="0" bIns="0" anchor="ctr">
+                <a:spAutoFit/>
+              </a:bodyPr>
+              <a:lstStyle/>
+              <a:p>
+                <a:pPr algn="ctr"/>
+                <a:r>
+                  <a:rPr lang="en-US" sz="1050" b="1" i="0" dirty="0">
+                    <a:solidFill>
+                      <a:srgbClr val="C0392B"/>
+                    </a:solidFill>
+                    <a:latin typeface="Arial"/>
+                  </a:rPr>
+                  <a:t>C</a:t>
+                </a:r>
+                <a:r>
+                  <a:rPr sz="1050" b="1" i="0" dirty="0">
+                    <a:solidFill>
+                      <a:srgbClr val="C0392B"/>
+                    </a:solidFill>
+                    <a:latin typeface="Arial"/>
+                  </a:rPr>
+                  <a:t>radle walls </a:t>
+                </a:r>
+                <a14:m>
+                  <m:oMath xmlns:m="http://schemas.openxmlformats.org/officeDocument/2006/math">
+                    <m:r>
+                      <a:rPr lang="ko-KR" altLang="en-US" sz="1050" b="1" i="1">
+                        <a:solidFill>
+                          <a:srgbClr val="C0392B"/>
+                        </a:solidFill>
+                        <a:latin typeface="Cambria Math" panose="02040503050406030204" pitchFamily="18" charset="0"/>
+                      </a:rPr>
+                      <m:t>∈</m:t>
+                    </m:r>
+                    <m:r>
+                      <a:rPr lang="ko-KR" altLang="en-US" sz="1050" b="1" i="1">
+                        <a:solidFill>
+                          <a:srgbClr val="C0392B"/>
+                        </a:solidFill>
+                        <a:latin typeface="Cambria Math" panose="02040503050406030204" pitchFamily="18" charset="0"/>
+                        <a:ea typeface="Cambria Math" panose="02040503050406030204" pitchFamily="18" charset="0"/>
+                      </a:rPr>
+                      <m:t>𝓕</m:t>
+                    </m:r>
+                  </m:oMath>
+                </a14:m>
+                <a:endParaRPr sz="1050" b="1" i="0" dirty="0">
+                  <a:solidFill>
+                    <a:srgbClr val="C0392B"/>
+                  </a:solidFill>
+                  <a:latin typeface="Arial"/>
+                </a:endParaRPr>
+              </a:p>
+            </p:txBody>
+          </p:sp>
+        </mc:Choice>
+        <mc:Fallback>
+          <p:sp>
+            <p:nvSpPr>
+              <p:cNvPr id="51" name="TextBox 50">
+                <a:extLst>
+                  <a:ext uri="{FF2B5EF4-FFF2-40B4-BE49-F238E27FC236}">
+                    <a16:creationId xmlns:a16="http://schemas.microsoft.com/office/drawing/2014/main" id="{25EC1E74-9F5F-CCF8-D38B-7EE0027FE753}"/>
+                  </a:ext>
+                </a:extLst>
+              </p:cNvPr>
+              <p:cNvSpPr txBox="1">
+                <a:spLocks noRot="1" noChangeAspect="1" noMove="1" noResize="1" noEditPoints="1" noAdjustHandles="1" noChangeArrowheads="1" noChangeShapeType="1" noTextEdit="1"/>
+              </p:cNvSpPr>
+              <p:nvPr/>
+            </p:nvSpPr>
+            <p:spPr>
+              <a:xfrm>
+                <a:off x="10638613" y="3624984"/>
+                <a:ext cx="1545782" cy="161583"/>
+              </a:xfrm>
+              <a:prstGeom prst="rect">
+                <a:avLst/>
+              </a:prstGeom>
+              <a:blipFill>
+                <a:blip r:embed="rId5"/>
+                <a:stretch>
+                  <a:fillRect t="-26923" b="-50000"/>
+                </a:stretch>
+              </a:blipFill>
+            </p:spPr>
+            <p:txBody>
+              <a:bodyPr/>
+              <a:lstStyle/>
+              <a:p>
+                <a:r>
+                  <a:rPr lang="ko-KR" altLang="en-US">
+                    <a:noFill/>
+                  </a:rPr>
+                  <a:t> </a:t>
+                </a:r>
+              </a:p>
+            </p:txBody>
+          </p:sp>
+        </mc:Fallback>
+      </mc:AlternateContent>
       <p:grpSp>
         <p:nvGrpSpPr>
-          <p:cNvPr id="23" name="그룹 22">
+          <p:cNvPr id="91" name="그룹 90">
             <a:extLst>
               <a:ext uri="{FF2B5EF4-FFF2-40B4-BE49-F238E27FC236}">
-                <a16:creationId xmlns:a16="http://schemas.microsoft.com/office/drawing/2014/main" id="{775D8C7B-4C79-EB61-F916-B4080EA2B54C}"/>
+                <a16:creationId xmlns:a16="http://schemas.microsoft.com/office/drawing/2014/main" id="{4191FDF6-F0F2-8C1A-D48F-4B64B15AC123}"/>
               </a:ext>
             </a:extLst>
           </p:cNvPr>
@@ -7173,18 +7405,18 @@
         </p:nvGrpSpPr>
         <p:grpSpPr>
           <a:xfrm>
-            <a:off x="8292057" y="2447992"/>
-            <a:ext cx="4679957" cy="1681164"/>
-            <a:chOff x="8167992" y="2460759"/>
-            <a:chExt cx="4679957" cy="1681164"/>
+            <a:off x="10063696" y="2823858"/>
+            <a:ext cx="1576861" cy="775041"/>
+            <a:chOff x="7609842" y="3689133"/>
+            <a:chExt cx="2338830" cy="1149557"/>
           </a:xfrm>
         </p:grpSpPr>
         <p:grpSp>
           <p:nvGrpSpPr>
-            <p:cNvPr id="128" name="그룹 127">
+            <p:cNvPr id="89" name="그룹 88">
               <a:extLst>
                 <a:ext uri="{FF2B5EF4-FFF2-40B4-BE49-F238E27FC236}">
-                  <a16:creationId xmlns:a16="http://schemas.microsoft.com/office/drawing/2014/main" id="{EC4D1173-50B8-FB43-9ABD-E5B3C1C6773C}"/>
+                  <a16:creationId xmlns:a16="http://schemas.microsoft.com/office/drawing/2014/main" id="{B2B0B546-289E-5DAF-F7B4-30F18BFD96CD}"/>
                 </a:ext>
               </a:extLst>
             </p:cNvPr>
@@ -7193,890 +7425,18 @@
           </p:nvGrpSpPr>
           <p:grpSpPr>
             <a:xfrm>
-              <a:off x="8167992" y="2460759"/>
-              <a:ext cx="3892338" cy="1449329"/>
-              <a:chOff x="7619108" y="3018448"/>
-              <a:chExt cx="4374738" cy="1628953"/>
+              <a:off x="7614075" y="3689133"/>
+              <a:ext cx="2334597" cy="1149557"/>
+              <a:chOff x="7447280" y="3841662"/>
+              <a:chExt cx="2334597" cy="1149557"/>
             </a:xfrm>
           </p:grpSpPr>
-          <p:sp>
-            <p:nvSpPr>
-              <p:cNvPr id="124" name="사각형: 둥근 모서리 123">
+          <p:pic>
+            <p:nvPicPr>
+              <p:cNvPr id="73" name="그림 72">
                 <a:extLst>
                   <a:ext uri="{FF2B5EF4-FFF2-40B4-BE49-F238E27FC236}">
-                    <a16:creationId xmlns:a16="http://schemas.microsoft.com/office/drawing/2014/main" id="{0EEBA7F7-2C90-20E4-BFDE-273BCA72CB8A}"/>
-                  </a:ext>
-                </a:extLst>
-              </p:cNvPr>
-              <p:cNvSpPr/>
-              <p:nvPr/>
-            </p:nvSpPr>
-            <p:spPr>
-              <a:xfrm>
-                <a:off x="7619108" y="3018448"/>
-                <a:ext cx="4325946" cy="1628953"/>
-              </a:xfrm>
-              <a:prstGeom prst="roundRect">
-                <a:avLst/>
-              </a:prstGeom>
-              <a:noFill/>
-              <a:ln w="19050">
-                <a:solidFill>
-                  <a:schemeClr val="tx1"/>
-                </a:solidFill>
-                <a:prstDash val="dash"/>
-              </a:ln>
-              <a:effectLst/>
-            </p:spPr>
-            <p:style>
-              <a:lnRef idx="1">
-                <a:schemeClr val="accent1"/>
-              </a:lnRef>
-              <a:fillRef idx="3">
-                <a:schemeClr val="accent1"/>
-              </a:fillRef>
-              <a:effectRef idx="2">
-                <a:schemeClr val="accent1"/>
-              </a:effectRef>
-              <a:fontRef idx="minor">
-                <a:schemeClr val="lt1"/>
-              </a:fontRef>
-            </p:style>
-            <p:txBody>
-              <a:bodyPr rtlCol="0" anchor="ctr"/>
-              <a:lstStyle/>
-              <a:p>
-                <a:pPr algn="ctr"/>
-                <a:endParaRPr lang="ko-KR" altLang="en-US"/>
-              </a:p>
-            </p:txBody>
-          </p:sp>
-          <mc:AlternateContent xmlns:mc="http://schemas.openxmlformats.org/markup-compatibility/2006" xmlns:a14="http://schemas.microsoft.com/office/drawing/2010/main">
-            <mc:Choice Requires="a14">
-              <p:sp>
-                <p:nvSpPr>
-                  <p:cNvPr id="44" name="TextBox 43">
-                    <a:extLst>
-                      <a:ext uri="{FF2B5EF4-FFF2-40B4-BE49-F238E27FC236}">
-                        <a16:creationId xmlns:a16="http://schemas.microsoft.com/office/drawing/2014/main" id="{638202AF-2449-538A-8694-561A42B05DC2}"/>
-                      </a:ext>
-                    </a:extLst>
-                  </p:cNvPr>
-                  <p:cNvSpPr txBox="1"/>
-                  <p:nvPr/>
-                </p:nvSpPr>
-                <p:spPr>
-                  <a:xfrm>
-                    <a:off x="7675879" y="3477525"/>
-                    <a:ext cx="1563929" cy="181609"/>
-                  </a:xfrm>
-                  <a:prstGeom prst="rect">
-                    <a:avLst/>
-                  </a:prstGeom>
-                  <a:noFill/>
-                </p:spPr>
-                <p:txBody>
-                  <a:bodyPr wrap="square" lIns="0" tIns="0" rIns="0" bIns="0" anchor="ctr">
-                    <a:spAutoFit/>
-                  </a:bodyPr>
-                  <a:lstStyle/>
-                  <a:p>
-                    <a:pPr algn="ctr"/>
-                    <a:r>
-                      <a:rPr lang="en-US" sz="1050" b="1" i="1" dirty="0">
-                        <a:solidFill>
-                          <a:srgbClr val="C0392B"/>
-                        </a:solidFill>
-                        <a:latin typeface="Arial"/>
-                      </a:rPr>
-                      <a:t>S</a:t>
-                    </a:r>
-                    <a:r>
-                      <a:rPr sz="1050" b="1" i="1" dirty="0">
-                        <a:solidFill>
-                          <a:srgbClr val="C0392B"/>
-                        </a:solidFill>
-                        <a:latin typeface="Arial"/>
-                      </a:rPr>
-                      <a:t>ide boundary</a:t>
-                    </a:r>
-                    <a:r>
-                      <a:rPr lang="en-US" sz="1050" b="1" i="1" dirty="0">
-                        <a:solidFill>
-                          <a:srgbClr val="C0392B"/>
-                        </a:solidFill>
-                        <a:latin typeface="Arial"/>
-                      </a:rPr>
-                      <a:t> </a:t>
-                    </a:r>
-                    <a14:m>
-                      <m:oMath xmlns:m="http://schemas.openxmlformats.org/officeDocument/2006/math">
-                        <m:r>
-                          <a:rPr lang="ko-KR" altLang="en-US" sz="1050" b="1" i="1" smtClean="0">
-                            <a:solidFill>
-                              <a:srgbClr val="C0392B"/>
-                            </a:solidFill>
-                            <a:latin typeface="Cambria Math" panose="02040503050406030204" pitchFamily="18" charset="0"/>
-                          </a:rPr>
-                          <m:t>∈</m:t>
-                        </m:r>
-                        <m:r>
-                          <a:rPr lang="ko-KR" altLang="en-US" sz="1050" b="1" i="1" smtClean="0">
-                            <a:solidFill>
-                              <a:srgbClr val="C0392B"/>
-                            </a:solidFill>
-                            <a:latin typeface="Cambria Math" panose="02040503050406030204" pitchFamily="18" charset="0"/>
-                            <a:ea typeface="Cambria Math" panose="02040503050406030204" pitchFamily="18" charset="0"/>
-                          </a:rPr>
-                          <m:t>𝓕</m:t>
-                        </m:r>
-                      </m:oMath>
-                    </a14:m>
-                    <a:endParaRPr sz="1050" b="1" i="1" dirty="0">
-                      <a:solidFill>
-                        <a:srgbClr val="C0392B"/>
-                      </a:solidFill>
-                      <a:latin typeface="Arial"/>
-                    </a:endParaRPr>
-                  </a:p>
-                </p:txBody>
-              </p:sp>
-            </mc:Choice>
-            <mc:Fallback xmlns="">
-              <p:sp>
-                <p:nvSpPr>
-                  <p:cNvPr id="44" name="TextBox 43">
-                    <a:extLst>
-                      <a:ext uri="{FF2B5EF4-FFF2-40B4-BE49-F238E27FC236}">
-                        <a16:creationId xmlns:a16="http://schemas.microsoft.com/office/drawing/2014/main" id="{638202AF-2449-538A-8694-561A42B05DC2}"/>
-                      </a:ext>
-                    </a:extLst>
-                  </p:cNvPr>
-                  <p:cNvSpPr txBox="1">
-                    <a:spLocks noRot="1" noChangeAspect="1" noMove="1" noResize="1" noEditPoints="1" noAdjustHandles="1" noChangeArrowheads="1" noChangeShapeType="1" noTextEdit="1"/>
-                  </p:cNvSpPr>
-                  <p:nvPr/>
-                </p:nvSpPr>
-                <p:spPr>
-                  <a:xfrm>
-                    <a:off x="7675879" y="3477525"/>
-                    <a:ext cx="1563929" cy="181609"/>
-                  </a:xfrm>
-                  <a:prstGeom prst="rect">
-                    <a:avLst/>
-                  </a:prstGeom>
-                  <a:blipFill>
-                    <a:blip r:embed="rId4"/>
-                    <a:stretch>
-                      <a:fillRect t="-26923" b="-50000"/>
-                    </a:stretch>
-                  </a:blipFill>
-                </p:spPr>
-                <p:txBody>
-                  <a:bodyPr/>
-                  <a:lstStyle/>
-                  <a:p>
-                    <a:r>
-                      <a:rPr lang="ko-KR" altLang="en-US">
-                        <a:noFill/>
-                      </a:rPr>
-                      <a:t> </a:t>
-                    </a:r>
-                  </a:p>
-                </p:txBody>
-              </p:sp>
-            </mc:Fallback>
-          </mc:AlternateContent>
-          <mc:AlternateContent xmlns:mc="http://schemas.openxmlformats.org/markup-compatibility/2006" xmlns:a14="http://schemas.microsoft.com/office/drawing/2010/main">
-            <mc:Choice Requires="a14">
-              <p:sp>
-                <p:nvSpPr>
-                  <p:cNvPr id="51" name="TextBox 50">
-                    <a:extLst>
-                      <a:ext uri="{FF2B5EF4-FFF2-40B4-BE49-F238E27FC236}">
-                        <a16:creationId xmlns:a16="http://schemas.microsoft.com/office/drawing/2014/main" id="{5FA0D53B-4563-1417-900B-0BEF02EEE23A}"/>
-                      </a:ext>
-                    </a:extLst>
-                  </p:cNvPr>
-                  <p:cNvSpPr txBox="1"/>
-                  <p:nvPr/>
-                </p:nvSpPr>
-                <p:spPr>
-                  <a:xfrm>
-                    <a:off x="10256486" y="4341312"/>
-                    <a:ext cx="1737360" cy="181609"/>
-                  </a:xfrm>
-                  <a:prstGeom prst="rect">
-                    <a:avLst/>
-                  </a:prstGeom>
-                  <a:noFill/>
-                </p:spPr>
-                <p:txBody>
-                  <a:bodyPr wrap="square" lIns="0" tIns="0" rIns="0" bIns="0" anchor="ctr">
-                    <a:spAutoFit/>
-                  </a:bodyPr>
-                  <a:lstStyle/>
-                  <a:p>
-                    <a:pPr algn="ctr"/>
-                    <a:r>
-                      <a:rPr lang="en-US" sz="1050" b="1" i="0" dirty="0">
-                        <a:solidFill>
-                          <a:srgbClr val="C0392B"/>
-                        </a:solidFill>
-                        <a:latin typeface="Arial"/>
-                      </a:rPr>
-                      <a:t>C</a:t>
-                    </a:r>
-                    <a:r>
-                      <a:rPr sz="1050" b="1" i="0" dirty="0">
-                        <a:solidFill>
-                          <a:srgbClr val="C0392B"/>
-                        </a:solidFill>
-                        <a:latin typeface="Arial"/>
-                      </a:rPr>
-                      <a:t>radle walls </a:t>
-                    </a:r>
-                    <a14:m>
-                      <m:oMath xmlns:m="http://schemas.openxmlformats.org/officeDocument/2006/math">
-                        <m:r>
-                          <a:rPr lang="ko-KR" altLang="en-US" sz="1050" b="1" i="1">
-                            <a:solidFill>
-                              <a:srgbClr val="C0392B"/>
-                            </a:solidFill>
-                            <a:latin typeface="Cambria Math" panose="02040503050406030204" pitchFamily="18" charset="0"/>
-                          </a:rPr>
-                          <m:t>∈</m:t>
-                        </m:r>
-                        <m:r>
-                          <a:rPr lang="ko-KR" altLang="en-US" sz="1050" b="1" i="1">
-                            <a:solidFill>
-                              <a:srgbClr val="C0392B"/>
-                            </a:solidFill>
-                            <a:latin typeface="Cambria Math" panose="02040503050406030204" pitchFamily="18" charset="0"/>
-                            <a:ea typeface="Cambria Math" panose="02040503050406030204" pitchFamily="18" charset="0"/>
-                          </a:rPr>
-                          <m:t>𝓕</m:t>
-                        </m:r>
-                      </m:oMath>
-                    </a14:m>
-                    <a:endParaRPr sz="1050" b="1" i="0" dirty="0">
-                      <a:solidFill>
-                        <a:srgbClr val="C0392B"/>
-                      </a:solidFill>
-                      <a:latin typeface="Arial"/>
-                    </a:endParaRPr>
-                  </a:p>
-                </p:txBody>
-              </p:sp>
-            </mc:Choice>
-            <mc:Fallback xmlns="">
-              <p:sp>
-                <p:nvSpPr>
-                  <p:cNvPr id="51" name="TextBox 50">
-                    <a:extLst>
-                      <a:ext uri="{FF2B5EF4-FFF2-40B4-BE49-F238E27FC236}">
-                        <a16:creationId xmlns:a16="http://schemas.microsoft.com/office/drawing/2014/main" id="{5FA0D53B-4563-1417-900B-0BEF02EEE23A}"/>
-                      </a:ext>
-                    </a:extLst>
-                  </p:cNvPr>
-                  <p:cNvSpPr txBox="1">
-                    <a:spLocks noRot="1" noChangeAspect="1" noMove="1" noResize="1" noEditPoints="1" noAdjustHandles="1" noChangeArrowheads="1" noChangeShapeType="1" noTextEdit="1"/>
-                  </p:cNvSpPr>
-                  <p:nvPr/>
-                </p:nvSpPr>
-                <p:spPr>
-                  <a:xfrm>
-                    <a:off x="10256486" y="4341312"/>
-                    <a:ext cx="1737360" cy="181609"/>
-                  </a:xfrm>
-                  <a:prstGeom prst="rect">
-                    <a:avLst/>
-                  </a:prstGeom>
-                  <a:blipFill>
-                    <a:blip r:embed="rId5"/>
-                    <a:stretch>
-                      <a:fillRect t="-26923" b="-53846"/>
-                    </a:stretch>
-                  </a:blipFill>
-                </p:spPr>
-                <p:txBody>
-                  <a:bodyPr/>
-                  <a:lstStyle/>
-                  <a:p>
-                    <a:r>
-                      <a:rPr lang="ko-KR" altLang="en-US">
-                        <a:noFill/>
-                      </a:rPr>
-                      <a:t> </a:t>
-                    </a:r>
-                  </a:p>
-                </p:txBody>
-              </p:sp>
-            </mc:Fallback>
-          </mc:AlternateContent>
-          <p:grpSp>
-            <p:nvGrpSpPr>
-              <p:cNvPr id="91" name="그룹 90">
-                <a:extLst>
-                  <a:ext uri="{FF2B5EF4-FFF2-40B4-BE49-F238E27FC236}">
-                    <a16:creationId xmlns:a16="http://schemas.microsoft.com/office/drawing/2014/main" id="{F0450F82-CC08-EA1E-8777-9CFA82134FD8}"/>
-                  </a:ext>
-                </a:extLst>
-              </p:cNvPr>
-              <p:cNvGrpSpPr/>
-              <p:nvPr/>
-            </p:nvGrpSpPr>
-            <p:grpSpPr>
-              <a:xfrm>
-                <a:off x="9610317" y="3440897"/>
-                <a:ext cx="1772290" cy="871097"/>
-                <a:chOff x="7609842" y="3689133"/>
-                <a:chExt cx="2338830" cy="1149557"/>
-              </a:xfrm>
-            </p:grpSpPr>
-            <p:grpSp>
-              <p:nvGrpSpPr>
-                <p:cNvPr id="89" name="그룹 88">
-                  <a:extLst>
-                    <a:ext uri="{FF2B5EF4-FFF2-40B4-BE49-F238E27FC236}">
-                      <a16:creationId xmlns:a16="http://schemas.microsoft.com/office/drawing/2014/main" id="{DBD66AA6-2578-D289-6CCA-E422E1496EF0}"/>
-                    </a:ext>
-                  </a:extLst>
-                </p:cNvPr>
-                <p:cNvGrpSpPr/>
-                <p:nvPr/>
-              </p:nvGrpSpPr>
-              <p:grpSpPr>
-                <a:xfrm>
-                  <a:off x="7614075" y="3689133"/>
-                  <a:ext cx="2334597" cy="1149557"/>
-                  <a:chOff x="7447280" y="3841662"/>
-                  <a:chExt cx="2334597" cy="1149557"/>
-                </a:xfrm>
-              </p:grpSpPr>
-              <p:pic>
-                <p:nvPicPr>
-                  <p:cNvPr id="73" name="그림 72">
-                    <a:extLst>
-                      <a:ext uri="{FF2B5EF4-FFF2-40B4-BE49-F238E27FC236}">
-                        <a16:creationId xmlns:a16="http://schemas.microsoft.com/office/drawing/2014/main" id="{D25F8341-DA89-F3A7-409F-81BFE6AF6937}"/>
-                      </a:ext>
-                    </a:extLst>
-                  </p:cNvPr>
-                  <p:cNvPicPr>
-                    <a:picLocks noChangeAspect="1"/>
-                  </p:cNvPicPr>
-                  <p:nvPr/>
-                </p:nvPicPr>
-                <p:blipFill>
-                  <a:blip r:embed="rId2"/>
-                  <a:srcRect t="20686" b="23574"/>
-                  <a:stretch>
-                    <a:fillRect/>
-                  </a:stretch>
-                </p:blipFill>
-                <p:spPr>
-                  <a:xfrm rot="10800000">
-                    <a:off x="7447280" y="3850128"/>
-                    <a:ext cx="2272876" cy="1141091"/>
-                  </a:xfrm>
-                  <a:prstGeom prst="rect">
-                    <a:avLst/>
-                  </a:prstGeom>
-                </p:spPr>
-              </p:pic>
-              <p:sp>
-                <p:nvSpPr>
-                  <p:cNvPr id="87" name="자유형: 도형 86">
-                    <a:extLst>
-                      <a:ext uri="{FF2B5EF4-FFF2-40B4-BE49-F238E27FC236}">
-                        <a16:creationId xmlns:a16="http://schemas.microsoft.com/office/drawing/2014/main" id="{512C4FC6-179E-7D9D-64E8-27A745264EB8}"/>
-                      </a:ext>
-                    </a:extLst>
-                  </p:cNvPr>
-                  <p:cNvSpPr/>
-                  <p:nvPr/>
-                </p:nvSpPr>
-                <p:spPr>
-                  <a:xfrm>
-                    <a:off x="7447280" y="3841662"/>
-                    <a:ext cx="2334597" cy="1141092"/>
-                  </a:xfrm>
-                  <a:custGeom>
-                    <a:avLst/>
-                    <a:gdLst>
-                      <a:gd name="csX0" fmla="*/ 1815251 w 2334597"/>
-                      <a:gd name="csY0" fmla="*/ 0 h 1141092"/>
-                      <a:gd name="csX1" fmla="*/ 2334597 w 2334597"/>
-                      <a:gd name="csY1" fmla="*/ 0 h 1141092"/>
-                      <a:gd name="csX2" fmla="*/ 2334597 w 2334597"/>
-                      <a:gd name="csY2" fmla="*/ 1141092 h 1141092"/>
-                      <a:gd name="csX3" fmla="*/ 2332567 w 2334597"/>
-                      <a:gd name="csY3" fmla="*/ 1141092 h 1141092"/>
-                      <a:gd name="csX4" fmla="*/ 1815251 w 2334597"/>
-                      <a:gd name="csY4" fmla="*/ 1141092 h 1141092"/>
-                      <a:gd name="csX5" fmla="*/ 0 w 2334597"/>
-                      <a:gd name="csY5" fmla="*/ 1141092 h 1141092"/>
-                      <a:gd name="csX6" fmla="*/ 0 w 2334597"/>
-                      <a:gd name="csY6" fmla="*/ 778422 h 1141092"/>
-                      <a:gd name="csX7" fmla="*/ 1815251 w 2334597"/>
-                      <a:gd name="csY7" fmla="*/ 778422 h 1141092"/>
-                      <a:gd name="csX8" fmla="*/ 1815251 w 2334597"/>
-                      <a:gd name="csY8" fmla="*/ 362671 h 1141092"/>
-                      <a:gd name="csX9" fmla="*/ 0 w 2334597"/>
-                      <a:gd name="csY9" fmla="*/ 362671 h 1141092"/>
-                      <a:gd name="csX10" fmla="*/ 0 w 2334597"/>
-                      <a:gd name="csY10" fmla="*/ 1 h 1141092"/>
-                      <a:gd name="csX11" fmla="*/ 1815251 w 2334597"/>
-                      <a:gd name="csY11" fmla="*/ 1 h 1141092"/>
-                    </a:gdLst>
-                    <a:ahLst/>
-                    <a:cxnLst>
-                      <a:cxn ang="0">
-                        <a:pos x="csX0" y="csY0"/>
-                      </a:cxn>
-                      <a:cxn ang="0">
-                        <a:pos x="csX1" y="csY1"/>
-                      </a:cxn>
-                      <a:cxn ang="0">
-                        <a:pos x="csX2" y="csY2"/>
-                      </a:cxn>
-                      <a:cxn ang="0">
-                        <a:pos x="csX3" y="csY3"/>
-                      </a:cxn>
-                      <a:cxn ang="0">
-                        <a:pos x="csX4" y="csY4"/>
-                      </a:cxn>
-                      <a:cxn ang="0">
-                        <a:pos x="csX5" y="csY5"/>
-                      </a:cxn>
-                      <a:cxn ang="0">
-                        <a:pos x="csX6" y="csY6"/>
-                      </a:cxn>
-                      <a:cxn ang="0">
-                        <a:pos x="csX7" y="csY7"/>
-                      </a:cxn>
-                      <a:cxn ang="0">
-                        <a:pos x="csX8" y="csY8"/>
-                      </a:cxn>
-                      <a:cxn ang="0">
-                        <a:pos x="csX9" y="csY9"/>
-                      </a:cxn>
-                      <a:cxn ang="0">
-                        <a:pos x="csX10" y="csY10"/>
-                      </a:cxn>
-                      <a:cxn ang="0">
-                        <a:pos x="csX11" y="csY11"/>
-                      </a:cxn>
-                    </a:cxnLst>
-                    <a:rect l="l" t="t" r="r" b="b"/>
-                    <a:pathLst>
-                      <a:path w="2334597" h="1141092">
-                        <a:moveTo>
-                          <a:pt x="1815251" y="0"/>
-                        </a:moveTo>
-                        <a:lnTo>
-                          <a:pt x="2334597" y="0"/>
-                        </a:lnTo>
-                        <a:lnTo>
-                          <a:pt x="2334597" y="1141092"/>
-                        </a:lnTo>
-                        <a:lnTo>
-                          <a:pt x="2332567" y="1141092"/>
-                        </a:lnTo>
-                        <a:lnTo>
-                          <a:pt x="1815251" y="1141092"/>
-                        </a:lnTo>
-                        <a:lnTo>
-                          <a:pt x="0" y="1141092"/>
-                        </a:lnTo>
-                        <a:lnTo>
-                          <a:pt x="0" y="778422"/>
-                        </a:lnTo>
-                        <a:lnTo>
-                          <a:pt x="1815251" y="778422"/>
-                        </a:lnTo>
-                        <a:lnTo>
-                          <a:pt x="1815251" y="362671"/>
-                        </a:lnTo>
-                        <a:lnTo>
-                          <a:pt x="0" y="362671"/>
-                        </a:lnTo>
-                        <a:lnTo>
-                          <a:pt x="0" y="1"/>
-                        </a:lnTo>
-                        <a:lnTo>
-                          <a:pt x="1815251" y="1"/>
-                        </a:lnTo>
-                        <a:close/>
-                      </a:path>
-                    </a:pathLst>
-                  </a:custGeom>
-                  <a:solidFill>
-                    <a:schemeClr val="accent6">
-                      <a:lumMod val="40000"/>
-                      <a:lumOff val="60000"/>
-                      <a:alpha val="51000"/>
-                    </a:schemeClr>
-                  </a:solidFill>
-                  <a:ln>
-                    <a:solidFill>
-                      <a:srgbClr val="FF6600"/>
-                    </a:solidFill>
-                    <a:prstDash val="dash"/>
-                  </a:ln>
-                </p:spPr>
-                <p:style>
-                  <a:lnRef idx="2">
-                    <a:schemeClr val="dk1"/>
-                  </a:lnRef>
-                  <a:fillRef idx="1">
-                    <a:schemeClr val="lt1"/>
-                  </a:fillRef>
-                  <a:effectRef idx="0">
-                    <a:schemeClr val="dk1"/>
-                  </a:effectRef>
-                  <a:fontRef idx="minor">
-                    <a:schemeClr val="dk1"/>
-                  </a:fontRef>
-                </p:style>
-                <p:txBody>
-                  <a:bodyPr wrap="square" rtlCol="0" anchor="ctr">
-                    <a:noAutofit/>
-                  </a:bodyPr>
-                  <a:lstStyle/>
-                  <a:p>
-                    <a:pPr algn="ctr"/>
-                    <a:endParaRPr lang="ko-KR" altLang="en-US">
-                      <a:ln w="0"/>
-                      <a:solidFill>
-                        <a:schemeClr val="tx1"/>
-                      </a:solidFill>
-                      <a:effectLst>
-                        <a:outerShdw blurRad="38100" dist="19050" dir="2700000" algn="tl" rotWithShape="0">
-                          <a:schemeClr val="dk1">
-                            <a:alpha val="40000"/>
-                          </a:schemeClr>
-                        </a:outerShdw>
-                      </a:effectLst>
-                    </a:endParaRPr>
-                  </a:p>
-                </p:txBody>
-              </p:sp>
-            </p:grpSp>
-            <p:sp>
-              <p:nvSpPr>
-                <p:cNvPr id="90" name="직사각형 89">
-                  <a:extLst>
-                    <a:ext uri="{FF2B5EF4-FFF2-40B4-BE49-F238E27FC236}">
-                      <a16:creationId xmlns:a16="http://schemas.microsoft.com/office/drawing/2014/main" id="{6F61FD2A-63A4-591F-7E15-EAE37CC0E3C7}"/>
-                    </a:ext>
-                  </a:extLst>
-                </p:cNvPr>
-                <p:cNvSpPr/>
-                <p:nvPr/>
-              </p:nvSpPr>
-              <p:spPr>
-                <a:xfrm>
-                  <a:off x="7609842" y="4092811"/>
-                  <a:ext cx="1775459" cy="329868"/>
-                </a:xfrm>
-                <a:prstGeom prst="rect">
-                  <a:avLst/>
-                </a:prstGeom>
-                <a:solidFill>
-                  <a:schemeClr val="accent3">
-                    <a:lumMod val="20000"/>
-                    <a:lumOff val="80000"/>
-                  </a:schemeClr>
-                </a:solidFill>
-                <a:ln w="19050">
-                  <a:solidFill>
-                    <a:schemeClr val="accent3">
-                      <a:lumMod val="75000"/>
-                    </a:schemeClr>
-                  </a:solidFill>
-                  <a:prstDash val="sysDot"/>
-                </a:ln>
-              </p:spPr>
-              <p:style>
-                <a:lnRef idx="2">
-                  <a:schemeClr val="dk1"/>
-                </a:lnRef>
-                <a:fillRef idx="1">
-                  <a:schemeClr val="lt1"/>
-                </a:fillRef>
-                <a:effectRef idx="0">
-                  <a:schemeClr val="dk1"/>
-                </a:effectRef>
-                <a:fontRef idx="minor">
-                  <a:schemeClr val="dk1"/>
-                </a:fontRef>
-              </p:style>
-              <p:txBody>
-                <a:bodyPr rtlCol="0" anchor="ctr"/>
-                <a:lstStyle/>
-                <a:p>
-                  <a:pPr algn="ctr"/>
-                  <a:endParaRPr lang="ko-KR" altLang="en-US"/>
-                </a:p>
-              </p:txBody>
-            </p:sp>
-          </p:grpSp>
-          <p:grpSp>
-            <p:nvGrpSpPr>
-              <p:cNvPr id="94" name="그룹 93">
-                <a:extLst>
-                  <a:ext uri="{FF2B5EF4-FFF2-40B4-BE49-F238E27FC236}">
-                    <a16:creationId xmlns:a16="http://schemas.microsoft.com/office/drawing/2014/main" id="{C8146ABF-E913-B1AB-2CDA-32CA10753CB8}"/>
-                  </a:ext>
-                </a:extLst>
-              </p:cNvPr>
-              <p:cNvGrpSpPr/>
-              <p:nvPr/>
-            </p:nvGrpSpPr>
-            <p:grpSpPr>
-              <a:xfrm rot="21238330">
-                <a:off x="8452894" y="3780929"/>
-                <a:ext cx="1185669" cy="387770"/>
-                <a:chOff x="6083109" y="4170560"/>
-                <a:chExt cx="1564687" cy="511727"/>
-              </a:xfrm>
-            </p:grpSpPr>
-            <p:pic>
-              <p:nvPicPr>
-                <p:cNvPr id="82" name="그림 81">
-                  <a:extLst>
-                    <a:ext uri="{FF2B5EF4-FFF2-40B4-BE49-F238E27FC236}">
-                      <a16:creationId xmlns:a16="http://schemas.microsoft.com/office/drawing/2014/main" id="{A6CF955F-5F3C-4C05-0B43-7FFE00BE1A7D}"/>
-                    </a:ext>
-                  </a:extLst>
-                </p:cNvPr>
-                <p:cNvPicPr>
-                  <a:picLocks noChangeAspect="1"/>
-                </p:cNvPicPr>
-                <p:nvPr/>
-              </p:nvPicPr>
-              <p:blipFill>
-                <a:blip r:embed="rId3"/>
-                <a:srcRect l="10392" t="79073" r="57408" b="8050"/>
-                <a:stretch>
-                  <a:fillRect/>
-                </a:stretch>
-              </p:blipFill>
-              <p:spPr>
-                <a:xfrm rot="21278377">
-                  <a:off x="6083109" y="4170560"/>
-                  <a:ext cx="1564077" cy="511727"/>
-                </a:xfrm>
-                <a:prstGeom prst="rect">
-                  <a:avLst/>
-                </a:prstGeom>
-              </p:spPr>
-            </p:pic>
-            <p:sp>
-              <p:nvSpPr>
-                <p:cNvPr id="93" name="타원 92">
-                  <a:extLst>
-                    <a:ext uri="{FF2B5EF4-FFF2-40B4-BE49-F238E27FC236}">
-                      <a16:creationId xmlns:a16="http://schemas.microsoft.com/office/drawing/2014/main" id="{346891C5-9981-E578-9C5D-045380BD025B}"/>
-                    </a:ext>
-                  </a:extLst>
-                </p:cNvPr>
-                <p:cNvSpPr/>
-                <p:nvPr/>
-              </p:nvSpPr>
-              <p:spPr>
-                <a:xfrm flipH="1">
-                  <a:off x="7573423" y="4308006"/>
-                  <a:ext cx="74373" cy="74373"/>
-                </a:xfrm>
-                <a:prstGeom prst="ellipse">
-                  <a:avLst/>
-                </a:prstGeom>
-                <a:solidFill>
-                  <a:schemeClr val="accent5">
-                    <a:lumMod val="40000"/>
-                    <a:lumOff val="60000"/>
-                  </a:schemeClr>
-                </a:solidFill>
-                <a:ln>
-                  <a:solidFill>
-                    <a:schemeClr val="accent1"/>
-                  </a:solidFill>
-                </a:ln>
-              </p:spPr>
-              <p:style>
-                <a:lnRef idx="2">
-                  <a:schemeClr val="dk1"/>
-                </a:lnRef>
-                <a:fillRef idx="1">
-                  <a:schemeClr val="lt1"/>
-                </a:fillRef>
-                <a:effectRef idx="0">
-                  <a:schemeClr val="dk1"/>
-                </a:effectRef>
-                <a:fontRef idx="minor">
-                  <a:schemeClr val="dk1"/>
-                </a:fontRef>
-              </p:style>
-              <p:txBody>
-                <a:bodyPr rtlCol="0" anchor="ctr"/>
-                <a:lstStyle/>
-                <a:p>
-                  <a:pPr algn="ctr"/>
-                  <a:endParaRPr lang="ko-KR" altLang="en-US"/>
-                </a:p>
-              </p:txBody>
-            </p:sp>
-          </p:grpSp>
-          <p:cxnSp>
-            <p:nvCxnSpPr>
-              <p:cNvPr id="97" name="Connector 9">
-                <a:extLst>
-                  <a:ext uri="{FF2B5EF4-FFF2-40B4-BE49-F238E27FC236}">
-                    <a16:creationId xmlns:a16="http://schemas.microsoft.com/office/drawing/2014/main" id="{E275C861-9756-3EF4-6723-7A70B679B381}"/>
-                  </a:ext>
-                </a:extLst>
-              </p:cNvPr>
-              <p:cNvCxnSpPr>
-                <a:cxnSpLocks/>
-              </p:cNvCxnSpPr>
-              <p:nvPr/>
-            </p:nvCxnSpPr>
-            <p:spPr>
-              <a:xfrm>
-                <a:off x="7899150" y="3440897"/>
-                <a:ext cx="1670666" cy="0"/>
-              </a:xfrm>
-              <a:prstGeom prst="line">
-                <a:avLst/>
-              </a:prstGeom>
-              <a:ln w="25400">
-                <a:solidFill>
-                  <a:srgbClr val="FF6600"/>
-                </a:solidFill>
-                <a:prstDash val="dash"/>
-              </a:ln>
-              <a:effectLst/>
-            </p:spPr>
-            <p:style>
-              <a:lnRef idx="1">
-                <a:schemeClr val="dk1"/>
-              </a:lnRef>
-              <a:fillRef idx="0">
-                <a:schemeClr val="dk1"/>
-              </a:fillRef>
-              <a:effectRef idx="0">
-                <a:schemeClr val="dk1"/>
-              </a:effectRef>
-              <a:fontRef idx="minor">
-                <a:schemeClr val="tx1"/>
-              </a:fontRef>
-            </p:style>
-          </p:cxnSp>
-          <p:cxnSp>
-            <p:nvCxnSpPr>
-              <p:cNvPr id="103" name="Connector 9">
-                <a:extLst>
-                  <a:ext uri="{FF2B5EF4-FFF2-40B4-BE49-F238E27FC236}">
-                    <a16:creationId xmlns:a16="http://schemas.microsoft.com/office/drawing/2014/main" id="{EE2B2BC7-052D-8386-057B-7CFE4FB23CFD}"/>
-                  </a:ext>
-                </a:extLst>
-              </p:cNvPr>
-              <p:cNvCxnSpPr>
-                <a:cxnSpLocks/>
-              </p:cNvCxnSpPr>
-              <p:nvPr/>
-            </p:nvCxnSpPr>
-            <p:spPr>
-              <a:xfrm>
-                <a:off x="11419059" y="3440897"/>
-                <a:ext cx="337264" cy="0"/>
-              </a:xfrm>
-              <a:prstGeom prst="line">
-                <a:avLst/>
-              </a:prstGeom>
-              <a:ln w="25400">
-                <a:solidFill>
-                  <a:srgbClr val="FF6600"/>
-                </a:solidFill>
-                <a:prstDash val="dash"/>
-              </a:ln>
-              <a:effectLst/>
-            </p:spPr>
-            <p:style>
-              <a:lnRef idx="1">
-                <a:schemeClr val="dk1"/>
-              </a:lnRef>
-              <a:fillRef idx="0">
-                <a:schemeClr val="dk1"/>
-              </a:fillRef>
-              <a:effectRef idx="0">
-                <a:schemeClr val="dk1"/>
-              </a:effectRef>
-              <a:fontRef idx="minor">
-                <a:schemeClr val="tx1"/>
-              </a:fontRef>
-            </p:style>
-          </p:cxnSp>
-          <p:sp>
-            <p:nvSpPr>
-              <p:cNvPr id="106" name="Rectangle 8">
-                <a:extLst>
-                  <a:ext uri="{FF2B5EF4-FFF2-40B4-BE49-F238E27FC236}">
-                    <a16:creationId xmlns:a16="http://schemas.microsoft.com/office/drawing/2014/main" id="{D63A9DB3-3BF9-CD46-3B75-88998D35A639}"/>
-                  </a:ext>
-                </a:extLst>
-              </p:cNvPr>
-              <p:cNvSpPr/>
-              <p:nvPr/>
-            </p:nvSpPr>
-            <p:spPr>
-              <a:xfrm>
-                <a:off x="7807841" y="3361380"/>
-                <a:ext cx="3948481" cy="72140"/>
-              </a:xfrm>
-              <a:prstGeom prst="rect">
-                <a:avLst/>
-              </a:prstGeom>
-              <a:solidFill>
-                <a:srgbClr val="FBE9DA"/>
-              </a:solidFill>
-              <a:ln>
-                <a:noFill/>
-              </a:ln>
-              <a:effectLst/>
-            </p:spPr>
-            <p:style>
-              <a:lnRef idx="1">
-                <a:schemeClr val="accent1"/>
-              </a:lnRef>
-              <a:fillRef idx="3">
-                <a:schemeClr val="accent1"/>
-              </a:fillRef>
-              <a:effectRef idx="2">
-                <a:schemeClr val="accent1"/>
-              </a:effectRef>
-              <a:fontRef idx="minor">
-                <a:schemeClr val="lt1"/>
-              </a:fontRef>
-            </p:style>
-            <p:txBody>
-              <a:bodyPr rtlCol="0" anchor="ctr"/>
-              <a:lstStyle/>
-              <a:p>
-                <a:pPr algn="ctr"/>
-                <a:endParaRPr/>
-              </a:p>
-            </p:txBody>
-          </p:sp>
-          <p:pic>
-            <p:nvPicPr>
-              <p:cNvPr id="127" name="그림 126">
-                <a:extLst>
-                  <a:ext uri="{FF2B5EF4-FFF2-40B4-BE49-F238E27FC236}">
-                    <a16:creationId xmlns:a16="http://schemas.microsoft.com/office/drawing/2014/main" id="{9490E217-03EE-92A6-AFB3-CC4D16E14C1C}"/>
+                    <a16:creationId xmlns:a16="http://schemas.microsoft.com/office/drawing/2014/main" id="{8577C202-23F8-E9FB-45DD-B5D7D3E121E8}"/>
                   </a:ext>
                 </a:extLst>
               </p:cNvPr>
@@ -8086,34 +7446,66 @@
               <p:nvPr/>
             </p:nvPicPr>
             <p:blipFill>
-              <a:blip r:embed="rId3"/>
-              <a:srcRect l="10016" t="25048" r="29812" b="66394"/>
+              <a:blip r:embed="rId2"/>
+              <a:srcRect t="20686" b="23574"/>
               <a:stretch>
                 <a:fillRect/>
               </a:stretch>
             </p:blipFill>
             <p:spPr>
+              <a:xfrm rot="10800000">
+                <a:off x="7447280" y="3850128"/>
+                <a:ext cx="2272876" cy="1141091"/>
+              </a:xfrm>
+              <a:prstGeom prst="rect">
+                <a:avLst/>
+              </a:prstGeom>
+            </p:spPr>
+          </p:pic>
+          <p:sp>
+            <p:nvSpPr>
+              <p:cNvPr id="87" name="자유형: 도형 86">
+                <a:extLst>
+                  <a:ext uri="{FF2B5EF4-FFF2-40B4-BE49-F238E27FC236}">
+                    <a16:creationId xmlns:a16="http://schemas.microsoft.com/office/drawing/2014/main" id="{0E0B40C5-09F2-9025-13AE-E36868BB3B0E}"/>
+                  </a:ext>
+                </a:extLst>
+              </p:cNvPr>
+              <p:cNvSpPr/>
+              <p:nvPr/>
+            </p:nvSpPr>
+            <p:spPr>
               <a:xfrm>
-                <a:off x="7619108" y="3028205"/>
-                <a:ext cx="4325946" cy="410168"/>
+                <a:off x="7447280" y="3841662"/>
+                <a:ext cx="2334597" cy="1141092"/>
               </a:xfrm>
               <a:custGeom>
                 <a:avLst/>
                 <a:gdLst>
-                  <a:gd name="csX0" fmla="*/ 271498 w 4325946"/>
-                  <a:gd name="csY0" fmla="*/ 0 h 410168"/>
-                  <a:gd name="csX1" fmla="*/ 4054448 w 4325946"/>
-                  <a:gd name="csY1" fmla="*/ 0 h 410168"/>
-                  <a:gd name="csX2" fmla="*/ 4325946 w 4325946"/>
-                  <a:gd name="csY2" fmla="*/ 271498 h 410168"/>
-                  <a:gd name="csX3" fmla="*/ 4325946 w 4325946"/>
-                  <a:gd name="csY3" fmla="*/ 410168 h 410168"/>
-                  <a:gd name="csX4" fmla="*/ 0 w 4325946"/>
-                  <a:gd name="csY4" fmla="*/ 410168 h 410168"/>
-                  <a:gd name="csX5" fmla="*/ 0 w 4325946"/>
-                  <a:gd name="csY5" fmla="*/ 271498 h 410168"/>
-                  <a:gd name="csX6" fmla="*/ 271498 w 4325946"/>
-                  <a:gd name="csY6" fmla="*/ 0 h 410168"/>
+                  <a:gd name="csX0" fmla="*/ 1815251 w 2334597"/>
+                  <a:gd name="csY0" fmla="*/ 0 h 1141092"/>
+                  <a:gd name="csX1" fmla="*/ 2334597 w 2334597"/>
+                  <a:gd name="csY1" fmla="*/ 0 h 1141092"/>
+                  <a:gd name="csX2" fmla="*/ 2334597 w 2334597"/>
+                  <a:gd name="csY2" fmla="*/ 1141092 h 1141092"/>
+                  <a:gd name="csX3" fmla="*/ 2332567 w 2334597"/>
+                  <a:gd name="csY3" fmla="*/ 1141092 h 1141092"/>
+                  <a:gd name="csX4" fmla="*/ 1815251 w 2334597"/>
+                  <a:gd name="csY4" fmla="*/ 1141092 h 1141092"/>
+                  <a:gd name="csX5" fmla="*/ 0 w 2334597"/>
+                  <a:gd name="csY5" fmla="*/ 1141092 h 1141092"/>
+                  <a:gd name="csX6" fmla="*/ 0 w 2334597"/>
+                  <a:gd name="csY6" fmla="*/ 778422 h 1141092"/>
+                  <a:gd name="csX7" fmla="*/ 1815251 w 2334597"/>
+                  <a:gd name="csY7" fmla="*/ 778422 h 1141092"/>
+                  <a:gd name="csX8" fmla="*/ 1815251 w 2334597"/>
+                  <a:gd name="csY8" fmla="*/ 362671 h 1141092"/>
+                  <a:gd name="csX9" fmla="*/ 0 w 2334597"/>
+                  <a:gd name="csY9" fmla="*/ 362671 h 1141092"/>
+                  <a:gd name="csX10" fmla="*/ 0 w 2334597"/>
+                  <a:gd name="csY10" fmla="*/ 1 h 1141092"/>
+                  <a:gd name="csX11" fmla="*/ 1815251 w 2334597"/>
+                  <a:gd name="csY11" fmla="*/ 1 h 1141092"/>
                 </a:gdLst>
                 <a:ahLst/>
                 <a:cxnLst>
@@ -8138,196 +7530,762 @@
                   <a:cxn ang="0">
                     <a:pos x="csX6" y="csY6"/>
                   </a:cxn>
+                  <a:cxn ang="0">
+                    <a:pos x="csX7" y="csY7"/>
+                  </a:cxn>
+                  <a:cxn ang="0">
+                    <a:pos x="csX8" y="csY8"/>
+                  </a:cxn>
+                  <a:cxn ang="0">
+                    <a:pos x="csX9" y="csY9"/>
+                  </a:cxn>
+                  <a:cxn ang="0">
+                    <a:pos x="csX10" y="csY10"/>
+                  </a:cxn>
+                  <a:cxn ang="0">
+                    <a:pos x="csX11" y="csY11"/>
+                  </a:cxn>
                 </a:cxnLst>
                 <a:rect l="l" t="t" r="r" b="b"/>
                 <a:pathLst>
-                  <a:path w="4325946" h="410168">
+                  <a:path w="2334597" h="1141092">
                     <a:moveTo>
-                      <a:pt x="271498" y="0"/>
+                      <a:pt x="1815251" y="0"/>
                     </a:moveTo>
                     <a:lnTo>
-                      <a:pt x="4054448" y="0"/>
-                    </a:lnTo>
-                    <a:cubicBezTo>
-                      <a:pt x="4204392" y="0"/>
-                      <a:pt x="4325946" y="121554"/>
-                      <a:pt x="4325946" y="271498"/>
-                    </a:cubicBezTo>
-                    <a:lnTo>
-                      <a:pt x="4325946" y="410168"/>
+                      <a:pt x="2334597" y="0"/>
                     </a:lnTo>
                     <a:lnTo>
-                      <a:pt x="0" y="410168"/>
+                      <a:pt x="2334597" y="1141092"/>
                     </a:lnTo>
                     <a:lnTo>
-                      <a:pt x="0" y="271498"/>
+                      <a:pt x="2332567" y="1141092"/>
                     </a:lnTo>
-                    <a:cubicBezTo>
-                      <a:pt x="0" y="121554"/>
-                      <a:pt x="121554" y="0"/>
-                      <a:pt x="271498" y="0"/>
-                    </a:cubicBezTo>
+                    <a:lnTo>
+                      <a:pt x="1815251" y="1141092"/>
+                    </a:lnTo>
+                    <a:lnTo>
+                      <a:pt x="0" y="1141092"/>
+                    </a:lnTo>
+                    <a:lnTo>
+                      <a:pt x="0" y="778422"/>
+                    </a:lnTo>
+                    <a:lnTo>
+                      <a:pt x="1815251" y="778422"/>
+                    </a:lnTo>
+                    <a:lnTo>
+                      <a:pt x="1815251" y="362671"/>
+                    </a:lnTo>
+                    <a:lnTo>
+                      <a:pt x="0" y="362671"/>
+                    </a:lnTo>
+                    <a:lnTo>
+                      <a:pt x="0" y="1"/>
+                    </a:lnTo>
+                    <a:lnTo>
+                      <a:pt x="1815251" y="1"/>
+                    </a:lnTo>
                     <a:close/>
                   </a:path>
                 </a:pathLst>
               </a:custGeom>
+              <a:solidFill>
+                <a:schemeClr val="accent6">
+                  <a:lumMod val="40000"/>
+                  <a:lumOff val="60000"/>
+                  <a:alpha val="51000"/>
+                </a:schemeClr>
+              </a:solidFill>
+              <a:ln>
+                <a:solidFill>
+                  <a:srgbClr val="FF6600"/>
+                </a:solidFill>
+                <a:prstDash val="dash"/>
+              </a:ln>
             </p:spPr>
-          </p:pic>
-          <mc:AlternateContent xmlns:mc="http://schemas.openxmlformats.org/markup-compatibility/2006" xmlns:a14="http://schemas.microsoft.com/office/drawing/2010/main">
-            <mc:Choice Requires="a14">
-              <p:sp>
-                <p:nvSpPr>
-                  <p:cNvPr id="109" name="TextBox 108">
-                    <a:extLst>
-                      <a:ext uri="{FF2B5EF4-FFF2-40B4-BE49-F238E27FC236}">
-                        <a16:creationId xmlns:a16="http://schemas.microsoft.com/office/drawing/2014/main" id="{943FFFBF-7D14-5601-0E75-3C81B9BE8DE1}"/>
-                      </a:ext>
-                    </a:extLst>
-                  </p:cNvPr>
-                  <p:cNvSpPr txBox="1"/>
-                  <p:nvPr/>
-                </p:nvSpPr>
-                <p:spPr>
-                  <a:xfrm>
-                    <a:off x="9765621" y="3723852"/>
-                    <a:ext cx="1209537" cy="285385"/>
-                  </a:xfrm>
-                  <a:prstGeom prst="rect">
-                    <a:avLst/>
-                  </a:prstGeom>
-                  <a:noFill/>
-                </p:spPr>
-                <p:txBody>
-                  <a:bodyPr wrap="square">
-                    <a:spAutoFit/>
-                  </a:bodyPr>
-                  <a:lstStyle/>
-                  <a:p>
-                    <a:r>
-                      <a:rPr lang="en-US" altLang="ko-KR" sz="1050" b="1" i="0" dirty="0">
-                        <a:solidFill>
-                          <a:srgbClr val="3E8E3E"/>
-                        </a:solidFill>
-                        <a:latin typeface="Arial"/>
-                      </a:rPr>
-                      <a:t>Target set  </a:t>
-                    </a:r>
-                    <a14:m>
-                      <m:oMath xmlns:m="http://schemas.openxmlformats.org/officeDocument/2006/math">
-                        <m:r>
-                          <a:rPr lang="ko-KR" altLang="en-US" sz="1050" b="1" i="1" smtClean="0">
-                            <a:solidFill>
-                              <a:srgbClr val="3E8E3E"/>
-                            </a:solidFill>
-                            <a:latin typeface="Cambria Math" panose="02040503050406030204" pitchFamily="18" charset="0"/>
-                          </a:rPr>
-                          <m:t>𝓣</m:t>
-                        </m:r>
-                      </m:oMath>
-                    </a14:m>
-                    <a:endParaRPr lang="ko-KR" altLang="en-US" sz="1050" dirty="0"/>
-                  </a:p>
-                </p:txBody>
-              </p:sp>
-            </mc:Choice>
-            <mc:Fallback xmlns="">
-              <p:sp>
-                <p:nvSpPr>
-                  <p:cNvPr id="109" name="TextBox 108">
-                    <a:extLst>
-                      <a:ext uri="{FF2B5EF4-FFF2-40B4-BE49-F238E27FC236}">
-                        <a16:creationId xmlns:a16="http://schemas.microsoft.com/office/drawing/2014/main" id="{943FFFBF-7D14-5601-0E75-3C81B9BE8DE1}"/>
-                      </a:ext>
-                    </a:extLst>
-                  </p:cNvPr>
-                  <p:cNvSpPr txBox="1">
-                    <a:spLocks noRot="1" noChangeAspect="1" noMove="1" noResize="1" noEditPoints="1" noAdjustHandles="1" noChangeArrowheads="1" noChangeShapeType="1" noTextEdit="1"/>
-                  </p:cNvSpPr>
-                  <p:nvPr/>
-                </p:nvSpPr>
-                <p:spPr>
-                  <a:xfrm>
-                    <a:off x="9765621" y="3723852"/>
-                    <a:ext cx="1209537" cy="285385"/>
-                  </a:xfrm>
-                  <a:prstGeom prst="rect">
-                    <a:avLst/>
-                  </a:prstGeom>
-                  <a:blipFill>
-                    <a:blip r:embed="rId6"/>
-                    <a:stretch>
-                      <a:fillRect b="-14634"/>
-                    </a:stretch>
-                  </a:blipFill>
-                </p:spPr>
-                <p:txBody>
-                  <a:bodyPr/>
-                  <a:lstStyle/>
-                  <a:p>
-                    <a:r>
-                      <a:rPr lang="ko-KR" altLang="en-US">
-                        <a:noFill/>
-                      </a:rPr>
-                      <a:t> </a:t>
-                    </a:r>
-                  </a:p>
-                </p:txBody>
-              </p:sp>
-            </mc:Fallback>
-          </mc:AlternateContent>
+            <p:style>
+              <a:lnRef idx="2">
+                <a:schemeClr val="dk1"/>
+              </a:lnRef>
+              <a:fillRef idx="1">
+                <a:schemeClr val="lt1"/>
+              </a:fillRef>
+              <a:effectRef idx="0">
+                <a:schemeClr val="dk1"/>
+              </a:effectRef>
+              <a:fontRef idx="minor">
+                <a:schemeClr val="dk1"/>
+              </a:fontRef>
+            </p:style>
+            <p:txBody>
+              <a:bodyPr wrap="square" rtlCol="0" anchor="ctr">
+                <a:noAutofit/>
+              </a:bodyPr>
+              <a:lstStyle/>
+              <a:p>
+                <a:pPr algn="ctr"/>
+                <a:endParaRPr lang="ko-KR" altLang="en-US">
+                  <a:ln w="0"/>
+                  <a:solidFill>
+                    <a:schemeClr val="tx1"/>
+                  </a:solidFill>
+                  <a:effectLst>
+                    <a:outerShdw blurRad="38100" dist="19050" dir="2700000" algn="tl" rotWithShape="0">
+                      <a:schemeClr val="dk1">
+                        <a:alpha val="40000"/>
+                      </a:schemeClr>
+                    </a:outerShdw>
+                  </a:effectLst>
+                </a:endParaRPr>
+              </a:p>
+            </p:txBody>
+          </p:sp>
         </p:grpSp>
         <p:sp>
           <p:nvSpPr>
-            <p:cNvPr id="22" name="TextBox 21">
+            <p:cNvPr id="90" name="직사각형 89">
               <a:extLst>
                 <a:ext uri="{FF2B5EF4-FFF2-40B4-BE49-F238E27FC236}">
-                  <a16:creationId xmlns:a16="http://schemas.microsoft.com/office/drawing/2014/main" id="{47D8579C-7832-7169-F716-5C5DAC5BE2FB}"/>
+                  <a16:creationId xmlns:a16="http://schemas.microsoft.com/office/drawing/2014/main" id="{C8919171-5BBC-8EB3-FC25-CEC7318E50C8}"/>
                 </a:ext>
               </a:extLst>
             </p:cNvPr>
-            <p:cNvSpPr txBox="1"/>
+            <p:cNvSpPr/>
             <p:nvPr/>
           </p:nvSpPr>
           <p:spPr>
             <a:xfrm>
-              <a:off x="9344094" y="3972646"/>
-              <a:ext cx="3503855" cy="169277"/>
+              <a:off x="7609842" y="4092811"/>
+              <a:ext cx="1775459" cy="329868"/>
             </a:xfrm>
             <a:prstGeom prst="rect">
               <a:avLst/>
             </a:prstGeom>
-            <a:noFill/>
+            <a:solidFill>
+              <a:schemeClr val="accent3">
+                <a:lumMod val="20000"/>
+                <a:lumOff val="80000"/>
+              </a:schemeClr>
+            </a:solidFill>
+            <a:ln w="19050">
+              <a:solidFill>
+                <a:schemeClr val="accent3">
+                  <a:lumMod val="75000"/>
+                </a:schemeClr>
+              </a:solidFill>
+              <a:prstDash val="sysDot"/>
+            </a:ln>
           </p:spPr>
+          <p:style>
+            <a:lnRef idx="2">
+              <a:schemeClr val="dk1"/>
+            </a:lnRef>
+            <a:fillRef idx="1">
+              <a:schemeClr val="lt1"/>
+            </a:fillRef>
+            <a:effectRef idx="0">
+              <a:schemeClr val="dk1"/>
+            </a:effectRef>
+            <a:fontRef idx="minor">
+              <a:schemeClr val="dk1"/>
+            </a:fontRef>
+          </p:style>
           <p:txBody>
-            <a:bodyPr wrap="square" lIns="0" tIns="0" rIns="0" bIns="0" anchor="ctr">
-              <a:spAutoFit/>
-            </a:bodyPr>
+            <a:bodyPr rtlCol="0" anchor="ctr"/>
             <a:lstStyle/>
             <a:p>
               <a:pPr algn="ctr"/>
-              <a:r>
-                <a:rPr lang="en-US" sz="1100" b="1" i="0" dirty="0">
-                  <a:solidFill>
-                    <a:srgbClr val="304055"/>
-                  </a:solidFill>
-                  <a:latin typeface="Arial"/>
-                </a:rPr>
-                <a:t>Target and collision sets</a:t>
-              </a:r>
-              <a:endParaRPr sz="1100" b="1" i="0" dirty="0">
+              <a:endParaRPr lang="ko-KR" altLang="en-US"/>
+            </a:p>
+          </p:txBody>
+        </p:sp>
+      </p:grpSp>
+      <p:grpSp>
+        <p:nvGrpSpPr>
+          <p:cNvPr id="94" name="그룹 93">
+            <a:extLst>
+              <a:ext uri="{FF2B5EF4-FFF2-40B4-BE49-F238E27FC236}">
+                <a16:creationId xmlns:a16="http://schemas.microsoft.com/office/drawing/2014/main" id="{59E80654-ACD6-EEB8-1FFA-5026578C6ADC}"/>
+              </a:ext>
+            </a:extLst>
+          </p:cNvPr>
+          <p:cNvGrpSpPr/>
+          <p:nvPr/>
+        </p:nvGrpSpPr>
+        <p:grpSpPr>
+          <a:xfrm rot="21238330">
+            <a:off x="9033902" y="3126395"/>
+            <a:ext cx="1054926" cy="345011"/>
+            <a:chOff x="6083109" y="4170560"/>
+            <a:chExt cx="1564687" cy="511727"/>
+          </a:xfrm>
+        </p:grpSpPr>
+        <p:pic>
+          <p:nvPicPr>
+            <p:cNvPr id="82" name="그림 81">
+              <a:extLst>
+                <a:ext uri="{FF2B5EF4-FFF2-40B4-BE49-F238E27FC236}">
+                  <a16:creationId xmlns:a16="http://schemas.microsoft.com/office/drawing/2014/main" id="{6A36691B-E209-521E-B6C0-3C69C38919D5}"/>
+                </a:ext>
+              </a:extLst>
+            </p:cNvPr>
+            <p:cNvPicPr>
+              <a:picLocks noChangeAspect="1"/>
+            </p:cNvPicPr>
+            <p:nvPr/>
+          </p:nvPicPr>
+          <p:blipFill>
+            <a:blip r:embed="rId3"/>
+            <a:srcRect l="10392" t="79073" r="57408" b="8050"/>
+            <a:stretch>
+              <a:fillRect/>
+            </a:stretch>
+          </p:blipFill>
+          <p:spPr>
+            <a:xfrm rot="21278377">
+              <a:off x="6083109" y="4170560"/>
+              <a:ext cx="1564077" cy="511727"/>
+            </a:xfrm>
+            <a:prstGeom prst="rect">
+              <a:avLst/>
+            </a:prstGeom>
+          </p:spPr>
+        </p:pic>
+        <p:sp>
+          <p:nvSpPr>
+            <p:cNvPr id="93" name="타원 92">
+              <a:extLst>
+                <a:ext uri="{FF2B5EF4-FFF2-40B4-BE49-F238E27FC236}">
+                  <a16:creationId xmlns:a16="http://schemas.microsoft.com/office/drawing/2014/main" id="{92A48802-DD01-7AE6-9430-16B841BB47A0}"/>
+                </a:ext>
+              </a:extLst>
+            </p:cNvPr>
+            <p:cNvSpPr/>
+            <p:nvPr/>
+          </p:nvSpPr>
+          <p:spPr>
+            <a:xfrm flipH="1">
+              <a:off x="7573423" y="4308006"/>
+              <a:ext cx="74373" cy="74373"/>
+            </a:xfrm>
+            <a:prstGeom prst="ellipse">
+              <a:avLst/>
+            </a:prstGeom>
+            <a:solidFill>
+              <a:schemeClr val="accent5">
+                <a:lumMod val="40000"/>
+                <a:lumOff val="60000"/>
+              </a:schemeClr>
+            </a:solidFill>
+            <a:ln>
+              <a:solidFill>
+                <a:schemeClr val="accent1"/>
+              </a:solidFill>
+            </a:ln>
+          </p:spPr>
+          <p:style>
+            <a:lnRef idx="2">
+              <a:schemeClr val="dk1"/>
+            </a:lnRef>
+            <a:fillRef idx="1">
+              <a:schemeClr val="lt1"/>
+            </a:fillRef>
+            <a:effectRef idx="0">
+              <a:schemeClr val="dk1"/>
+            </a:effectRef>
+            <a:fontRef idx="minor">
+              <a:schemeClr val="dk1"/>
+            </a:fontRef>
+          </p:style>
+          <p:txBody>
+            <a:bodyPr rtlCol="0" anchor="ctr"/>
+            <a:lstStyle/>
+            <a:p>
+              <a:pPr algn="ctr"/>
+              <a:endParaRPr lang="ko-KR" altLang="en-US"/>
+            </a:p>
+          </p:txBody>
+        </p:sp>
+      </p:grpSp>
+      <p:cxnSp>
+        <p:nvCxnSpPr>
+          <p:cNvPr id="97" name="Connector 9">
+            <a:extLst>
+              <a:ext uri="{FF2B5EF4-FFF2-40B4-BE49-F238E27FC236}">
+                <a16:creationId xmlns:a16="http://schemas.microsoft.com/office/drawing/2014/main" id="{832F27A7-6936-79C7-18D3-DB1D55663BA5}"/>
+              </a:ext>
+            </a:extLst>
+          </p:cNvPr>
+          <p:cNvCxnSpPr>
+            <a:cxnSpLocks/>
+          </p:cNvCxnSpPr>
+          <p:nvPr/>
+        </p:nvCxnSpPr>
+        <p:spPr>
+          <a:xfrm>
+            <a:off x="8541219" y="2823858"/>
+            <a:ext cx="1486443" cy="0"/>
+          </a:xfrm>
+          <a:prstGeom prst="line">
+            <a:avLst/>
+          </a:prstGeom>
+          <a:ln w="25400">
+            <a:solidFill>
+              <a:srgbClr val="FF6600"/>
+            </a:solidFill>
+            <a:prstDash val="dash"/>
+          </a:ln>
+          <a:effectLst/>
+        </p:spPr>
+        <p:style>
+          <a:lnRef idx="1">
+            <a:schemeClr val="dk1"/>
+          </a:lnRef>
+          <a:fillRef idx="0">
+            <a:schemeClr val="dk1"/>
+          </a:fillRef>
+          <a:effectRef idx="0">
+            <a:schemeClr val="dk1"/>
+          </a:effectRef>
+          <a:fontRef idx="minor">
+            <a:schemeClr val="tx1"/>
+          </a:fontRef>
+        </p:style>
+      </p:cxnSp>
+      <p:cxnSp>
+        <p:nvCxnSpPr>
+          <p:cNvPr id="103" name="Connector 9">
+            <a:extLst>
+              <a:ext uri="{FF2B5EF4-FFF2-40B4-BE49-F238E27FC236}">
+                <a16:creationId xmlns:a16="http://schemas.microsoft.com/office/drawing/2014/main" id="{83B246D0-688C-3246-D619-F6270D2D884F}"/>
+              </a:ext>
+            </a:extLst>
+          </p:cNvPr>
+          <p:cNvCxnSpPr>
+            <a:cxnSpLocks/>
+          </p:cNvCxnSpPr>
+          <p:nvPr/>
+        </p:nvCxnSpPr>
+        <p:spPr>
+          <a:xfrm>
+            <a:off x="11672989" y="2823858"/>
+            <a:ext cx="300074" cy="0"/>
+          </a:xfrm>
+          <a:prstGeom prst="line">
+            <a:avLst/>
+          </a:prstGeom>
+          <a:ln w="25400">
+            <a:solidFill>
+              <a:srgbClr val="FF6600"/>
+            </a:solidFill>
+            <a:prstDash val="dash"/>
+          </a:ln>
+          <a:effectLst/>
+        </p:spPr>
+        <p:style>
+          <a:lnRef idx="1">
+            <a:schemeClr val="dk1"/>
+          </a:lnRef>
+          <a:fillRef idx="0">
+            <a:schemeClr val="dk1"/>
+          </a:fillRef>
+          <a:effectRef idx="0">
+            <a:schemeClr val="dk1"/>
+          </a:effectRef>
+          <a:fontRef idx="minor">
+            <a:schemeClr val="tx1"/>
+          </a:fontRef>
+        </p:style>
+      </p:cxnSp>
+      <p:sp>
+        <p:nvSpPr>
+          <p:cNvPr id="106" name="Rectangle 8">
+            <a:extLst>
+              <a:ext uri="{FF2B5EF4-FFF2-40B4-BE49-F238E27FC236}">
+                <a16:creationId xmlns:a16="http://schemas.microsoft.com/office/drawing/2014/main" id="{BEDC0A7D-109C-E88D-61FE-6EE7331E15FC}"/>
+              </a:ext>
+            </a:extLst>
+          </p:cNvPr>
+          <p:cNvSpPr/>
+          <p:nvPr/>
+        </p:nvSpPr>
+        <p:spPr>
+          <a:xfrm>
+            <a:off x="8459979" y="2753109"/>
+            <a:ext cx="3513084" cy="64185"/>
+          </a:xfrm>
+          <a:prstGeom prst="rect">
+            <a:avLst/>
+          </a:prstGeom>
+          <a:solidFill>
+            <a:srgbClr val="FBE9DA"/>
+          </a:solidFill>
+          <a:ln>
+            <a:noFill/>
+          </a:ln>
+          <a:effectLst/>
+        </p:spPr>
+        <p:style>
+          <a:lnRef idx="1">
+            <a:schemeClr val="accent1"/>
+          </a:lnRef>
+          <a:fillRef idx="3">
+            <a:schemeClr val="accent1"/>
+          </a:fillRef>
+          <a:effectRef idx="2">
+            <a:schemeClr val="accent1"/>
+          </a:effectRef>
+          <a:fontRef idx="minor">
+            <a:schemeClr val="lt1"/>
+          </a:fontRef>
+        </p:style>
+        <p:txBody>
+          <a:bodyPr rtlCol="0" anchor="ctr"/>
+          <a:lstStyle/>
+          <a:p>
+            <a:pPr algn="ctr"/>
+            <a:endParaRPr/>
+          </a:p>
+        </p:txBody>
+      </p:sp>
+      <mc:AlternateContent xmlns:mc="http://schemas.openxmlformats.org/markup-compatibility/2006">
+        <mc:Choice xmlns:a14="http://schemas.microsoft.com/office/drawing/2010/main" Requires="a14">
+          <p:sp>
+            <p:nvSpPr>
+              <p:cNvPr id="109" name="TextBox 108">
+                <a:extLst>
+                  <a:ext uri="{FF2B5EF4-FFF2-40B4-BE49-F238E27FC236}">
+                    <a16:creationId xmlns:a16="http://schemas.microsoft.com/office/drawing/2014/main" id="{73958027-6BBA-F37E-2862-A8FA9EEB00C1}"/>
+                  </a:ext>
+                </a:extLst>
+              </p:cNvPr>
+              <p:cNvSpPr txBox="1"/>
+              <p:nvPr/>
+            </p:nvSpPr>
+            <p:spPr>
+              <a:xfrm>
+                <a:off x="10201875" y="3075611"/>
+                <a:ext cx="1076162" cy="253916"/>
+              </a:xfrm>
+              <a:prstGeom prst="rect">
+                <a:avLst/>
+              </a:prstGeom>
+              <a:noFill/>
+            </p:spPr>
+            <p:txBody>
+              <a:bodyPr wrap="square">
+                <a:spAutoFit/>
+              </a:bodyPr>
+              <a:lstStyle/>
+              <a:p>
+                <a:r>
+                  <a:rPr lang="en-US" altLang="ko-KR" sz="1050" b="1" i="0" dirty="0">
+                    <a:solidFill>
+                      <a:srgbClr val="3E8E3E"/>
+                    </a:solidFill>
+                    <a:latin typeface="Arial"/>
+                  </a:rPr>
+                  <a:t>Target set  </a:t>
+                </a:r>
+                <a14:m>
+                  <m:oMath xmlns:m="http://schemas.openxmlformats.org/officeDocument/2006/math">
+                    <m:r>
+                      <a:rPr lang="ko-KR" altLang="en-US" sz="1050" b="1" i="1" smtClean="0">
+                        <a:solidFill>
+                          <a:srgbClr val="3E8E3E"/>
+                        </a:solidFill>
+                        <a:latin typeface="Cambria Math" panose="02040503050406030204" pitchFamily="18" charset="0"/>
+                      </a:rPr>
+                      <m:t>𝓣</m:t>
+                    </m:r>
+                  </m:oMath>
+                </a14:m>
+                <a:endParaRPr lang="ko-KR" altLang="en-US" sz="1050" dirty="0"/>
+              </a:p>
+            </p:txBody>
+          </p:sp>
+        </mc:Choice>
+        <mc:Fallback>
+          <p:sp>
+            <p:nvSpPr>
+              <p:cNvPr id="109" name="TextBox 108">
+                <a:extLst>
+                  <a:ext uri="{FF2B5EF4-FFF2-40B4-BE49-F238E27FC236}">
+                    <a16:creationId xmlns:a16="http://schemas.microsoft.com/office/drawing/2014/main" id="{73958027-6BBA-F37E-2862-A8FA9EEB00C1}"/>
+                  </a:ext>
+                </a:extLst>
+              </p:cNvPr>
+              <p:cNvSpPr txBox="1">
+                <a:spLocks noRot="1" noChangeAspect="1" noMove="1" noResize="1" noEditPoints="1" noAdjustHandles="1" noChangeArrowheads="1" noChangeShapeType="1" noTextEdit="1"/>
+              </p:cNvSpPr>
+              <p:nvPr/>
+            </p:nvSpPr>
+            <p:spPr>
+              <a:xfrm>
+                <a:off x="10201875" y="3075611"/>
+                <a:ext cx="1076162" cy="253916"/>
+              </a:xfrm>
+              <a:prstGeom prst="rect">
+                <a:avLst/>
+              </a:prstGeom>
+              <a:blipFill>
+                <a:blip r:embed="rId6"/>
+                <a:stretch>
+                  <a:fillRect b="-14634"/>
+                </a:stretch>
+              </a:blipFill>
+            </p:spPr>
+            <p:txBody>
+              <a:bodyPr/>
+              <a:lstStyle/>
+              <a:p>
+                <a:r>
+                  <a:rPr lang="ko-KR" altLang="en-US">
+                    <a:noFill/>
+                  </a:rPr>
+                  <a:t> </a:t>
+                </a:r>
+              </a:p>
+            </p:txBody>
+          </p:sp>
+        </mc:Fallback>
+      </mc:AlternateContent>
+      <p:sp>
+        <p:nvSpPr>
+          <p:cNvPr id="22" name="TextBox 21">
+            <a:extLst>
+              <a:ext uri="{FF2B5EF4-FFF2-40B4-BE49-F238E27FC236}">
+                <a16:creationId xmlns:a16="http://schemas.microsoft.com/office/drawing/2014/main" id="{0FA29CDA-9A15-2ABF-38AD-D9B27FCE705A}"/>
+              </a:ext>
+            </a:extLst>
+          </p:cNvPr>
+          <p:cNvSpPr txBox="1"/>
+          <p:nvPr/>
+        </p:nvSpPr>
+        <p:spPr>
+          <a:xfrm>
+            <a:off x="9468159" y="3959879"/>
+            <a:ext cx="3503855" cy="169277"/>
+          </a:xfrm>
+          <a:prstGeom prst="rect">
+            <a:avLst/>
+          </a:prstGeom>
+          <a:noFill/>
+        </p:spPr>
+        <p:txBody>
+          <a:bodyPr wrap="square" lIns="0" tIns="0" rIns="0" bIns="0" anchor="ctr">
+            <a:spAutoFit/>
+          </a:bodyPr>
+          <a:lstStyle/>
+          <a:p>
+            <a:pPr algn="ctr"/>
+            <a:r>
+              <a:rPr lang="en-US" sz="1100" b="1" i="0" dirty="0">
                 <a:solidFill>
                   <a:srgbClr val="304055"/>
                 </a:solidFill>
                 <a:latin typeface="Arial"/>
-              </a:endParaRPr>
-            </a:p>
-          </p:txBody>
-        </p:sp>
-      </p:grpSp>
+              </a:rPr>
+              <a:t>Target and collision sets</a:t>
+            </a:r>
+            <a:endParaRPr sz="1100" b="1" i="0" dirty="0">
+              <a:solidFill>
+                <a:srgbClr val="304055"/>
+              </a:solidFill>
+              <a:latin typeface="Arial"/>
+            </a:endParaRPr>
+          </a:p>
+        </p:txBody>
+      </p:sp>
+      <p:pic>
+        <p:nvPicPr>
+          <p:cNvPr id="12" name="그림 11">
+            <a:extLst>
+              <a:ext uri="{FF2B5EF4-FFF2-40B4-BE49-F238E27FC236}">
+                <a16:creationId xmlns:a16="http://schemas.microsoft.com/office/drawing/2014/main" id="{24ED876A-66B5-83AA-D40A-8D4A406CCF89}"/>
+              </a:ext>
+            </a:extLst>
+          </p:cNvPr>
+          <p:cNvPicPr>
+            <a:picLocks noChangeAspect="1"/>
+          </p:cNvPicPr>
+          <p:nvPr/>
+        </p:nvPicPr>
+        <p:blipFill>
+          <a:blip r:embed="rId7"/>
+          <a:srcRect l="8821" t="1516" r="3964" b="66897"/>
+          <a:stretch>
+            <a:fillRect/>
+          </a:stretch>
+        </p:blipFill>
+        <p:spPr>
+          <a:xfrm>
+            <a:off x="4603343" y="220723"/>
+            <a:ext cx="5962458" cy="1439600"/>
+          </a:xfrm>
+          <a:prstGeom prst="rect">
+            <a:avLst/>
+          </a:prstGeom>
+        </p:spPr>
+      </p:pic>
+      <p:pic>
+        <p:nvPicPr>
+          <p:cNvPr id="35" name="그림 34">
+            <a:extLst>
+              <a:ext uri="{FF2B5EF4-FFF2-40B4-BE49-F238E27FC236}">
+                <a16:creationId xmlns:a16="http://schemas.microsoft.com/office/drawing/2014/main" id="{9BEDA343-17A0-9E06-99F7-9AE494BCFE8F}"/>
+              </a:ext>
+            </a:extLst>
+          </p:cNvPr>
+          <p:cNvPicPr>
+            <a:picLocks noChangeAspect="1"/>
+          </p:cNvPicPr>
+          <p:nvPr/>
+        </p:nvPicPr>
+        <p:blipFill>
+          <a:blip r:embed="rId7"/>
+          <a:srcRect l="12562" t="25205" r="31139" b="66897"/>
+          <a:stretch>
+            <a:fillRect/>
+          </a:stretch>
+        </p:blipFill>
+        <p:spPr>
+          <a:xfrm>
+            <a:off x="8292057" y="2447992"/>
+            <a:ext cx="3848926" cy="359970"/>
+          </a:xfrm>
+          <a:custGeom>
+            <a:avLst/>
+            <a:gdLst>
+              <a:gd name="csX0" fmla="*/ 241560 w 3848926"/>
+              <a:gd name="csY0" fmla="*/ 0 h 359970"/>
+              <a:gd name="csX1" fmla="*/ 3607366 w 3848926"/>
+              <a:gd name="csY1" fmla="*/ 0 h 359970"/>
+              <a:gd name="csX2" fmla="*/ 3848926 w 3848926"/>
+              <a:gd name="csY2" fmla="*/ 241560 h 359970"/>
+              <a:gd name="csX3" fmla="*/ 3848926 w 3848926"/>
+              <a:gd name="csY3" fmla="*/ 359970 h 359970"/>
+              <a:gd name="csX4" fmla="*/ 0 w 3848926"/>
+              <a:gd name="csY4" fmla="*/ 359970 h 359970"/>
+              <a:gd name="csX5" fmla="*/ 0 w 3848926"/>
+              <a:gd name="csY5" fmla="*/ 241560 h 359970"/>
+              <a:gd name="csX6" fmla="*/ 241560 w 3848926"/>
+              <a:gd name="csY6" fmla="*/ 0 h 359970"/>
+            </a:gdLst>
+            <a:ahLst/>
+            <a:cxnLst>
+              <a:cxn ang="0">
+                <a:pos x="csX0" y="csY0"/>
+              </a:cxn>
+              <a:cxn ang="0">
+                <a:pos x="csX1" y="csY1"/>
+              </a:cxn>
+              <a:cxn ang="0">
+                <a:pos x="csX2" y="csY2"/>
+              </a:cxn>
+              <a:cxn ang="0">
+                <a:pos x="csX3" y="csY3"/>
+              </a:cxn>
+              <a:cxn ang="0">
+                <a:pos x="csX4" y="csY4"/>
+              </a:cxn>
+              <a:cxn ang="0">
+                <a:pos x="csX5" y="csY5"/>
+              </a:cxn>
+              <a:cxn ang="0">
+                <a:pos x="csX6" y="csY6"/>
+              </a:cxn>
+            </a:cxnLst>
+            <a:rect l="l" t="t" r="r" b="b"/>
+            <a:pathLst>
+              <a:path w="3848926" h="359970">
+                <a:moveTo>
+                  <a:pt x="241560" y="0"/>
+                </a:moveTo>
+                <a:lnTo>
+                  <a:pt x="3607366" y="0"/>
+                </a:lnTo>
+                <a:cubicBezTo>
+                  <a:pt x="3740776" y="0"/>
+                  <a:pt x="3848926" y="108150"/>
+                  <a:pt x="3848926" y="241560"/>
+                </a:cubicBezTo>
+                <a:lnTo>
+                  <a:pt x="3848926" y="359970"/>
+                </a:lnTo>
+                <a:lnTo>
+                  <a:pt x="0" y="359970"/>
+                </a:lnTo>
+                <a:lnTo>
+                  <a:pt x="0" y="241560"/>
+                </a:lnTo>
+                <a:cubicBezTo>
+                  <a:pt x="0" y="108150"/>
+                  <a:pt x="108150" y="0"/>
+                  <a:pt x="241560" y="0"/>
+                </a:cubicBezTo>
+                <a:close/>
+              </a:path>
+            </a:pathLst>
+          </a:custGeom>
+        </p:spPr>
+      </p:pic>
+      <p:sp>
+        <p:nvSpPr>
+          <p:cNvPr id="29" name="사각형: 둥근 모서리 28">
+            <a:extLst>
+              <a:ext uri="{FF2B5EF4-FFF2-40B4-BE49-F238E27FC236}">
+                <a16:creationId xmlns:a16="http://schemas.microsoft.com/office/drawing/2014/main" id="{F57FBD1B-F054-B6B3-3C68-371F965982A8}"/>
+              </a:ext>
+            </a:extLst>
+          </p:cNvPr>
+          <p:cNvSpPr/>
+          <p:nvPr/>
+        </p:nvSpPr>
+        <p:spPr>
+          <a:xfrm>
+            <a:off x="8285832" y="2439707"/>
+            <a:ext cx="3848926" cy="1449329"/>
+          </a:xfrm>
+          <a:prstGeom prst="roundRect">
+            <a:avLst/>
+          </a:prstGeom>
+          <a:noFill/>
+          <a:ln w="19050">
+            <a:solidFill>
+              <a:schemeClr val="tx1"/>
+            </a:solidFill>
+            <a:prstDash val="dash"/>
+          </a:ln>
+          <a:effectLst/>
+        </p:spPr>
+        <p:style>
+          <a:lnRef idx="1">
+            <a:schemeClr val="accent1"/>
+          </a:lnRef>
+          <a:fillRef idx="3">
+            <a:schemeClr val="accent1"/>
+          </a:fillRef>
+          <a:effectRef idx="2">
+            <a:schemeClr val="accent1"/>
+          </a:effectRef>
+          <a:fontRef idx="minor">
+            <a:schemeClr val="lt1"/>
+          </a:fontRef>
+        </p:style>
+        <p:txBody>
+          <a:bodyPr rtlCol="0" anchor="ctr"/>
+          <a:lstStyle/>
+          <a:p>
+            <a:pPr algn="ctr"/>
+            <a:endParaRPr lang="ko-KR" altLang="en-US"/>
+          </a:p>
+        </p:txBody>
+      </p:sp>
     </p:spTree>
     <p:extLst>
       <p:ext uri="{BB962C8B-B14F-4D97-AF65-F5344CB8AC3E}">
-        <p14:creationId xmlns:p14="http://schemas.microsoft.com/office/powerpoint/2010/main" val="3592759201"/>
+        <p14:creationId xmlns:p14="http://schemas.microsoft.com/office/powerpoint/2010/main" val="4004035925"/>
       </p:ext>
     </p:extLst>
   </p:cSld>

</xml_diff>